<commit_message>
Thread A4 page/drawer metaphor into workshop decks
W1: Add A4 paper slide after rules exercise (do → understand),
replace Skills intro with "drawer" hero, replace GPS with
"the page stays clean", reorder for do→understand→do→land→prove.
W2: Update speaker notes with page/drawer callbacks.

Co-Authored-By: Claude Opus 4.6 <noreply@anthropic.com>
</commit_message>
<xml_diff>
--- a/decks/workshop-1-strategist/workshop-1-strategist.pptx
+++ b/decks/workshop-1-strategist/workshop-1-strategist.pptx
@@ -34,9 +34,10 @@
     <p:sldId id="282" r:id="rId28"/>
     <p:sldId id="283" r:id="rId29"/>
     <p:sldId id="284" r:id="rId30"/>
+    <p:sldId id="285" r:id="rId31"/>
   </p:sldIdLst>
   <p:notesMasterIdLst>
-    <p:notesMasterId r:id="rId31"/>
+    <p:notesMasterId r:id="rId32"/>
   </p:notesMasterIdLst>
   <p:sldSz cx="9144000" cy="5143500"/>
   <p:notesSz cx="5143500" cy="9144000"/>
@@ -1938,7 +1939,7 @@
           <a:p>
             <a:r>
               <a:rPr lang="en-US" dirty="0"/>
-              <a:t>Navigate to Customize → Skills. Show the built-in Anthropic Skills: presentations, documents, spreadsheets. "These are reusable workflows. Turn one on and Claude gains a new capability." Briefly mention the Skills Directory for the curious. Keep it quick — the exercise is what matters.</a:t>
+              <a:t>"You just wrote your rules. Here's what that actually looks like." One piece of A4 paper. That's it. Everything she knows right now — your rules, your request, the conversation — fits on this one page. Your rules go on this page. They're always there, grounding every conversation. That's powerful. But the page is small — you need to be selective about what earns a permanent spot. "So what happens to all those brilliant workflows that don't fit on the page?"</a:t>
             </a:r>
             <a:endParaRPr lang="en-US" dirty="0"/>
           </a:p>
@@ -2026,7 +2027,7 @@
           <a:p>
             <a:r>
               <a:rPr lang="en-US" dirty="0"/>
-              <a:t>Have them enable the presentation Skill in Customize → Skills, then use it. The aha: they typed one bare sentence and got output that knows who they are (rules) AND how to build a proper presentation (Skill). "Rules + Skills = a colleague who never forgets who you are or how you work."</a:t>
+              <a:t>Skills. Instructions kept in a drawer, pulled onto the page only when the task needs them. They don't take up memory between tasks. She pulls one out, uses it, puts it back. The page stays clean. Rule example (always on the page): 'All presentations use billboard design.' Skill example (from the drawer): 'How to write a project proposal' — step-by-step workflow loaded when you ask for a proposal, back in the drawer when you don't. Navigate to Customize → Skills. Show the built-in Anthropic Skills: presentations, documents, spreadsheets.</a:t>
             </a:r>
             <a:endParaRPr lang="en-US" dirty="0"/>
           </a:p>
@@ -2114,7 +2115,7 @@
           <a:p>
             <a:r>
               <a:rPr lang="en-US" dirty="0"/>
-              <a:t>Second emotional peak — bigger than the first. The three-way comparison shows the full journey. If time is tight, this can be a facilitator demo. Point out: column 1 to 2 was five techniques. Column 2 to 3 was rules + Skills. The second jump required zero effort per conversation.</a:t>
+              <a:t>Have them enable the presentation Skill in Customize → Skills, then use it. The aha: they typed one bare sentence and got output that knows who they are (rules on the page) AND how to build a proper presentation (Skill pulled from the drawer). "The page told her who you are. The drawer told her how to work."</a:t>
             </a:r>
             <a:endParaRPr lang="en-US" dirty="0"/>
           </a:p>
@@ -2202,7 +2203,7 @@
           <a:p>
             <a:r>
               <a:rPr lang="en-US" dirty="0"/>
-              <a:t>GPS metaphor cements the concept. Prompt engineering = giving directions every trip. Rules + Skills = a GPS that remembers your preferences AND knows every road. "Personal preferences, custom Skills, org Skills — all compound. All stack."</a:t>
+              <a:t>The landing line. Rules earn a permanent spot on the page — only the essentials. Everything else lives in the drawer as Skills, pulled out when relevant. This is the distinction that separates someone who 'uses AI' from someone who has built a system. The page doesn't fill up because Skills come and go. "Personal preferences = the page. Skills = the drawer. Both compound. Both stack."</a:t>
             </a:r>
             <a:endParaRPr lang="en-US" dirty="0"/>
           </a:p>
@@ -2290,7 +2291,7 @@
           <a:p>
             <a:r>
               <a:rPr lang="en-US" dirty="0"/>
-              <a:t>Brief graduation moment. "You don't just talk to AI well — you've set up its playbook." But keep it short — this is the halfway point, not the finish line.</a:t>
+              <a:t>Second emotional peak — bigger than the first. The three-way comparison shows the full journey. If time is tight, this can be a facilitator demo. Point out: column 1 to 2 was five techniques. Column 2 to 3 was rules + Skills. The second jump required zero effort per conversation.</a:t>
             </a:r>
             <a:endParaRPr lang="en-US" dirty="0"/>
           </a:p>
@@ -2378,7 +2379,7 @@
           <a:p>
             <a:r>
               <a:rPr lang="en-US" dirty="0"/>
-              <a:t>The cliffhanger. "You search, you paste, you copy, you apply. Every step has 'you' in it." This should sting — they just felt the power of rules + Skills, but they're still the bottleneck. "Next time: Strategist → Orchestrator. We hand the AI the keys — and build it a team." Plant the seed: "Rules tell Claude who you are. Skills tell Claude how to work. Next time, each step in a chain gets its own specialized Skill — a whole team." Remind: save your prompt, preferences, and enabled Skills — they carry forward.</a:t>
+              <a:t>Brief graduation moment. "You don't just talk to AI well — you've set up its playbook." But keep it short — this is the halfway point, not the finish line.</a:t>
             </a:r>
             <a:endParaRPr lang="en-US" dirty="0"/>
           </a:p>
@@ -2490,6 +2491,94 @@
             <a:fld id="{F7021451-1387-4CA6-816F-3879F97B5CBC}" type="slidenum">
               <a:rPr lang="en-US"/>
               <a:t>3</a:t>
+            </a:fld>
+            <a:endParaRPr lang="en-US"/>
+          </a:p>
+        </p:txBody>
+      </p:sp>
+    </p:spTree>
+    <p:extLst>
+      <p:ext uri="{BB962C8B-B14F-4D97-AF65-F5344CB8AC3E}">
+        <p14:creationId xmlns:p14="http://schemas.microsoft.com/office/powerpoint/2010/main" val="1024086991"/>
+      </p:ext>
+    </p:extLst>
+  </p:cSld>
+  <p:clrMapOvr>
+    <a:masterClrMapping/>
+  </p:clrMapOvr>
+</p:notes>
+</file>
+
+<file path=ppt/notesSlides/notesSlide30.xml><?xml version="1.0" encoding="utf-8"?>
+<p:notes xmlns:a="http://schemas.openxmlformats.org/drawingml/2006/main" xmlns:r="http://schemas.openxmlformats.org/officeDocument/2006/relationships" xmlns:p="http://schemas.openxmlformats.org/presentationml/2006/main">
+  <p:cSld>
+    <p:spTree>
+      <p:nvGrpSpPr>
+        <p:cNvPr id="1" name=""/>
+        <p:cNvGrpSpPr/>
+        <p:nvPr/>
+      </p:nvGrpSpPr>
+      <p:grpSpPr>
+        <a:xfrm>
+          <a:off x="0" y="0"/>
+          <a:ext cx="0" cy="0"/>
+          <a:chOff x="0" y="0"/>
+          <a:chExt cx="0" cy="0"/>
+        </a:xfrm>
+      </p:grpSpPr>
+      <p:sp>
+        <p:nvSpPr>
+          <p:cNvPr id="2" name="Slide Image Placeholder 1"/>
+          <p:cNvSpPr>
+            <a:spLocks noGrp="1" noRot="1" noChangeAspect="1"/>
+          </p:cNvSpPr>
+          <p:nvPr>
+            <p:ph type="sldImg"/>
+          </p:nvPr>
+        </p:nvSpPr>
+        <p:spPr/>
+      </p:sp>
+      <p:sp>
+        <p:nvSpPr>
+          <p:cNvPr id="3" name="Notes Placeholder 2"/>
+          <p:cNvSpPr>
+            <a:spLocks noGrp="1"/>
+          </p:cNvSpPr>
+          <p:nvPr>
+            <p:ph type="body" idx="1"/>
+          </p:nvPr>
+        </p:nvSpPr>
+        <p:spPr/>
+        <p:txBody>
+          <a:bodyPr/>
+          <a:lstStyle/>
+          <a:p>
+            <a:r>
+              <a:rPr lang="en-US" dirty="0"/>
+              <a:t>The cliffhanger. "You search, you paste, you copy, you apply. Every step has 'you' in it." This should sting — they just felt the power of rules + Skills, but they're still the bottleneck. "Next time: Strategist → Orchestrator. We hand the AI the keys — and build it a team." Plant the seed: "Rules tell Claude who you are. Skills tell Claude how to work. Next time, each step in a chain gets its own specialized Skill — a whole team." Remind: save your prompt, preferences, and enabled Skills — they carry forward.</a:t>
+            </a:r>
+            <a:endParaRPr lang="en-US" dirty="0"/>
+          </a:p>
+        </p:txBody>
+      </p:sp>
+      <p:sp>
+        <p:nvSpPr>
+          <p:cNvPr id="4" name="Slide Number Placeholder 3"/>
+          <p:cNvSpPr>
+            <a:spLocks noGrp="1"/>
+          </p:cNvSpPr>
+          <p:nvPr>
+            <p:ph type="sldNum" sz="quarter" idx="10"/>
+          </p:nvPr>
+        </p:nvSpPr>
+        <p:spPr/>
+        <p:txBody>
+          <a:bodyPr/>
+          <a:lstStyle/>
+          <a:p>
+            <a:fld id="{F7021451-1387-4CA6-816F-3879F97B5CBC}" type="slidenum">
+              <a:rPr lang="en-US"/>
+              <a:t>30</a:t>
             </a:fld>
             <a:endParaRPr lang="en-US"/>
           </a:p>
@@ -6847,14 +6936,41 @@
       </p:sp>
       <p:sp>
         <p:nvSpPr>
-          <p:cNvPr id="3" name="Text 1"/>
-          <p:cNvSpPr/>
-          <p:nvPr/>
-        </p:nvSpPr>
-        <p:spPr>
-          <a:xfrm>
-            <a:off x="914400" y="914400"/>
-            <a:ext cx="7315200" cy="3291840"/>
+          <p:cNvPr id="3" name="Shape 1"/>
+          <p:cNvSpPr/>
+          <p:nvPr/>
+        </p:nvSpPr>
+        <p:spPr>
+          <a:xfrm>
+            <a:off x="1097280" y="457200"/>
+            <a:ext cx="2926080" cy="4114800"/>
+          </a:xfrm>
+          <a:prstGeom prst="rect">
+            <a:avLst/>
+          </a:prstGeom>
+          <a:solidFill>
+            <a:srgbClr val="F8F8F8"/>
+          </a:solidFill>
+          <a:ln/>
+          <a:effectLst>
+            <a:outerShdw sx="100000" sy="100000" kx="0" ky="0" algn="bl" rotWithShape="0" blurRad="127000" dist="50800" dir="16200000">
+              <a:srgbClr val="000000">
+                <a:alpha val="30000"/>
+              </a:srgbClr>
+            </a:outerShdw>
+          </a:effectLst>
+        </p:spPr>
+      </p:sp>
+      <p:sp>
+        <p:nvSpPr>
+          <p:cNvPr id="4" name="Text 2"/>
+          <p:cNvSpPr/>
+          <p:nvPr/>
+        </p:nvSpPr>
+        <p:spPr>
+          <a:xfrm>
+            <a:off x="1371600" y="731520"/>
+            <a:ext cx="2377440" cy="3474720"/>
           </a:xfrm>
           <a:prstGeom prst="rect">
             <a:avLst/>
@@ -6863,61 +6979,163 @@
           <a:ln/>
         </p:spPr>
         <p:txBody>
+          <a:bodyPr wrap="square" lIns="0" tIns="0" rIns="0" bIns="0" rtlCol="0" anchor="t"/>
+          <a:lstStyle/>
+          <a:p>
+            <a:pPr indent="0" marL="0">
+              <a:buNone/>
+            </a:pPr>
+            <a:r>
+              <a:rPr lang="en-US" sz="1600" dirty="0">
+                <a:solidFill>
+                  <a:srgbClr val="1A1F36"/>
+                </a:solidFill>
+                <a:latin typeface="Verdana" pitchFamily="34" charset="0"/>
+                <a:ea typeface="Verdana" pitchFamily="34" charset="-122"/>
+                <a:cs typeface="Verdana" pitchFamily="34" charset="-120"/>
+              </a:rPr>
+              <a:t>Rules</a:t>
+            </a:r>
+            <a:endParaRPr lang="en-US" sz="1600" dirty="0"/>
+          </a:p>
+          <a:p>
+            <a:pPr indent="0" marL="0">
+              <a:buNone/>
+            </a:pPr>
+            <a:endParaRPr lang="en-US" sz="1600" dirty="0"/>
+          </a:p>
+          <a:p>
+            <a:pPr indent="0" marL="0">
+              <a:buNone/>
+            </a:pPr>
+            <a:r>
+              <a:rPr lang="en-US" sz="1600" dirty="0">
+                <a:solidFill>
+                  <a:srgbClr val="1A1F36"/>
+                </a:solidFill>
+                <a:latin typeface="Verdana" pitchFamily="34" charset="0"/>
+                <a:ea typeface="Verdana" pitchFamily="34" charset="-122"/>
+                <a:cs typeface="Verdana" pitchFamily="34" charset="-120"/>
+              </a:rPr>
+              <a:t>• Billboard design</a:t>
+            </a:r>
+            <a:endParaRPr lang="en-US" sz="1600" dirty="0"/>
+          </a:p>
+          <a:p>
+            <a:pPr indent="0" marL="0">
+              <a:buNone/>
+            </a:pPr>
+            <a:r>
+              <a:rPr lang="en-US" sz="1600" dirty="0">
+                <a:solidFill>
+                  <a:srgbClr val="1A1F36"/>
+                </a:solidFill>
+                <a:latin typeface="Verdana" pitchFamily="34" charset="0"/>
+                <a:ea typeface="Verdana" pitchFamily="34" charset="-122"/>
+                <a:cs typeface="Verdana" pitchFamily="34" charset="-120"/>
+              </a:rPr>
+              <a:t>• British English</a:t>
+            </a:r>
+            <a:endParaRPr lang="en-US" sz="1600" dirty="0"/>
+          </a:p>
+          <a:p>
+            <a:pPr indent="0" marL="0">
+              <a:buNone/>
+            </a:pPr>
+            <a:r>
+              <a:rPr lang="en-US" sz="1600" dirty="0">
+                <a:solidFill>
+                  <a:srgbClr val="1A1F36"/>
+                </a:solidFill>
+                <a:latin typeface="Verdana" pitchFamily="34" charset="0"/>
+                <a:ea typeface="Verdana" pitchFamily="34" charset="-122"/>
+                <a:cs typeface="Verdana" pitchFamily="34" charset="-120"/>
+              </a:rPr>
+              <a:t>• Be concise</a:t>
+            </a:r>
+            <a:endParaRPr lang="en-US" sz="1600" dirty="0"/>
+          </a:p>
+          <a:p>
+            <a:pPr indent="0" marL="0">
+              <a:buNone/>
+            </a:pPr>
+            <a:r>
+              <a:rPr lang="en-US" sz="1600" dirty="0">
+                <a:solidFill>
+                  <a:srgbClr val="1A1F36"/>
+                </a:solidFill>
+                <a:latin typeface="Verdana" pitchFamily="34" charset="0"/>
+                <a:ea typeface="Verdana" pitchFamily="34" charset="-122"/>
+                <a:cs typeface="Verdana" pitchFamily="34" charset="-120"/>
+              </a:rPr>
+              <a:t>• No jargon</a:t>
+            </a:r>
+            <a:endParaRPr lang="en-US" sz="1600" dirty="0"/>
+          </a:p>
+        </p:txBody>
+      </p:sp>
+      <p:sp>
+        <p:nvSpPr>
+          <p:cNvPr id="5" name="Text 3"/>
+          <p:cNvSpPr/>
+          <p:nvPr/>
+        </p:nvSpPr>
+        <p:spPr>
+          <a:xfrm>
+            <a:off x="4754880" y="731520"/>
+            <a:ext cx="3840480" cy="1828800"/>
+          </a:xfrm>
+          <a:prstGeom prst="rect">
+            <a:avLst/>
+          </a:prstGeom>
+          <a:noFill/>
+          <a:ln/>
+        </p:spPr>
+        <p:txBody>
           <a:bodyPr wrap="square" lIns="0" tIns="0" rIns="0" bIns="0" rtlCol="0" anchor="ctr"/>
           <a:lstStyle/>
           <a:p>
-            <a:pPr algn="ctr" indent="0" marL="0">
-              <a:buNone/>
-            </a:pPr>
-            <a:r>
-              <a:rPr lang="en-US" sz="2800" b="1" dirty="0">
-                <a:solidFill>
-                  <a:srgbClr val="635BFF"/>
+            <a:pPr indent="0" marL="0">
+              <a:buNone/>
+            </a:pPr>
+            <a:r>
+              <a:rPr lang="en-US" sz="4800" b="1" dirty="0">
+                <a:solidFill>
+                  <a:srgbClr val="FFFFFF"/>
                 </a:solidFill>
                 <a:latin typeface="Georgia" pitchFamily="34" charset="0"/>
                 <a:ea typeface="Georgia" pitchFamily="34" charset="-122"/>
                 <a:cs typeface="Georgia" pitchFamily="34" charset="-120"/>
               </a:rPr>
-              <a:t>Rules tell Claude who you are</a:t>
-            </a:r>
-            <a:endParaRPr lang="en-US" sz="2800" dirty="0"/>
-          </a:p>
-          <a:p>
-            <a:pPr algn="ctr" indent="0" marL="0">
-              <a:buNone/>
-            </a:pPr>
-            <a:r>
-              <a:rPr lang="en-US" sz="3600" b="1" dirty="0">
-                <a:solidFill>
-                  <a:srgbClr val="635BFF"/>
-                </a:solidFill>
-                <a:latin typeface="Georgia" pitchFamily="34" charset="0"/>
-                <a:ea typeface="Georgia" pitchFamily="34" charset="-122"/>
-                <a:cs typeface="Georgia" pitchFamily="34" charset="-120"/>
-              </a:rPr>
-              <a:t>Skills tell Claude how to do things</a:t>
-            </a:r>
-            <a:endParaRPr lang="en-US" sz="2800" dirty="0"/>
-          </a:p>
-          <a:p>
-            <a:pPr algn="ctr" indent="0" marL="0">
-              <a:buNone/>
-            </a:pPr>
-            <a:r>
-              <a:rPr lang="en-US" sz="2200" i="1" dirty="0">
-                <a:solidFill>
-                  <a:srgbClr val="8B95A5"/>
-                </a:solidFill>
-                <a:latin typeface="Verdana" pitchFamily="34" charset="0"/>
-                <a:ea typeface="Verdana" pitchFamily="34" charset="-122"/>
-                <a:cs typeface="Verdana" pitchFamily="34" charset="-120"/>
-              </a:rPr>
-              <a:t>Customize → Skills</a:t>
-            </a:r>
-            <a:endParaRPr lang="en-US" sz="2800" dirty="0"/>
-          </a:p>
-        </p:txBody>
-      </p:sp>
+              <a:t>Her entire memory.</a:t>
+            </a:r>
+            <a:endParaRPr lang="en-US" sz="4800" dirty="0"/>
+          </a:p>
+        </p:txBody>
+      </p:sp>
+      <p:pic>
+        <p:nvPicPr>
+          <p:cNvPr id="6" name="Image 0" descr="/Users/michaelengland/Developer/michaelengland/ai-best-practices/decks/ai-best-practices/assets/blue-tang-transparent.png">    </p:cNvPr>
+          <p:cNvPicPr>
+            <a:picLocks noChangeAspect="1"/>
+          </p:cNvPicPr>
+          <p:nvPr/>
+        </p:nvPicPr>
+        <p:blipFill>
+          <a:blip r:embed="rId1"/>
+          <a:srcRect l="0" r="0" t="0" b="0"/>
+          <a:stretch/>
+        </p:blipFill>
+        <p:spPr>
+          <a:xfrm>
+            <a:off x="6583680" y="2743200"/>
+            <a:ext cx="2011680" cy="2011680"/>
+          </a:xfrm>
+          <a:prstGeom prst="rect">
+            <a:avLst/>
+          </a:prstGeom>
+        </p:spPr>
+      </p:pic>
     </p:spTree>
   </p:cSld>
   <p:clrMapOvr>
@@ -6980,8 +7198,8 @@
         </p:nvSpPr>
         <p:spPr>
           <a:xfrm>
-            <a:off x="914400" y="914400"/>
-            <a:ext cx="7315200" cy="3291840"/>
+            <a:off x="914400" y="1097280"/>
+            <a:ext cx="7315200" cy="2560320"/>
           </a:xfrm>
           <a:prstGeom prst="rect">
             <a:avLst/>
@@ -6997,17 +7215,17 @@
               <a:buNone/>
             </a:pPr>
             <a:r>
-              <a:rPr lang="en-US" sz="2800" b="1" dirty="0">
-                <a:solidFill>
-                  <a:srgbClr val="635BFF"/>
+              <a:rPr lang="en-US" sz="3600" b="1" dirty="0">
+                <a:solidFill>
+                  <a:srgbClr val="FFFFFF"/>
                 </a:solidFill>
                 <a:latin typeface="Georgia" pitchFamily="34" charset="0"/>
                 <a:ea typeface="Georgia" pitchFamily="34" charset="-122"/>
                 <a:cs typeface="Georgia" pitchFamily="34" charset="-120"/>
               </a:rPr>
-              <a:t>Enable the Presentation skill</a:t>
-            </a:r>
-            <a:endParaRPr lang="en-US" sz="2800" dirty="0"/>
+              <a:t>Skills live in the drawer.</a:t>
+            </a:r>
+            <a:endParaRPr lang="en-US" sz="3600" dirty="0"/>
           </a:p>
           <a:p>
             <a:pPr algn="ctr" indent="0" marL="0">
@@ -7016,15 +7234,15 @@
             <a:r>
               <a:rPr lang="en-US" sz="3600" b="1" dirty="0">
                 <a:solidFill>
-                  <a:srgbClr val="635BFF"/>
+                  <a:srgbClr val="FFFFFF"/>
                 </a:solidFill>
                 <a:latin typeface="Georgia" pitchFamily="34" charset="0"/>
                 <a:ea typeface="Georgia" pitchFamily="34" charset="-122"/>
                 <a:cs typeface="Georgia" pitchFamily="34" charset="-120"/>
               </a:rPr>
-              <a:t>Then type: "Make me a presentation</a:t>
-            </a:r>
-            <a:endParaRPr lang="en-US" sz="2800" dirty="0"/>
+              <a:t>Pulled onto the page</a:t>
+            </a:r>
+            <a:endParaRPr lang="en-US" sz="3600" dirty="0"/>
           </a:p>
           <a:p>
             <a:pPr algn="ctr" indent="0" marL="0">
@@ -7033,32 +7251,32 @@
             <a:r>
               <a:rPr lang="en-US" sz="3600" b="1" dirty="0">
                 <a:solidFill>
-                  <a:srgbClr val="635BFF"/>
+                  <a:srgbClr val="FFFFFF"/>
                 </a:solidFill>
                 <a:latin typeface="Georgia" pitchFamily="34" charset="0"/>
                 <a:ea typeface="Georgia" pitchFamily="34" charset="-122"/>
                 <a:cs typeface="Georgia" pitchFamily="34" charset="-120"/>
               </a:rPr>
-              <a:t>about making a cup of tea"</a:t>
-            </a:r>
-            <a:endParaRPr lang="en-US" sz="2800" dirty="0"/>
+              <a:t>when needed.</a:t>
+            </a:r>
+            <a:endParaRPr lang="en-US" sz="3600" dirty="0"/>
           </a:p>
           <a:p>
             <a:pPr algn="ctr" indent="0" marL="0">
               <a:buNone/>
             </a:pPr>
             <a:r>
-              <a:rPr lang="en-US" sz="2200" i="1" dirty="0">
-                <a:solidFill>
-                  <a:srgbClr val="8B95A5"/>
-                </a:solidFill>
-                <a:latin typeface="Verdana" pitchFamily="34" charset="0"/>
-                <a:ea typeface="Verdana" pitchFamily="34" charset="-122"/>
-                <a:cs typeface="Verdana" pitchFamily="34" charset="-120"/>
-              </a:rPr>
-              <a:t>One sentence. It already knows the rest.</a:t>
-            </a:r>
-            <a:endParaRPr lang="en-US" sz="2800" dirty="0"/>
+              <a:rPr lang="en-US" sz="3600" b="1" dirty="0">
+                <a:solidFill>
+                  <a:srgbClr val="FFFFFF"/>
+                </a:solidFill>
+                <a:latin typeface="Georgia" pitchFamily="34" charset="0"/>
+                <a:ea typeface="Georgia" pitchFamily="34" charset="-122"/>
+                <a:cs typeface="Georgia" pitchFamily="34" charset="-120"/>
+              </a:rPr>
+              <a:t>Gone when done.</a:t>
+            </a:r>
+            <a:endParaRPr lang="en-US" sz="3600" dirty="0"/>
           </a:p>
         </p:txBody>
       </p:sp>
@@ -7073,6 +7291,260 @@
 <file path=ppt/slides/slide26.xml><?xml version="1.0" encoding="utf-8"?>
 <p:sld xmlns:a="http://schemas.openxmlformats.org/drawingml/2006/main" xmlns:r="http://schemas.openxmlformats.org/officeDocument/2006/relationships" xmlns:p="http://schemas.openxmlformats.org/presentationml/2006/main">
   <p:cSld name="Slide 26">
+    <p:bg>
+      <p:bgPr>
+        <a:solidFill>
+          <a:srgbClr val="0A2540"/>
+        </a:solidFill>
+      </p:bgPr>
+    </p:bg>
+    <p:spTree>
+      <p:nvGrpSpPr>
+        <p:cNvPr id="1" name=""/>
+        <p:cNvGrpSpPr/>
+        <p:nvPr/>
+      </p:nvGrpSpPr>
+      <p:grpSpPr>
+        <a:xfrm>
+          <a:off x="0" y="0"/>
+          <a:ext cx="0" cy="0"/>
+          <a:chOff x="0" y="0"/>
+          <a:chExt cx="0" cy="0"/>
+        </a:xfrm>
+      </p:grpSpPr>
+      <p:sp>
+        <p:nvSpPr>
+          <p:cNvPr id="2" name="Shape 0"/>
+          <p:cNvSpPr/>
+          <p:nvPr/>
+        </p:nvSpPr>
+        <p:spPr>
+          <a:xfrm>
+            <a:off x="4572000" y="2286000"/>
+            <a:ext cx="7315200" cy="5486400"/>
+          </a:xfrm>
+          <a:prstGeom prst="ellipse">
+            <a:avLst/>
+          </a:prstGeom>
+          <a:solidFill>
+            <a:srgbClr val="635BFF">
+              <a:alpha val="4000"/>
+            </a:srgbClr>
+          </a:solidFill>
+          <a:ln/>
+        </p:spPr>
+      </p:sp>
+      <p:sp>
+        <p:nvSpPr>
+          <p:cNvPr id="3" name="Text 1"/>
+          <p:cNvSpPr/>
+          <p:nvPr/>
+        </p:nvSpPr>
+        <p:spPr>
+          <a:xfrm>
+            <a:off x="914400" y="914400"/>
+            <a:ext cx="7315200" cy="3291840"/>
+          </a:xfrm>
+          <a:prstGeom prst="rect">
+            <a:avLst/>
+          </a:prstGeom>
+          <a:noFill/>
+          <a:ln/>
+        </p:spPr>
+        <p:txBody>
+          <a:bodyPr wrap="square" lIns="0" tIns="0" rIns="0" bIns="0" rtlCol="0" anchor="ctr"/>
+          <a:lstStyle/>
+          <a:p>
+            <a:pPr algn="ctr" indent="0" marL="0">
+              <a:buNone/>
+            </a:pPr>
+            <a:r>
+              <a:rPr lang="en-US" sz="2800" b="1" dirty="0">
+                <a:solidFill>
+                  <a:srgbClr val="635BFF"/>
+                </a:solidFill>
+                <a:latin typeface="Georgia" pitchFamily="34" charset="0"/>
+                <a:ea typeface="Georgia" pitchFamily="34" charset="-122"/>
+                <a:cs typeface="Georgia" pitchFamily="34" charset="-120"/>
+              </a:rPr>
+              <a:t>Enable the Presentation skill</a:t>
+            </a:r>
+            <a:endParaRPr lang="en-US" sz="2800" dirty="0"/>
+          </a:p>
+          <a:p>
+            <a:pPr algn="ctr" indent="0" marL="0">
+              <a:buNone/>
+            </a:pPr>
+            <a:r>
+              <a:rPr lang="en-US" sz="3600" b="1" dirty="0">
+                <a:solidFill>
+                  <a:srgbClr val="635BFF"/>
+                </a:solidFill>
+                <a:latin typeface="Georgia" pitchFamily="34" charset="0"/>
+                <a:ea typeface="Georgia" pitchFamily="34" charset="-122"/>
+                <a:cs typeface="Georgia" pitchFamily="34" charset="-120"/>
+              </a:rPr>
+              <a:t>Then type: "Make me a presentation</a:t>
+            </a:r>
+            <a:endParaRPr lang="en-US" sz="2800" dirty="0"/>
+          </a:p>
+          <a:p>
+            <a:pPr algn="ctr" indent="0" marL="0">
+              <a:buNone/>
+            </a:pPr>
+            <a:r>
+              <a:rPr lang="en-US" sz="3600" b="1" dirty="0">
+                <a:solidFill>
+                  <a:srgbClr val="635BFF"/>
+                </a:solidFill>
+                <a:latin typeface="Georgia" pitchFamily="34" charset="0"/>
+                <a:ea typeface="Georgia" pitchFamily="34" charset="-122"/>
+                <a:cs typeface="Georgia" pitchFamily="34" charset="-120"/>
+              </a:rPr>
+              <a:t>about making a cup of tea"</a:t>
+            </a:r>
+            <a:endParaRPr lang="en-US" sz="2800" dirty="0"/>
+          </a:p>
+          <a:p>
+            <a:pPr algn="ctr" indent="0" marL="0">
+              <a:buNone/>
+            </a:pPr>
+            <a:r>
+              <a:rPr lang="en-US" sz="2200" i="1" dirty="0">
+                <a:solidFill>
+                  <a:srgbClr val="8B95A5"/>
+                </a:solidFill>
+                <a:latin typeface="Verdana" pitchFamily="34" charset="0"/>
+                <a:ea typeface="Verdana" pitchFamily="34" charset="-122"/>
+                <a:cs typeface="Verdana" pitchFamily="34" charset="-120"/>
+              </a:rPr>
+              <a:t>One sentence. It already knows the rest.</a:t>
+            </a:r>
+            <a:endParaRPr lang="en-US" sz="2800" dirty="0"/>
+          </a:p>
+        </p:txBody>
+      </p:sp>
+    </p:spTree>
+  </p:cSld>
+  <p:clrMapOvr>
+    <a:masterClrMapping/>
+  </p:clrMapOvr>
+</p:sld>
+</file>
+
+<file path=ppt/slides/slide27.xml><?xml version="1.0" encoding="utf-8"?>
+<p:sld xmlns:a="http://schemas.openxmlformats.org/drawingml/2006/main" xmlns:r="http://schemas.openxmlformats.org/officeDocument/2006/relationships" xmlns:p="http://schemas.openxmlformats.org/presentationml/2006/main">
+  <p:cSld name="Slide 27">
+    <p:bg>
+      <p:bgPr>
+        <a:solidFill>
+          <a:srgbClr val="0A2540"/>
+        </a:solidFill>
+      </p:bgPr>
+    </p:bg>
+    <p:spTree>
+      <p:nvGrpSpPr>
+        <p:cNvPr id="1" name=""/>
+        <p:cNvGrpSpPr/>
+        <p:nvPr/>
+      </p:nvGrpSpPr>
+      <p:grpSpPr>
+        <a:xfrm>
+          <a:off x="0" y="0"/>
+          <a:ext cx="0" cy="0"/>
+          <a:chOff x="0" y="0"/>
+          <a:chExt cx="0" cy="0"/>
+        </a:xfrm>
+      </p:grpSpPr>
+      <p:sp>
+        <p:nvSpPr>
+          <p:cNvPr id="2" name="Shape 0"/>
+          <p:cNvSpPr/>
+          <p:nvPr/>
+        </p:nvSpPr>
+        <p:spPr>
+          <a:xfrm>
+            <a:off x="4572000" y="2286000"/>
+            <a:ext cx="7315200" cy="5486400"/>
+          </a:xfrm>
+          <a:prstGeom prst="ellipse">
+            <a:avLst/>
+          </a:prstGeom>
+          <a:solidFill>
+            <a:srgbClr val="635BFF">
+              <a:alpha val="4000"/>
+            </a:srgbClr>
+          </a:solidFill>
+          <a:ln/>
+        </p:spPr>
+      </p:sp>
+      <p:sp>
+        <p:nvSpPr>
+          <p:cNvPr id="3" name="Text 1"/>
+          <p:cNvSpPr/>
+          <p:nvPr/>
+        </p:nvSpPr>
+        <p:spPr>
+          <a:xfrm>
+            <a:off x="914400" y="1097280"/>
+            <a:ext cx="7315200" cy="2560320"/>
+          </a:xfrm>
+          <a:prstGeom prst="rect">
+            <a:avLst/>
+          </a:prstGeom>
+          <a:noFill/>
+          <a:ln/>
+        </p:spPr>
+        <p:txBody>
+          <a:bodyPr wrap="square" lIns="0" tIns="0" rIns="0" bIns="0" rtlCol="0" anchor="ctr"/>
+          <a:lstStyle/>
+          <a:p>
+            <a:pPr algn="ctr" indent="0" marL="0">
+              <a:buNone/>
+            </a:pPr>
+            <a:r>
+              <a:rPr lang="en-US" sz="4400" b="1" dirty="0">
+                <a:solidFill>
+                  <a:srgbClr val="635BFF"/>
+                </a:solidFill>
+                <a:latin typeface="Georgia" pitchFamily="34" charset="0"/>
+                <a:ea typeface="Georgia" pitchFamily="34" charset="-122"/>
+                <a:cs typeface="Georgia" pitchFamily="34" charset="-120"/>
+              </a:rPr>
+              <a:t>The page stays clean.</a:t>
+            </a:r>
+            <a:endParaRPr lang="en-US" sz="4400" dirty="0"/>
+          </a:p>
+          <a:p>
+            <a:pPr algn="ctr" indent="0" marL="0">
+              <a:buNone/>
+            </a:pPr>
+            <a:r>
+              <a:rPr lang="en-US" sz="4400" b="1" dirty="0">
+                <a:solidFill>
+                  <a:srgbClr val="635BFF"/>
+                </a:solidFill>
+                <a:latin typeface="Georgia" pitchFamily="34" charset="0"/>
+                <a:ea typeface="Georgia" pitchFamily="34" charset="-122"/>
+                <a:cs typeface="Georgia" pitchFamily="34" charset="-120"/>
+              </a:rPr>
+              <a:t>The drawer holds the rest.</a:t>
+            </a:r>
+            <a:endParaRPr lang="en-US" sz="4400" dirty="0"/>
+          </a:p>
+        </p:txBody>
+      </p:sp>
+    </p:spTree>
+  </p:cSld>
+  <p:clrMapOvr>
+    <a:masterClrMapping/>
+  </p:clrMapOvr>
+</p:sld>
+</file>
+
+<file path=ppt/slides/slide28.xml><?xml version="1.0" encoding="utf-8"?>
+<p:sld xmlns:a="http://schemas.openxmlformats.org/drawingml/2006/main" xmlns:r="http://schemas.openxmlformats.org/officeDocument/2006/relationships" xmlns:p="http://schemas.openxmlformats.org/presentationml/2006/main">
+  <p:cSld name="Slide 28">
     <p:bg>
       <p:bgPr>
         <a:solidFill>
@@ -7484,344 +7956,6 @@
               <a:t>Strategist</a:t>
             </a:r>
             <a:endParaRPr lang="en-US" sz="1400" dirty="0"/>
-          </a:p>
-        </p:txBody>
-      </p:sp>
-    </p:spTree>
-  </p:cSld>
-  <p:clrMapOvr>
-    <a:masterClrMapping/>
-  </p:clrMapOvr>
-</p:sld>
-</file>
-
-<file path=ppt/slides/slide27.xml><?xml version="1.0" encoding="utf-8"?>
-<p:sld xmlns:a="http://schemas.openxmlformats.org/drawingml/2006/main" xmlns:r="http://schemas.openxmlformats.org/officeDocument/2006/relationships" xmlns:p="http://schemas.openxmlformats.org/presentationml/2006/main">
-  <p:cSld name="Slide 27">
-    <p:bg>
-      <p:bgPr>
-        <a:solidFill>
-          <a:srgbClr val="FFFFFF"/>
-        </a:solidFill>
-      </p:bgPr>
-    </p:bg>
-    <p:spTree>
-      <p:nvGrpSpPr>
-        <p:cNvPr id="1" name=""/>
-        <p:cNvGrpSpPr/>
-        <p:nvPr/>
-      </p:nvGrpSpPr>
-      <p:grpSpPr>
-        <a:xfrm>
-          <a:off x="0" y="0"/>
-          <a:ext cx="0" cy="0"/>
-          <a:chOff x="0" y="0"/>
-          <a:chExt cx="0" cy="0"/>
-        </a:xfrm>
-      </p:grpSpPr>
-      <p:sp>
-        <p:nvSpPr>
-          <p:cNvPr id="2" name="Text 0"/>
-          <p:cNvSpPr/>
-          <p:nvPr/>
-        </p:nvSpPr>
-        <p:spPr>
-          <a:xfrm>
-            <a:off x="457200" y="1371600"/>
-            <a:ext cx="3840480" cy="1097280"/>
-          </a:xfrm>
-          <a:prstGeom prst="rect">
-            <a:avLst/>
-          </a:prstGeom>
-          <a:noFill/>
-          <a:ln/>
-        </p:spPr>
-        <p:txBody>
-          <a:bodyPr wrap="square" lIns="0" tIns="0" rIns="0" bIns="0" rtlCol="0" anchor="ctr"/>
-          <a:lstStyle/>
-          <a:p>
-            <a:pPr algn="ctr" indent="0" marL="0">
-              <a:buNone/>
-            </a:pPr>
-            <a:r>
-              <a:rPr lang="en-US" sz="3200" b="1" dirty="0">
-                <a:solidFill>
-                  <a:srgbClr val="FF6B8A"/>
-                </a:solidFill>
-                <a:latin typeface="Georgia" pitchFamily="34" charset="0"/>
-                <a:ea typeface="Georgia" pitchFamily="34" charset="-122"/>
-                <a:cs typeface="Georgia" pitchFamily="34" charset="-120"/>
-              </a:rPr>
-              <a:t>Directions</a:t>
-            </a:r>
-            <a:endParaRPr lang="en-US" sz="3200" dirty="0"/>
-          </a:p>
-          <a:p>
-            <a:pPr algn="ctr" indent="0" marL="0">
-              <a:buNone/>
-            </a:pPr>
-            <a:r>
-              <a:rPr lang="en-US" sz="3200" b="1" dirty="0">
-                <a:solidFill>
-                  <a:srgbClr val="FF6B8A"/>
-                </a:solidFill>
-                <a:latin typeface="Georgia" pitchFamily="34" charset="0"/>
-                <a:ea typeface="Georgia" pitchFamily="34" charset="-122"/>
-                <a:cs typeface="Georgia" pitchFamily="34" charset="-120"/>
-              </a:rPr>
-              <a:t>every trip</a:t>
-            </a:r>
-            <a:endParaRPr lang="en-US" sz="3200" dirty="0"/>
-          </a:p>
-        </p:txBody>
-      </p:sp>
-      <p:sp>
-        <p:nvSpPr>
-          <p:cNvPr id="3" name="Text 1"/>
-          <p:cNvSpPr/>
-          <p:nvPr/>
-        </p:nvSpPr>
-        <p:spPr>
-          <a:xfrm>
-            <a:off x="457200" y="2560320"/>
-            <a:ext cx="3840480" cy="731520"/>
-          </a:xfrm>
-          <a:prstGeom prst="rect">
-            <a:avLst/>
-          </a:prstGeom>
-          <a:noFill/>
-          <a:ln/>
-        </p:spPr>
-        <p:txBody>
-          <a:bodyPr wrap="square" lIns="0" tIns="0" rIns="0" bIns="0" rtlCol="0" anchor="t"/>
-          <a:lstStyle/>
-          <a:p>
-            <a:pPr algn="ctr" indent="0" marL="0">
-              <a:buNone/>
-            </a:pPr>
-            <a:r>
-              <a:rPr lang="en-US" sz="2200" dirty="0">
-                <a:solidFill>
-                  <a:srgbClr val="8B95A5"/>
-                </a:solidFill>
-                <a:latin typeface="Verdana" pitchFamily="34" charset="0"/>
-                <a:ea typeface="Verdana" pitchFamily="34" charset="-122"/>
-                <a:cs typeface="Verdana" pitchFamily="34" charset="-120"/>
-              </a:rPr>
-              <a:t>Effort. Every. Time.</a:t>
-            </a:r>
-            <a:endParaRPr lang="en-US" sz="2200" dirty="0"/>
-          </a:p>
-        </p:txBody>
-      </p:sp>
-      <p:sp>
-        <p:nvSpPr>
-          <p:cNvPr id="4" name="Shape 2"/>
-          <p:cNvSpPr/>
-          <p:nvPr/>
-        </p:nvSpPr>
-        <p:spPr>
-          <a:xfrm>
-            <a:off x="4572000" y="914400"/>
-            <a:ext cx="0" cy="3291840"/>
-          </a:xfrm>
-          <a:prstGeom prst="line">
-            <a:avLst/>
-          </a:prstGeom>
-          <a:noFill/>
-          <a:ln w="12700">
-            <a:solidFill>
-              <a:srgbClr val="8B95A5"/>
-            </a:solidFill>
-            <a:prstDash val="solid"/>
-          </a:ln>
-        </p:spPr>
-      </p:sp>
-      <p:sp>
-        <p:nvSpPr>
-          <p:cNvPr id="5" name="Text 3"/>
-          <p:cNvSpPr/>
-          <p:nvPr/>
-        </p:nvSpPr>
-        <p:spPr>
-          <a:xfrm>
-            <a:off x="4846320" y="1371600"/>
-            <a:ext cx="3840480" cy="1097280"/>
-          </a:xfrm>
-          <a:prstGeom prst="rect">
-            <a:avLst/>
-          </a:prstGeom>
-          <a:noFill/>
-          <a:ln/>
-        </p:spPr>
-        <p:txBody>
-          <a:bodyPr wrap="square" lIns="0" tIns="0" rIns="0" bIns="0" rtlCol="0" anchor="ctr"/>
-          <a:lstStyle/>
-          <a:p>
-            <a:pPr algn="ctr" indent="0" marL="0">
-              <a:buNone/>
-            </a:pPr>
-            <a:r>
-              <a:rPr lang="en-US" sz="3200" b="1" dirty="0">
-                <a:solidFill>
-                  <a:srgbClr val="09825D"/>
-                </a:solidFill>
-                <a:latin typeface="Georgia" pitchFamily="34" charset="0"/>
-                <a:ea typeface="Georgia" pitchFamily="34" charset="-122"/>
-                <a:cs typeface="Georgia" pitchFamily="34" charset="-120"/>
-              </a:rPr>
-              <a:t>GPS that</a:t>
-            </a:r>
-            <a:endParaRPr lang="en-US" sz="3200" dirty="0"/>
-          </a:p>
-          <a:p>
-            <a:pPr algn="ctr" indent="0" marL="0">
-              <a:buNone/>
-            </a:pPr>
-            <a:r>
-              <a:rPr lang="en-US" sz="3200" b="1" dirty="0">
-                <a:solidFill>
-                  <a:srgbClr val="09825D"/>
-                </a:solidFill>
-                <a:latin typeface="Georgia" pitchFamily="34" charset="0"/>
-                <a:ea typeface="Georgia" pitchFamily="34" charset="-122"/>
-                <a:cs typeface="Georgia" pitchFamily="34" charset="-120"/>
-              </a:rPr>
-              <a:t>remembers</a:t>
-            </a:r>
-            <a:endParaRPr lang="en-US" sz="3200" dirty="0"/>
-          </a:p>
-        </p:txBody>
-      </p:sp>
-      <p:sp>
-        <p:nvSpPr>
-          <p:cNvPr id="6" name="Text 4"/>
-          <p:cNvSpPr/>
-          <p:nvPr/>
-        </p:nvSpPr>
-        <p:spPr>
-          <a:xfrm>
-            <a:off x="4846320" y="2560320"/>
-            <a:ext cx="3840480" cy="731520"/>
-          </a:xfrm>
-          <a:prstGeom prst="rect">
-            <a:avLst/>
-          </a:prstGeom>
-          <a:noFill/>
-          <a:ln/>
-        </p:spPr>
-        <p:txBody>
-          <a:bodyPr wrap="square" lIns="0" tIns="0" rIns="0" bIns="0" rtlCol="0" anchor="t"/>
-          <a:lstStyle/>
-          <a:p>
-            <a:pPr algn="ctr" indent="0" marL="0">
-              <a:buNone/>
-            </a:pPr>
-            <a:r>
-              <a:rPr lang="en-US" sz="2200" dirty="0">
-                <a:solidFill>
-                  <a:srgbClr val="635BFF"/>
-                </a:solidFill>
-                <a:latin typeface="Verdana" pitchFamily="34" charset="0"/>
-                <a:ea typeface="Verdana" pitchFamily="34" charset="-122"/>
-                <a:cs typeface="Verdana" pitchFamily="34" charset="-120"/>
-              </a:rPr>
-              <a:t>Compounds permanently.</a:t>
-            </a:r>
-            <a:endParaRPr lang="en-US" sz="2200" dirty="0"/>
-          </a:p>
-        </p:txBody>
-      </p:sp>
-    </p:spTree>
-  </p:cSld>
-  <p:clrMapOvr>
-    <a:masterClrMapping/>
-  </p:clrMapOvr>
-</p:sld>
-</file>
-
-<file path=ppt/slides/slide28.xml><?xml version="1.0" encoding="utf-8"?>
-<p:sld xmlns:a="http://schemas.openxmlformats.org/drawingml/2006/main" xmlns:r="http://schemas.openxmlformats.org/officeDocument/2006/relationships" xmlns:p="http://schemas.openxmlformats.org/presentationml/2006/main">
-  <p:cSld name="Slide 28">
-    <p:bg>
-      <p:bgPr>
-        <a:solidFill>
-          <a:srgbClr val="0A2540"/>
-        </a:solidFill>
-      </p:bgPr>
-    </p:bg>
-    <p:spTree>
-      <p:nvGrpSpPr>
-        <p:cNvPr id="1" name=""/>
-        <p:cNvGrpSpPr/>
-        <p:nvPr/>
-      </p:nvGrpSpPr>
-      <p:grpSpPr>
-        <a:xfrm>
-          <a:off x="0" y="0"/>
-          <a:ext cx="0" cy="0"/>
-          <a:chOff x="0" y="0"/>
-          <a:chExt cx="0" cy="0"/>
-        </a:xfrm>
-      </p:grpSpPr>
-      <p:sp>
-        <p:nvSpPr>
-          <p:cNvPr id="2" name="Shape 0"/>
-          <p:cNvSpPr/>
-          <p:nvPr/>
-        </p:nvSpPr>
-        <p:spPr>
-          <a:xfrm>
-            <a:off x="4572000" y="2286000"/>
-            <a:ext cx="7315200" cy="5486400"/>
-          </a:xfrm>
-          <a:prstGeom prst="ellipse">
-            <a:avLst/>
-          </a:prstGeom>
-          <a:solidFill>
-            <a:srgbClr val="635BFF">
-              <a:alpha val="4000"/>
-            </a:srgbClr>
-          </a:solidFill>
-          <a:ln/>
-        </p:spPr>
-      </p:sp>
-      <p:sp>
-        <p:nvSpPr>
-          <p:cNvPr id="3" name="Text 1"/>
-          <p:cNvSpPr/>
-          <p:nvPr/>
-        </p:nvSpPr>
-        <p:spPr>
-          <a:xfrm>
-            <a:off x="914400" y="1097280"/>
-            <a:ext cx="7315200" cy="2560320"/>
-          </a:xfrm>
-          <a:prstGeom prst="rect">
-            <a:avLst/>
-          </a:prstGeom>
-          <a:noFill/>
-          <a:ln/>
-        </p:spPr>
-        <p:txBody>
-          <a:bodyPr wrap="square" lIns="0" tIns="0" rIns="0" bIns="0" rtlCol="0" anchor="ctr"/>
-          <a:lstStyle/>
-          <a:p>
-            <a:pPr algn="ctr" indent="0" marL="0">
-              <a:buNone/>
-            </a:pPr>
-            <a:r>
-              <a:rPr lang="en-US" sz="5400" b="1" dirty="0">
-                <a:solidFill>
-                  <a:srgbClr val="FFFFFF"/>
-                </a:solidFill>
-                <a:latin typeface="Georgia" pitchFamily="34" charset="0"/>
-                <a:ea typeface="Georgia" pitchFamily="34" charset="-122"/>
-                <a:cs typeface="Georgia" pitchFamily="34" charset="-120"/>
-              </a:rPr>
-              <a:t>You're now a Strategist</a:t>
-            </a:r>
-            <a:endParaRPr lang="en-US" sz="5400" dirty="0"/>
           </a:p>
         </p:txBody>
       </p:sp>
@@ -7904,7 +8038,7 @@
               <a:buNone/>
             </a:pPr>
             <a:r>
-              <a:rPr lang="en-US" sz="4800" b="1" dirty="0">
+              <a:rPr lang="en-US" sz="5400" b="1" dirty="0">
                 <a:solidFill>
                   <a:srgbClr val="FFFFFF"/>
                 </a:solidFill>
@@ -7912,43 +8046,9 @@
                 <a:ea typeface="Georgia" pitchFamily="34" charset="-122"/>
                 <a:cs typeface="Georgia" pitchFamily="34" charset="-120"/>
               </a:rPr>
-              <a:t>But who's doing</a:t>
-            </a:r>
-            <a:endParaRPr lang="en-US" sz="4800" dirty="0"/>
-          </a:p>
-          <a:p>
-            <a:pPr algn="ctr" indent="0" marL="0">
-              <a:buNone/>
-            </a:pPr>
-            <a:r>
-              <a:rPr lang="en-US" sz="4800" b="1" dirty="0">
-                <a:solidFill>
-                  <a:srgbClr val="FFFFFF"/>
-                </a:solidFill>
-                <a:latin typeface="Georgia" pitchFamily="34" charset="0"/>
-                <a:ea typeface="Georgia" pitchFamily="34" charset="-122"/>
-                <a:cs typeface="Georgia" pitchFamily="34" charset="-120"/>
-              </a:rPr>
-              <a:t>all the work?</a:t>
-            </a:r>
-            <a:endParaRPr lang="en-US" sz="4800" dirty="0"/>
-          </a:p>
-          <a:p>
-            <a:pPr algn="ctr" indent="0" marL="0">
-              <a:buNone/>
-            </a:pPr>
-            <a:r>
-              <a:rPr lang="en-US" sz="4800" b="1" dirty="0">
-                <a:solidFill>
-                  <a:srgbClr val="FFFFFF"/>
-                </a:solidFill>
-                <a:latin typeface="Georgia" pitchFamily="34" charset="0"/>
-                <a:ea typeface="Georgia" pitchFamily="34" charset="-122"/>
-                <a:cs typeface="Georgia" pitchFamily="34" charset="-120"/>
-              </a:rPr>
-              <a:t>Still you.</a:t>
-            </a:r>
-            <a:endParaRPr lang="en-US" sz="4800" dirty="0"/>
+              <a:t>You're now a Strategist</a:t>
+            </a:r>
+            <a:endParaRPr lang="en-US" sz="5400" dirty="0"/>
           </a:p>
         </p:txBody>
       </p:sp>
@@ -8059,6 +8159,133 @@
               <a:t>AND the information</a:t>
             </a:r>
             <a:endParaRPr lang="en-US" sz="4400" dirty="0"/>
+          </a:p>
+        </p:txBody>
+      </p:sp>
+    </p:spTree>
+  </p:cSld>
+  <p:clrMapOvr>
+    <a:masterClrMapping/>
+  </p:clrMapOvr>
+</p:sld>
+</file>
+
+<file path=ppt/slides/slide30.xml><?xml version="1.0" encoding="utf-8"?>
+<p:sld xmlns:a="http://schemas.openxmlformats.org/drawingml/2006/main" xmlns:r="http://schemas.openxmlformats.org/officeDocument/2006/relationships" xmlns:p="http://schemas.openxmlformats.org/presentationml/2006/main">
+  <p:cSld name="Slide 30">
+    <p:bg>
+      <p:bgPr>
+        <a:solidFill>
+          <a:srgbClr val="0A2540"/>
+        </a:solidFill>
+      </p:bgPr>
+    </p:bg>
+    <p:spTree>
+      <p:nvGrpSpPr>
+        <p:cNvPr id="1" name=""/>
+        <p:cNvGrpSpPr/>
+        <p:nvPr/>
+      </p:nvGrpSpPr>
+      <p:grpSpPr>
+        <a:xfrm>
+          <a:off x="0" y="0"/>
+          <a:ext cx="0" cy="0"/>
+          <a:chOff x="0" y="0"/>
+          <a:chExt cx="0" cy="0"/>
+        </a:xfrm>
+      </p:grpSpPr>
+      <p:sp>
+        <p:nvSpPr>
+          <p:cNvPr id="2" name="Shape 0"/>
+          <p:cNvSpPr/>
+          <p:nvPr/>
+        </p:nvSpPr>
+        <p:spPr>
+          <a:xfrm>
+            <a:off x="4572000" y="2286000"/>
+            <a:ext cx="7315200" cy="5486400"/>
+          </a:xfrm>
+          <a:prstGeom prst="ellipse">
+            <a:avLst/>
+          </a:prstGeom>
+          <a:solidFill>
+            <a:srgbClr val="635BFF">
+              <a:alpha val="4000"/>
+            </a:srgbClr>
+          </a:solidFill>
+          <a:ln/>
+        </p:spPr>
+      </p:sp>
+      <p:sp>
+        <p:nvSpPr>
+          <p:cNvPr id="3" name="Text 1"/>
+          <p:cNvSpPr/>
+          <p:nvPr/>
+        </p:nvSpPr>
+        <p:spPr>
+          <a:xfrm>
+            <a:off x="914400" y="1097280"/>
+            <a:ext cx="7315200" cy="2560320"/>
+          </a:xfrm>
+          <a:prstGeom prst="rect">
+            <a:avLst/>
+          </a:prstGeom>
+          <a:noFill/>
+          <a:ln/>
+        </p:spPr>
+        <p:txBody>
+          <a:bodyPr wrap="square" lIns="0" tIns="0" rIns="0" bIns="0" rtlCol="0" anchor="ctr"/>
+          <a:lstStyle/>
+          <a:p>
+            <a:pPr algn="ctr" indent="0" marL="0">
+              <a:buNone/>
+            </a:pPr>
+            <a:r>
+              <a:rPr lang="en-US" sz="4800" b="1" dirty="0">
+                <a:solidFill>
+                  <a:srgbClr val="FFFFFF"/>
+                </a:solidFill>
+                <a:latin typeface="Georgia" pitchFamily="34" charset="0"/>
+                <a:ea typeface="Georgia" pitchFamily="34" charset="-122"/>
+                <a:cs typeface="Georgia" pitchFamily="34" charset="-120"/>
+              </a:rPr>
+              <a:t>But who's doing</a:t>
+            </a:r>
+            <a:endParaRPr lang="en-US" sz="4800" dirty="0"/>
+          </a:p>
+          <a:p>
+            <a:pPr algn="ctr" indent="0" marL="0">
+              <a:buNone/>
+            </a:pPr>
+            <a:r>
+              <a:rPr lang="en-US" sz="4800" b="1" dirty="0">
+                <a:solidFill>
+                  <a:srgbClr val="FFFFFF"/>
+                </a:solidFill>
+                <a:latin typeface="Georgia" pitchFamily="34" charset="0"/>
+                <a:ea typeface="Georgia" pitchFamily="34" charset="-122"/>
+                <a:cs typeface="Georgia" pitchFamily="34" charset="-120"/>
+              </a:rPr>
+              <a:t>all the work?</a:t>
+            </a:r>
+            <a:endParaRPr lang="en-US" sz="4800" dirty="0"/>
+          </a:p>
+          <a:p>
+            <a:pPr algn="ctr" indent="0" marL="0">
+              <a:buNone/>
+            </a:pPr>
+            <a:r>
+              <a:rPr lang="en-US" sz="4800" b="1" dirty="0">
+                <a:solidFill>
+                  <a:srgbClr val="FFFFFF"/>
+                </a:solidFill>
+                <a:latin typeface="Georgia" pitchFamily="34" charset="0"/>
+                <a:ea typeface="Georgia" pitchFamily="34" charset="-122"/>
+                <a:cs typeface="Georgia" pitchFamily="34" charset="-120"/>
+              </a:rPr>
+              <a:t>Still you.</a:t>
+            </a:r>
+            <a:endParaRPr lang="en-US" sz="4800" dirty="0"/>
           </a:p>
         </p:txBody>
       </p:sp>

</xml_diff>

<commit_message>
Add spectrum callbacks to workshop decks
Extract reusable spectrum() function. Add mid-point callbacks:
W1 after first reveal (Explorer→Whisperer), W2 after trust section
(Strategist→Operator). Replace W1 "You're now a Strategist" hero
with spectrum visual showing earned progress. Quick flash, no
lingering — wayfinding not decoration.

Co-Authored-By: Claude Opus 4.6 <noreply@anthropic.com>
</commit_message>
<xml_diff>
--- a/decks/workshop-1-strategist/workshop-1-strategist.pptx
+++ b/decks/workshop-1-strategist/workshop-1-strategist.pptx
@@ -35,9 +35,10 @@
     <p:sldId id="283" r:id="rId29"/>
     <p:sldId id="284" r:id="rId30"/>
     <p:sldId id="285" r:id="rId31"/>
+    <p:sldId id="286" r:id="rId32"/>
   </p:sldIdLst>
   <p:notesMasterIdLst>
-    <p:notesMasterId r:id="rId32"/>
+    <p:notesMasterId r:id="rId33"/>
   </p:notesMasterIdLst>
   <p:sldSz cx="9144000" cy="5143500"/>
   <p:notesSz cx="5143500" cy="9144000"/>
@@ -1235,7 +1236,7 @@
           <a:p>
             <a:r>
               <a:rPr lang="en-US" dirty="0"/>
-              <a:t>The pivot. Five techniques, dramatic improvement. But every round changed the words — never the information. "Watch what happens when we do." This sets up the biggest conceptual shift in the workshop.</a:t>
+              <a:t>Quick flash — 5 seconds. "You just crossed from Explorer to Whisperer. Five techniques, one task, dramatic improvement. But we haven't changed what the AI knows yet." Don't linger. Move on.</a:t>
             </a:r>
             <a:endParaRPr lang="en-US" dirty="0"/>
           </a:p>
@@ -1323,7 +1324,7 @@
           <a:p>
             <a:r>
               <a:rPr lang="en-US" dirty="0"/>
-              <a:t>Take the prompt from Technique 5. Add real detail — numbers, names, constraints. Coach the room to be specific: not "we have tea" but "Our office has a Sage Smart Kettle on the third floor. Loose-leaf collection in the blue tin — mostly Earl Grey and oolong. Dave in accounting is militant about warming the pot first. The audience is new hires who've never used the office kitchen." Then compare. Ask: "Which made a bigger difference — five techniques or four sentences of context?"</a:t>
+              <a:t>The pivot. Five techniques, dramatic improvement. But every round changed the words — never the information. "Watch what happens when we do." This sets up the biggest conceptual shift in the workshop.</a:t>
             </a:r>
             <a:endParaRPr lang="en-US" dirty="0"/>
           </a:p>
@@ -1411,7 +1412,7 @@
           <a:p>
             <a:r>
               <a:rPr lang="en-US" dirty="0"/>
-              <a:t>The Dory image should get a laugh — let it land. "Every conversation starts from scratch. She doesn't know your company, your role, or what you told her yesterday." This is the memory problem that rules and Skills solve.</a:t>
+              <a:t>Take the prompt from Technique 5. Add real detail — numbers, names, constraints. Coach the room to be specific: not "we have tea" but "Our office has a Sage Smart Kettle on the third floor. Loose-leaf collection in the blue tin — mostly Earl Grey and oolong. Dave in accounting is militant about warming the pot first. The audience is new hires who've never used the office kitchen." Then compare. Ask: "Which made a bigger difference — five techniques or four sentences of context?"</a:t>
             </a:r>
             <a:endParaRPr lang="en-US" dirty="0"/>
           </a:p>
@@ -1587,7 +1588,7 @@
           <a:p>
             <a:r>
               <a:rPr lang="en-US" dirty="0"/>
-              <a:t>This is the single highest-leverage technique in the workshop. Point out what the AI asked that the attendee hadn't thought to provide — budget constraints, stakeholder concerns, timeline, success criteria. "Did it surface things you hadn't thought of?"</a:t>
+              <a:t>The Dory image should get a laugh — let it land. "Every conversation starts from scratch. She doesn't know your company, your role, or what you told her yesterday." This is the memory problem that rules and Skills solve.</a:t>
             </a:r>
             <a:endParaRPr lang="en-US" dirty="0"/>
           </a:p>
@@ -1675,7 +1676,7 @@
           <a:p>
             <a:r>
               <a:rPr lang="en-US" dirty="0"/>
-              <a:t>Pivot to the pain. They just pasted all that context manually — role, company, preferences, constraints. Next conversation, they'll do it all again. Let the frustration build. "What if the AI already knew?"</a:t>
+              <a:t>This is the single highest-leverage technique in the workshop. Point out what the AI asked that the attendee hadn't thought to provide — budget constraints, stakeholder concerns, timeline, success criteria. "Did it surface things you hadn't thought of?"</a:t>
             </a:r>
             <a:endParaRPr lang="en-US" dirty="0"/>
           </a:p>
@@ -1763,7 +1764,7 @@
           <a:p>
             <a:r>
               <a:rPr lang="en-US" dirty="0"/>
-              <a:t>Screen-share this walkthrough. Wait for everyone to find it. "This is where you tell Claude who you are — once. These are your rules." Verify the exact path before the session — Claude may move this periodically.</a:t>
+              <a:t>Pivot to the pain. They just pasted all that context manually — role, company, preferences, constraints. Next conversation, they'll do it all again. Let the frustration build. "What if the AI already knew?"</a:t>
             </a:r>
             <a:endParaRPr lang="en-US" dirty="0"/>
           </a:p>
@@ -1851,7 +1852,7 @@
           <a:p>
             <a:r>
               <a:rPr lang="en-US" dirty="0"/>
-              <a:t>3 minutes to write. Walk the room. Help anyone stuck. Template: "I work at [company]. My role is [role]. Be radically honest. Challenge my assumptions. Flag uncertainty. When I ask for presentations, default to billboard design — max 15 words per slide, with speaker notes." Quick test: open a NEW conversation and ask a question about your work — it already knows your role. Rules = who you are.</a:t>
+              <a:t>Screen-share this walkthrough. Wait for everyone to find it. "This is where you tell Claude who you are — once. These are your rules." Verify the exact path before the session — Claude may move this periodically.</a:t>
             </a:r>
             <a:endParaRPr lang="en-US" dirty="0"/>
           </a:p>
@@ -1939,7 +1940,7 @@
           <a:p>
             <a:r>
               <a:rPr lang="en-US" dirty="0"/>
-              <a:t>"You just wrote your rules. Here's what that actually looks like." One piece of A4 paper. That's it. Everything she knows right now — your rules, your request, the conversation — fits on this one page. Your rules go on this page. They're always there, grounding every conversation. That's powerful. But the page is small — you need to be selective about what earns a permanent spot. "So what happens to all those brilliant workflows that don't fit on the page?"</a:t>
+              <a:t>3 minutes to write. Walk the room. Help anyone stuck. Template: "I work at [company]. My role is [role]. Be radically honest. Challenge my assumptions. Flag uncertainty. When I ask for presentations, default to billboard design — max 15 words per slide, with speaker notes." Quick test: open a NEW conversation and ask a question about your work — it already knows your role. Rules = who you are.</a:t>
             </a:r>
             <a:endParaRPr lang="en-US" dirty="0"/>
           </a:p>
@@ -2027,7 +2028,7 @@
           <a:p>
             <a:r>
               <a:rPr lang="en-US" dirty="0"/>
-              <a:t>Skills. Instructions kept in a drawer, pulled onto the page only when the task needs them. They don't take up memory between tasks. She pulls one out, uses it, puts it back. The page stays clean. Rule example (always on the page): 'All presentations use billboard design.' Skill example (from the drawer): 'How to write a project proposal' — step-by-step workflow loaded when you ask for a proposal, back in the drawer when you don't. Navigate to Customize → Skills. Show the built-in Anthropic Skills: presentations, documents, spreadsheets.</a:t>
+              <a:t>"You just wrote your rules. Here's what that actually looks like." One piece of A4 paper. That's it. Everything she knows right now — your rules, your request, the conversation — fits on this one page. Your rules go on this page. They're always there, grounding every conversation. That's powerful. But the page is small — you need to be selective about what earns a permanent spot. "So what happens to all those brilliant workflows that don't fit on the page?"</a:t>
             </a:r>
             <a:endParaRPr lang="en-US" dirty="0"/>
           </a:p>
@@ -2115,7 +2116,7 @@
           <a:p>
             <a:r>
               <a:rPr lang="en-US" dirty="0"/>
-              <a:t>Have them enable the presentation Skill in Customize → Skills, then use it. The aha: they typed one bare sentence and got output that knows who they are (rules on the page) AND how to build a proper presentation (Skill pulled from the drawer). "The page told her who you are. The drawer told her how to work."</a:t>
+              <a:t>Skills. Instructions kept in a drawer, pulled onto the page only when the task needs them. They don't take up memory between tasks. She pulls one out, uses it, puts it back. The page stays clean. Rule example (always on the page): 'All presentations use billboard design.' Skill example (from the drawer): 'How to write a project proposal' — step-by-step workflow loaded when you ask for a proposal, back in the drawer when you don't. Navigate to Customize → Skills. Show the built-in Anthropic Skills: presentations, documents, spreadsheets.</a:t>
             </a:r>
             <a:endParaRPr lang="en-US" dirty="0"/>
           </a:p>
@@ -2203,7 +2204,7 @@
           <a:p>
             <a:r>
               <a:rPr lang="en-US" dirty="0"/>
-              <a:t>The landing line. Rules earn a permanent spot on the page — only the essentials. Everything else lives in the drawer as Skills, pulled out when relevant. This is the distinction that separates someone who 'uses AI' from someone who has built a system. The page doesn't fill up because Skills come and go. "Personal preferences = the page. Skills = the drawer. Both compound. Both stack."</a:t>
+              <a:t>Have them enable the presentation Skill in Customize → Skills, then use it. The aha: they typed one bare sentence and got output that knows who they are (rules on the page) AND how to build a proper presentation (Skill pulled from the drawer). "The page told her who you are. The drawer told her how to work."</a:t>
             </a:r>
             <a:endParaRPr lang="en-US" dirty="0"/>
           </a:p>
@@ -2291,7 +2292,7 @@
           <a:p>
             <a:r>
               <a:rPr lang="en-US" dirty="0"/>
-              <a:t>Second emotional peak — bigger than the first. The three-way comparison shows the full journey. If time is tight, this can be a facilitator demo. Point out: column 1 to 2 was five techniques. Column 2 to 3 was rules + Skills. The second jump required zero effort per conversation.</a:t>
+              <a:t>The landing line. Rules earn a permanent spot on the page — only the essentials. Everything else lives in the drawer as Skills, pulled out when relevant. This is the distinction that separates someone who 'uses AI' from someone who has built a system. The page doesn't fill up because Skills come and go. "Personal preferences = the page. Skills = the drawer. Both compound. Both stack."</a:t>
             </a:r>
             <a:endParaRPr lang="en-US" dirty="0"/>
           </a:p>
@@ -2379,7 +2380,7 @@
           <a:p>
             <a:r>
               <a:rPr lang="en-US" dirty="0"/>
-              <a:t>Brief graduation moment. "You don't just talk to AI well — you've set up its playbook." But keep it short — this is the halfway point, not the finish line.</a:t>
+              <a:t>Second emotional peak — bigger than the first. The three-way comparison shows the full journey. If time is tight, this can be a facilitator demo. Point out: column 1 to 2 was five techniques. Column 2 to 3 was rules + Skills. The second jump required zero effort per conversation.</a:t>
             </a:r>
             <a:endParaRPr lang="en-US" dirty="0"/>
           </a:p>
@@ -2555,7 +2556,7 @@
           <a:p>
             <a:r>
               <a:rPr lang="en-US" dirty="0"/>
-              <a:t>The cliffhanger. "You search, you paste, you copy, you apply. Every step has 'you' in it." This should sting — they just felt the power of rules + Skills, but they're still the bottleneck. "Next time: Strategist → Orchestrator. We hand the AI the keys — and build it a team." Plant the seed: "Rules tell Claude who you are. Skills tell Claude how to work. Next time, each step in a chain gets its own specialized Skill — a whole team." Remind: save your prompt, preferences, and enabled Skills — they carry forward.</a:t>
+              <a:t>Graduation moment — the spectrum fills in. "You don't just talk to AI well — you've set up its playbook." But keep it short — this is the halfway point, not the finish line.</a:t>
             </a:r>
             <a:endParaRPr lang="en-US" dirty="0"/>
           </a:p>
@@ -2579,6 +2580,94 @@
             <a:fld id="{F7021451-1387-4CA6-816F-3879F97B5CBC}" type="slidenum">
               <a:rPr lang="en-US"/>
               <a:t>30</a:t>
+            </a:fld>
+            <a:endParaRPr lang="en-US"/>
+          </a:p>
+        </p:txBody>
+      </p:sp>
+    </p:spTree>
+    <p:extLst>
+      <p:ext uri="{BB962C8B-B14F-4D97-AF65-F5344CB8AC3E}">
+        <p14:creationId xmlns:p14="http://schemas.microsoft.com/office/powerpoint/2010/main" val="1024086991"/>
+      </p:ext>
+    </p:extLst>
+  </p:cSld>
+  <p:clrMapOvr>
+    <a:masterClrMapping/>
+  </p:clrMapOvr>
+</p:notes>
+</file>
+
+<file path=ppt/notesSlides/notesSlide31.xml><?xml version="1.0" encoding="utf-8"?>
+<p:notes xmlns:a="http://schemas.openxmlformats.org/drawingml/2006/main" xmlns:r="http://schemas.openxmlformats.org/officeDocument/2006/relationships" xmlns:p="http://schemas.openxmlformats.org/presentationml/2006/main">
+  <p:cSld>
+    <p:spTree>
+      <p:nvGrpSpPr>
+        <p:cNvPr id="1" name=""/>
+        <p:cNvGrpSpPr/>
+        <p:nvPr/>
+      </p:nvGrpSpPr>
+      <p:grpSpPr>
+        <a:xfrm>
+          <a:off x="0" y="0"/>
+          <a:ext cx="0" cy="0"/>
+          <a:chOff x="0" y="0"/>
+          <a:chExt cx="0" cy="0"/>
+        </a:xfrm>
+      </p:grpSpPr>
+      <p:sp>
+        <p:nvSpPr>
+          <p:cNvPr id="2" name="Slide Image Placeholder 1"/>
+          <p:cNvSpPr>
+            <a:spLocks noGrp="1" noRot="1" noChangeAspect="1"/>
+          </p:cNvSpPr>
+          <p:nvPr>
+            <p:ph type="sldImg"/>
+          </p:nvPr>
+        </p:nvSpPr>
+        <p:spPr/>
+      </p:sp>
+      <p:sp>
+        <p:nvSpPr>
+          <p:cNvPr id="3" name="Notes Placeholder 2"/>
+          <p:cNvSpPr>
+            <a:spLocks noGrp="1"/>
+          </p:cNvSpPr>
+          <p:nvPr>
+            <p:ph type="body" idx="1"/>
+          </p:nvPr>
+        </p:nvSpPr>
+        <p:spPr/>
+        <p:txBody>
+          <a:bodyPr/>
+          <a:lstStyle/>
+          <a:p>
+            <a:r>
+              <a:rPr lang="en-US" dirty="0"/>
+              <a:t>The cliffhanger. "You search, you paste, you copy, you apply. Every step has 'you' in it." This should sting — they just felt the power of rules + Skills, but they're still the bottleneck. "Next time: Strategist → Orchestrator. We hand the AI the keys — and build it a team." Plant the seed: "Rules tell Claude who you are. Skills tell Claude how to work. Next time, each step in a chain gets its own specialized Skill — a whole team." Remind: save your prompt, preferences, and enabled Skills — they carry forward.</a:t>
+            </a:r>
+            <a:endParaRPr lang="en-US" dirty="0"/>
+          </a:p>
+        </p:txBody>
+      </p:sp>
+      <p:sp>
+        <p:nvSpPr>
+          <p:cNvPr id="4" name="Slide Number Placeholder 3"/>
+          <p:cNvSpPr>
+            <a:spLocks noGrp="1"/>
+          </p:cNvSpPr>
+          <p:nvPr>
+            <p:ph type="sldNum" sz="quarter" idx="10"/>
+          </p:nvPr>
+        </p:nvSpPr>
+        <p:spPr/>
+        <p:txBody>
+          <a:bodyPr/>
+          <a:lstStyle/>
+          <a:p>
+            <a:fld id="{F7021451-1387-4CA6-816F-3879F97B5CBC}" type="slidenum">
+              <a:rPr lang="en-US"/>
+              <a:t>31</a:t>
             </a:fld>
             <a:endParaRPr lang="en-US"/>
           </a:p>
@@ -5043,14 +5132,43 @@
       </p:sp>
       <p:sp>
         <p:nvSpPr>
-          <p:cNvPr id="3" name="Text 1"/>
-          <p:cNvSpPr/>
-          <p:nvPr/>
-        </p:nvSpPr>
-        <p:spPr>
-          <a:xfrm>
-            <a:off x="914400" y="1097280"/>
-            <a:ext cx="7315200" cy="2560320"/>
+          <p:cNvPr id="3" name="Shape 1"/>
+          <p:cNvSpPr/>
+          <p:nvPr/>
+        </p:nvSpPr>
+        <p:spPr>
+          <a:xfrm>
+            <a:off x="192024" y="2011680"/>
+            <a:ext cx="1188720" cy="640080"/>
+          </a:xfrm>
+          <a:prstGeom prst="roundRect">
+            <a:avLst>
+              <a:gd name="adj" fmla="val 11429"/>
+            </a:avLst>
+          </a:prstGeom>
+          <a:solidFill>
+            <a:srgbClr val="0A2540">
+              <a:alpha val="50000"/>
+            </a:srgbClr>
+          </a:solidFill>
+          <a:ln w="19050">
+            <a:solidFill>
+              <a:srgbClr val="8B95A5"/>
+            </a:solidFill>
+            <a:prstDash val="solid"/>
+          </a:ln>
+        </p:spPr>
+      </p:sp>
+      <p:sp>
+        <p:nvSpPr>
+          <p:cNvPr id="4" name="Text 2"/>
+          <p:cNvSpPr/>
+          <p:nvPr/>
+        </p:nvSpPr>
+        <p:spPr>
+          <a:xfrm>
+            <a:off x="192024" y="2011680"/>
+            <a:ext cx="1188720" cy="640080"/>
           </a:xfrm>
           <a:prstGeom prst="rect">
             <a:avLst/>
@@ -5059,6 +5177,47 @@
           <a:ln/>
         </p:spPr>
         <p:txBody>
+          <a:bodyPr wrap="square" lIns="0" tIns="0" rIns="0" bIns="0" rtlCol="0" anchor="ctr">
+            <a:normAutofit/>
+          </a:bodyPr>
+          <a:lstStyle/>
+          <a:p>
+            <a:pPr algn="ctr" indent="0" marL="0">
+              <a:buNone/>
+            </a:pPr>
+            <a:r>
+              <a:rPr lang="en-US" sz="1100" b="1" dirty="0">
+                <a:solidFill>
+                  <a:srgbClr val="8B95A5"/>
+                </a:solidFill>
+                <a:latin typeface="Verdana" pitchFamily="34" charset="0"/>
+                <a:ea typeface="Verdana" pitchFamily="34" charset="-122"/>
+                <a:cs typeface="Verdana" pitchFamily="34" charset="-120"/>
+              </a:rPr>
+              <a:t>Skeptic</a:t>
+            </a:r>
+            <a:endParaRPr lang="en-US" sz="1100" dirty="0"/>
+          </a:p>
+        </p:txBody>
+      </p:sp>
+      <p:sp>
+        <p:nvSpPr>
+          <p:cNvPr id="5" name="Text 3"/>
+          <p:cNvSpPr/>
+          <p:nvPr/>
+        </p:nvSpPr>
+        <p:spPr>
+          <a:xfrm>
+            <a:off x="1380744" y="2011680"/>
+            <a:ext cx="73152" cy="640080"/>
+          </a:xfrm>
+          <a:prstGeom prst="rect">
+            <a:avLst/>
+          </a:prstGeom>
+          <a:noFill/>
+          <a:ln/>
+        </p:spPr>
+        <p:txBody>
           <a:bodyPr wrap="square" lIns="0" tIns="0" rIns="0" bIns="0" rtlCol="0" anchor="ctr"/>
           <a:lstStyle/>
           <a:p>
@@ -5066,34 +5225,628 @@
               <a:buNone/>
             </a:pPr>
             <a:r>
-              <a:rPr lang="en-US" sz="4800" b="1" dirty="0">
+              <a:rPr lang="en-US" sz="1100" dirty="0">
+                <a:solidFill>
+                  <a:srgbClr val="8B95A5"/>
+                </a:solidFill>
+                <a:latin typeface="Verdana" pitchFamily="34" charset="0"/>
+                <a:ea typeface="Verdana" pitchFamily="34" charset="-122"/>
+                <a:cs typeface="Verdana" pitchFamily="34" charset="-120"/>
+              </a:rPr>
+              <a:t>→</a:t>
+            </a:r>
+            <a:endParaRPr lang="en-US" sz="1100" dirty="0"/>
+          </a:p>
+        </p:txBody>
+      </p:sp>
+      <p:sp>
+        <p:nvSpPr>
+          <p:cNvPr id="6" name="Shape 4"/>
+          <p:cNvSpPr/>
+          <p:nvPr/>
+        </p:nvSpPr>
+        <p:spPr>
+          <a:xfrm>
+            <a:off x="1453896" y="2011680"/>
+            <a:ext cx="1188720" cy="640080"/>
+          </a:xfrm>
+          <a:prstGeom prst="roundRect">
+            <a:avLst>
+              <a:gd name="adj" fmla="val 11429"/>
+            </a:avLst>
+          </a:prstGeom>
+          <a:solidFill>
+            <a:srgbClr val="635BFF"/>
+          </a:solidFill>
+          <a:ln w="19050">
+            <a:solidFill>
+              <a:srgbClr val="635BFF"/>
+            </a:solidFill>
+            <a:prstDash val="solid"/>
+          </a:ln>
+        </p:spPr>
+      </p:sp>
+      <p:sp>
+        <p:nvSpPr>
+          <p:cNvPr id="7" name="Text 5"/>
+          <p:cNvSpPr/>
+          <p:nvPr/>
+        </p:nvSpPr>
+        <p:spPr>
+          <a:xfrm>
+            <a:off x="1453896" y="2011680"/>
+            <a:ext cx="1188720" cy="640080"/>
+          </a:xfrm>
+          <a:prstGeom prst="rect">
+            <a:avLst/>
+          </a:prstGeom>
+          <a:noFill/>
+          <a:ln/>
+        </p:spPr>
+        <p:txBody>
+          <a:bodyPr wrap="square" lIns="0" tIns="0" rIns="0" bIns="0" rtlCol="0" anchor="ctr">
+            <a:normAutofit/>
+          </a:bodyPr>
+          <a:lstStyle/>
+          <a:p>
+            <a:pPr algn="ctr" indent="0" marL="0">
+              <a:buNone/>
+            </a:pPr>
+            <a:r>
+              <a:rPr lang="en-US" sz="1100" b="1" dirty="0">
                 <a:solidFill>
                   <a:srgbClr val="FFFFFF"/>
                 </a:solidFill>
-                <a:latin typeface="Georgia" pitchFamily="34" charset="0"/>
-                <a:ea typeface="Georgia" pitchFamily="34" charset="-122"/>
-                <a:cs typeface="Georgia" pitchFamily="34" charset="-120"/>
-              </a:rPr>
-              <a:t>We never changed</a:t>
-            </a:r>
-            <a:endParaRPr lang="en-US" sz="4800" dirty="0"/>
-          </a:p>
+                <a:latin typeface="Verdana" pitchFamily="34" charset="0"/>
+                <a:ea typeface="Verdana" pitchFamily="34" charset="-122"/>
+                <a:cs typeface="Verdana" pitchFamily="34" charset="-120"/>
+              </a:rPr>
+              <a:t>Explorer</a:t>
+            </a:r>
+            <a:endParaRPr lang="en-US" sz="1100" dirty="0"/>
+          </a:p>
+        </p:txBody>
+      </p:sp>
+      <p:sp>
+        <p:nvSpPr>
+          <p:cNvPr id="8" name="Text 6"/>
+          <p:cNvSpPr/>
+          <p:nvPr/>
+        </p:nvSpPr>
+        <p:spPr>
+          <a:xfrm>
+            <a:off x="2642616" y="2011680"/>
+            <a:ext cx="73152" cy="640080"/>
+          </a:xfrm>
+          <a:prstGeom prst="rect">
+            <a:avLst/>
+          </a:prstGeom>
+          <a:noFill/>
+          <a:ln/>
+        </p:spPr>
+        <p:txBody>
+          <a:bodyPr wrap="square" lIns="0" tIns="0" rIns="0" bIns="0" rtlCol="0" anchor="ctr"/>
+          <a:lstStyle/>
           <a:p>
             <a:pPr algn="ctr" indent="0" marL="0">
               <a:buNone/>
             </a:pPr>
             <a:r>
-              <a:rPr lang="en-US" sz="4800" b="1" dirty="0">
+              <a:rPr lang="en-US" sz="1100" dirty="0">
+                <a:solidFill>
+                  <a:srgbClr val="8B95A5"/>
+                </a:solidFill>
+                <a:latin typeface="Verdana" pitchFamily="34" charset="0"/>
+                <a:ea typeface="Verdana" pitchFamily="34" charset="-122"/>
+                <a:cs typeface="Verdana" pitchFamily="34" charset="-120"/>
+              </a:rPr>
+              <a:t>→</a:t>
+            </a:r>
+            <a:endParaRPr lang="en-US" sz="1100" dirty="0"/>
+          </a:p>
+        </p:txBody>
+      </p:sp>
+      <p:sp>
+        <p:nvSpPr>
+          <p:cNvPr id="9" name="Shape 7"/>
+          <p:cNvSpPr/>
+          <p:nvPr/>
+        </p:nvSpPr>
+        <p:spPr>
+          <a:xfrm>
+            <a:off x="2715768" y="2011680"/>
+            <a:ext cx="1188720" cy="640080"/>
+          </a:xfrm>
+          <a:prstGeom prst="roundRect">
+            <a:avLst>
+              <a:gd name="adj" fmla="val 11429"/>
+            </a:avLst>
+          </a:prstGeom>
+          <a:solidFill>
+            <a:srgbClr val="635BFF"/>
+          </a:solidFill>
+          <a:ln w="19050">
+            <a:solidFill>
+              <a:srgbClr val="635BFF"/>
+            </a:solidFill>
+            <a:prstDash val="solid"/>
+          </a:ln>
+        </p:spPr>
+      </p:sp>
+      <p:sp>
+        <p:nvSpPr>
+          <p:cNvPr id="10" name="Text 8"/>
+          <p:cNvSpPr/>
+          <p:nvPr/>
+        </p:nvSpPr>
+        <p:spPr>
+          <a:xfrm>
+            <a:off x="2715768" y="2011680"/>
+            <a:ext cx="1188720" cy="640080"/>
+          </a:xfrm>
+          <a:prstGeom prst="rect">
+            <a:avLst/>
+          </a:prstGeom>
+          <a:noFill/>
+          <a:ln/>
+        </p:spPr>
+        <p:txBody>
+          <a:bodyPr wrap="square" lIns="0" tIns="0" rIns="0" bIns="0" rtlCol="0" anchor="ctr">
+            <a:normAutofit/>
+          </a:bodyPr>
+          <a:lstStyle/>
+          <a:p>
+            <a:pPr algn="ctr" indent="0" marL="0">
+              <a:buNone/>
+            </a:pPr>
+            <a:r>
+              <a:rPr lang="en-US" sz="1100" b="1" dirty="0">
                 <a:solidFill>
                   <a:srgbClr val="FFFFFF"/>
                 </a:solidFill>
-                <a:latin typeface="Georgia" pitchFamily="34" charset="0"/>
-                <a:ea typeface="Georgia" pitchFamily="34" charset="-122"/>
-                <a:cs typeface="Georgia" pitchFamily="34" charset="-120"/>
-              </a:rPr>
-              <a:t>what the AI knew</a:t>
-            </a:r>
-            <a:endParaRPr lang="en-US" sz="4800" dirty="0"/>
+                <a:latin typeface="Verdana" pitchFamily="34" charset="0"/>
+                <a:ea typeface="Verdana" pitchFamily="34" charset="-122"/>
+                <a:cs typeface="Verdana" pitchFamily="34" charset="-120"/>
+              </a:rPr>
+              <a:t>Whisperer</a:t>
+            </a:r>
+            <a:endParaRPr lang="en-US" sz="1100" dirty="0"/>
+          </a:p>
+        </p:txBody>
+      </p:sp>
+      <p:sp>
+        <p:nvSpPr>
+          <p:cNvPr id="11" name="Text 9"/>
+          <p:cNvSpPr/>
+          <p:nvPr/>
+        </p:nvSpPr>
+        <p:spPr>
+          <a:xfrm>
+            <a:off x="3904488" y="2011680"/>
+            <a:ext cx="73152" cy="640080"/>
+          </a:xfrm>
+          <a:prstGeom prst="rect">
+            <a:avLst/>
+          </a:prstGeom>
+          <a:noFill/>
+          <a:ln/>
+        </p:spPr>
+        <p:txBody>
+          <a:bodyPr wrap="square" lIns="0" tIns="0" rIns="0" bIns="0" rtlCol="0" anchor="ctr"/>
+          <a:lstStyle/>
+          <a:p>
+            <a:pPr algn="ctr" indent="0" marL="0">
+              <a:buNone/>
+            </a:pPr>
+            <a:r>
+              <a:rPr lang="en-US" sz="1100" dirty="0">
+                <a:solidFill>
+                  <a:srgbClr val="8B95A5"/>
+                </a:solidFill>
+                <a:latin typeface="Verdana" pitchFamily="34" charset="0"/>
+                <a:ea typeface="Verdana" pitchFamily="34" charset="-122"/>
+                <a:cs typeface="Verdana" pitchFamily="34" charset="-120"/>
+              </a:rPr>
+              <a:t>→</a:t>
+            </a:r>
+            <a:endParaRPr lang="en-US" sz="1100" dirty="0"/>
+          </a:p>
+        </p:txBody>
+      </p:sp>
+      <p:sp>
+        <p:nvSpPr>
+          <p:cNvPr id="12" name="Shape 10"/>
+          <p:cNvSpPr/>
+          <p:nvPr/>
+        </p:nvSpPr>
+        <p:spPr>
+          <a:xfrm>
+            <a:off x="3977640" y="2011680"/>
+            <a:ext cx="1188720" cy="640080"/>
+          </a:xfrm>
+          <a:prstGeom prst="roundRect">
+            <a:avLst>
+              <a:gd name="adj" fmla="val 11429"/>
+            </a:avLst>
+          </a:prstGeom>
+          <a:solidFill>
+            <a:srgbClr val="0A2540">
+              <a:alpha val="50000"/>
+            </a:srgbClr>
+          </a:solidFill>
+          <a:ln w="19050">
+            <a:solidFill>
+              <a:srgbClr val="8B95A5"/>
+            </a:solidFill>
+            <a:prstDash val="solid"/>
+          </a:ln>
+        </p:spPr>
+      </p:sp>
+      <p:sp>
+        <p:nvSpPr>
+          <p:cNvPr id="13" name="Text 11"/>
+          <p:cNvSpPr/>
+          <p:nvPr/>
+        </p:nvSpPr>
+        <p:spPr>
+          <a:xfrm>
+            <a:off x="3977640" y="2011680"/>
+            <a:ext cx="1188720" cy="640080"/>
+          </a:xfrm>
+          <a:prstGeom prst="rect">
+            <a:avLst/>
+          </a:prstGeom>
+          <a:noFill/>
+          <a:ln/>
+        </p:spPr>
+        <p:txBody>
+          <a:bodyPr wrap="square" lIns="0" tIns="0" rIns="0" bIns="0" rtlCol="0" anchor="ctr">
+            <a:normAutofit/>
+          </a:bodyPr>
+          <a:lstStyle/>
+          <a:p>
+            <a:pPr algn="ctr" indent="0" marL="0">
+              <a:buNone/>
+            </a:pPr>
+            <a:r>
+              <a:rPr lang="en-US" sz="1100" b="1" dirty="0">
+                <a:solidFill>
+                  <a:srgbClr val="8B95A5"/>
+                </a:solidFill>
+                <a:latin typeface="Verdana" pitchFamily="34" charset="0"/>
+                <a:ea typeface="Verdana" pitchFamily="34" charset="-122"/>
+                <a:cs typeface="Verdana" pitchFamily="34" charset="-120"/>
+              </a:rPr>
+              <a:t>Strategist</a:t>
+            </a:r>
+            <a:endParaRPr lang="en-US" sz="1100" dirty="0"/>
+          </a:p>
+        </p:txBody>
+      </p:sp>
+      <p:sp>
+        <p:nvSpPr>
+          <p:cNvPr id="14" name="Text 12"/>
+          <p:cNvSpPr/>
+          <p:nvPr/>
+        </p:nvSpPr>
+        <p:spPr>
+          <a:xfrm>
+            <a:off x="5166360" y="2011680"/>
+            <a:ext cx="73152" cy="640080"/>
+          </a:xfrm>
+          <a:prstGeom prst="rect">
+            <a:avLst/>
+          </a:prstGeom>
+          <a:noFill/>
+          <a:ln/>
+        </p:spPr>
+        <p:txBody>
+          <a:bodyPr wrap="square" lIns="0" tIns="0" rIns="0" bIns="0" rtlCol="0" anchor="ctr"/>
+          <a:lstStyle/>
+          <a:p>
+            <a:pPr algn="ctr" indent="0" marL="0">
+              <a:buNone/>
+            </a:pPr>
+            <a:r>
+              <a:rPr lang="en-US" sz="1100" dirty="0">
+                <a:solidFill>
+                  <a:srgbClr val="8B95A5"/>
+                </a:solidFill>
+                <a:latin typeface="Verdana" pitchFamily="34" charset="0"/>
+                <a:ea typeface="Verdana" pitchFamily="34" charset="-122"/>
+                <a:cs typeface="Verdana" pitchFamily="34" charset="-120"/>
+              </a:rPr>
+              <a:t>→</a:t>
+            </a:r>
+            <a:endParaRPr lang="en-US" sz="1100" dirty="0"/>
+          </a:p>
+        </p:txBody>
+      </p:sp>
+      <p:sp>
+        <p:nvSpPr>
+          <p:cNvPr id="15" name="Shape 13"/>
+          <p:cNvSpPr/>
+          <p:nvPr/>
+        </p:nvSpPr>
+        <p:spPr>
+          <a:xfrm>
+            <a:off x="5239512" y="2011680"/>
+            <a:ext cx="1188720" cy="640080"/>
+          </a:xfrm>
+          <a:prstGeom prst="roundRect">
+            <a:avLst>
+              <a:gd name="adj" fmla="val 11429"/>
+            </a:avLst>
+          </a:prstGeom>
+          <a:solidFill>
+            <a:srgbClr val="0A2540">
+              <a:alpha val="50000"/>
+            </a:srgbClr>
+          </a:solidFill>
+          <a:ln w="19050">
+            <a:solidFill>
+              <a:srgbClr val="8B95A5"/>
+            </a:solidFill>
+            <a:prstDash val="solid"/>
+          </a:ln>
+        </p:spPr>
+      </p:sp>
+      <p:sp>
+        <p:nvSpPr>
+          <p:cNvPr id="16" name="Text 14"/>
+          <p:cNvSpPr/>
+          <p:nvPr/>
+        </p:nvSpPr>
+        <p:spPr>
+          <a:xfrm>
+            <a:off x="5239512" y="2011680"/>
+            <a:ext cx="1188720" cy="640080"/>
+          </a:xfrm>
+          <a:prstGeom prst="rect">
+            <a:avLst/>
+          </a:prstGeom>
+          <a:noFill/>
+          <a:ln/>
+        </p:spPr>
+        <p:txBody>
+          <a:bodyPr wrap="square" lIns="0" tIns="0" rIns="0" bIns="0" rtlCol="0" anchor="ctr">
+            <a:normAutofit/>
+          </a:bodyPr>
+          <a:lstStyle/>
+          <a:p>
+            <a:pPr algn="ctr" indent="0" marL="0">
+              <a:buNone/>
+            </a:pPr>
+            <a:r>
+              <a:rPr lang="en-US" sz="1100" b="1" dirty="0">
+                <a:solidFill>
+                  <a:srgbClr val="8B95A5"/>
+                </a:solidFill>
+                <a:latin typeface="Verdana" pitchFamily="34" charset="0"/>
+                <a:ea typeface="Verdana" pitchFamily="34" charset="-122"/>
+                <a:cs typeface="Verdana" pitchFamily="34" charset="-120"/>
+              </a:rPr>
+              <a:t>Operator</a:t>
+            </a:r>
+            <a:endParaRPr lang="en-US" sz="1100" dirty="0"/>
+          </a:p>
+        </p:txBody>
+      </p:sp>
+      <p:sp>
+        <p:nvSpPr>
+          <p:cNvPr id="17" name="Text 15"/>
+          <p:cNvSpPr/>
+          <p:nvPr/>
+        </p:nvSpPr>
+        <p:spPr>
+          <a:xfrm>
+            <a:off x="6428232" y="2011680"/>
+            <a:ext cx="73152" cy="640080"/>
+          </a:xfrm>
+          <a:prstGeom prst="rect">
+            <a:avLst/>
+          </a:prstGeom>
+          <a:noFill/>
+          <a:ln/>
+        </p:spPr>
+        <p:txBody>
+          <a:bodyPr wrap="square" lIns="0" tIns="0" rIns="0" bIns="0" rtlCol="0" anchor="ctr"/>
+          <a:lstStyle/>
+          <a:p>
+            <a:pPr algn="ctr" indent="0" marL="0">
+              <a:buNone/>
+            </a:pPr>
+            <a:r>
+              <a:rPr lang="en-US" sz="1100" dirty="0">
+                <a:solidFill>
+                  <a:srgbClr val="8B95A5"/>
+                </a:solidFill>
+                <a:latin typeface="Verdana" pitchFamily="34" charset="0"/>
+                <a:ea typeface="Verdana" pitchFamily="34" charset="-122"/>
+                <a:cs typeface="Verdana" pitchFamily="34" charset="-120"/>
+              </a:rPr>
+              <a:t>→</a:t>
+            </a:r>
+            <a:endParaRPr lang="en-US" sz="1100" dirty="0"/>
+          </a:p>
+        </p:txBody>
+      </p:sp>
+      <p:sp>
+        <p:nvSpPr>
+          <p:cNvPr id="18" name="Shape 16"/>
+          <p:cNvSpPr/>
+          <p:nvPr/>
+        </p:nvSpPr>
+        <p:spPr>
+          <a:xfrm>
+            <a:off x="6501384" y="2011680"/>
+            <a:ext cx="1188720" cy="640080"/>
+          </a:xfrm>
+          <a:prstGeom prst="roundRect">
+            <a:avLst>
+              <a:gd name="adj" fmla="val 11429"/>
+            </a:avLst>
+          </a:prstGeom>
+          <a:solidFill>
+            <a:srgbClr val="0A2540">
+              <a:alpha val="50000"/>
+            </a:srgbClr>
+          </a:solidFill>
+          <a:ln w="19050">
+            <a:solidFill>
+              <a:srgbClr val="8B95A5"/>
+            </a:solidFill>
+            <a:prstDash val="solid"/>
+          </a:ln>
+        </p:spPr>
+      </p:sp>
+      <p:sp>
+        <p:nvSpPr>
+          <p:cNvPr id="19" name="Text 17"/>
+          <p:cNvSpPr/>
+          <p:nvPr/>
+        </p:nvSpPr>
+        <p:spPr>
+          <a:xfrm>
+            <a:off x="6501384" y="2011680"/>
+            <a:ext cx="1188720" cy="640080"/>
+          </a:xfrm>
+          <a:prstGeom prst="rect">
+            <a:avLst/>
+          </a:prstGeom>
+          <a:noFill/>
+          <a:ln/>
+        </p:spPr>
+        <p:txBody>
+          <a:bodyPr wrap="square" lIns="0" tIns="0" rIns="0" bIns="0" rtlCol="0" anchor="ctr">
+            <a:normAutofit/>
+          </a:bodyPr>
+          <a:lstStyle/>
+          <a:p>
+            <a:pPr algn="ctr" indent="0" marL="0">
+              <a:buNone/>
+            </a:pPr>
+            <a:r>
+              <a:rPr lang="en-US" sz="1100" b="1" dirty="0">
+                <a:solidFill>
+                  <a:srgbClr val="8B95A5"/>
+                </a:solidFill>
+                <a:latin typeface="Verdana" pitchFamily="34" charset="0"/>
+                <a:ea typeface="Verdana" pitchFamily="34" charset="-122"/>
+                <a:cs typeface="Verdana" pitchFamily="34" charset="-120"/>
+              </a:rPr>
+              <a:t>Orchestrator</a:t>
+            </a:r>
+            <a:endParaRPr lang="en-US" sz="1100" dirty="0"/>
+          </a:p>
+        </p:txBody>
+      </p:sp>
+      <p:sp>
+        <p:nvSpPr>
+          <p:cNvPr id="20" name="Text 18"/>
+          <p:cNvSpPr/>
+          <p:nvPr/>
+        </p:nvSpPr>
+        <p:spPr>
+          <a:xfrm>
+            <a:off x="7690104" y="2011680"/>
+            <a:ext cx="73152" cy="640080"/>
+          </a:xfrm>
+          <a:prstGeom prst="rect">
+            <a:avLst/>
+          </a:prstGeom>
+          <a:noFill/>
+          <a:ln/>
+        </p:spPr>
+        <p:txBody>
+          <a:bodyPr wrap="square" lIns="0" tIns="0" rIns="0" bIns="0" rtlCol="0" anchor="ctr"/>
+          <a:lstStyle/>
+          <a:p>
+            <a:pPr algn="ctr" indent="0" marL="0">
+              <a:buNone/>
+            </a:pPr>
+            <a:r>
+              <a:rPr lang="en-US" sz="1100" dirty="0">
+                <a:solidFill>
+                  <a:srgbClr val="8B95A5"/>
+                </a:solidFill>
+                <a:latin typeface="Verdana" pitchFamily="34" charset="0"/>
+                <a:ea typeface="Verdana" pitchFamily="34" charset="-122"/>
+                <a:cs typeface="Verdana" pitchFamily="34" charset="-120"/>
+              </a:rPr>
+              <a:t>→</a:t>
+            </a:r>
+            <a:endParaRPr lang="en-US" sz="1100" dirty="0"/>
+          </a:p>
+        </p:txBody>
+      </p:sp>
+      <p:sp>
+        <p:nvSpPr>
+          <p:cNvPr id="21" name="Shape 19"/>
+          <p:cNvSpPr/>
+          <p:nvPr/>
+        </p:nvSpPr>
+        <p:spPr>
+          <a:xfrm>
+            <a:off x="7763256" y="2011680"/>
+            <a:ext cx="1188720" cy="640080"/>
+          </a:xfrm>
+          <a:prstGeom prst="roundRect">
+            <a:avLst>
+              <a:gd name="adj" fmla="val 11429"/>
+            </a:avLst>
+          </a:prstGeom>
+          <a:solidFill>
+            <a:srgbClr val="0A2540">
+              <a:alpha val="50000"/>
+            </a:srgbClr>
+          </a:solidFill>
+          <a:ln w="19050">
+            <a:solidFill>
+              <a:srgbClr val="8B95A5"/>
+            </a:solidFill>
+            <a:prstDash val="dash"/>
+          </a:ln>
+        </p:spPr>
+      </p:sp>
+      <p:sp>
+        <p:nvSpPr>
+          <p:cNvPr id="22" name="Text 20"/>
+          <p:cNvSpPr/>
+          <p:nvPr/>
+        </p:nvSpPr>
+        <p:spPr>
+          <a:xfrm>
+            <a:off x="7763256" y="2011680"/>
+            <a:ext cx="1188720" cy="640080"/>
+          </a:xfrm>
+          <a:prstGeom prst="rect">
+            <a:avLst/>
+          </a:prstGeom>
+          <a:noFill/>
+          <a:ln/>
+        </p:spPr>
+        <p:txBody>
+          <a:bodyPr wrap="square" lIns="0" tIns="0" rIns="0" bIns="0" rtlCol="0" anchor="ctr">
+            <a:normAutofit/>
+          </a:bodyPr>
+          <a:lstStyle/>
+          <a:p>
+            <a:pPr algn="ctr" indent="0" marL="0">
+              <a:buNone/>
+            </a:pPr>
+            <a:r>
+              <a:rPr lang="en-US" sz="1100" b="1" dirty="0">
+                <a:solidFill>
+                  <a:srgbClr val="8B95A5"/>
+                </a:solidFill>
+                <a:latin typeface="Verdana" pitchFamily="34" charset="0"/>
+                <a:ea typeface="Verdana" pitchFamily="34" charset="-122"/>
+                <a:cs typeface="Verdana" pitchFamily="34" charset="-120"/>
+              </a:rPr>
+              <a:t>Builder</a:t>
+            </a:r>
+            <a:endParaRPr lang="en-US" sz="1100" dirty="0"/>
           </a:p>
         </p:txBody>
       </p:sp>
@@ -5159,8 +5912,8 @@
         </p:nvSpPr>
         <p:spPr>
           <a:xfrm>
-            <a:off x="914400" y="914400"/>
-            <a:ext cx="7315200" cy="3291840"/>
+            <a:off x="914400" y="1097280"/>
+            <a:ext cx="7315200" cy="2560320"/>
           </a:xfrm>
           <a:prstGeom prst="rect">
             <a:avLst/>
@@ -5176,51 +5929,34 @@
               <a:buNone/>
             </a:pPr>
             <a:r>
-              <a:rPr lang="en-US" sz="2800" b="1" dirty="0">
-                <a:solidFill>
-                  <a:srgbClr val="635BFF"/>
+              <a:rPr lang="en-US" sz="4800" b="1" dirty="0">
+                <a:solidFill>
+                  <a:srgbClr val="FFFFFF"/>
                 </a:solidFill>
                 <a:latin typeface="Georgia" pitchFamily="34" charset="0"/>
                 <a:ea typeface="Georgia" pitchFamily="34" charset="-122"/>
                 <a:cs typeface="Georgia" pitchFamily="34" charset="-120"/>
               </a:rPr>
-              <a:t>Add 3–4 sentences of real context:</a:t>
-            </a:r>
-            <a:endParaRPr lang="en-US" sz="2800" dirty="0"/>
+              <a:t>We never changed</a:t>
+            </a:r>
+            <a:endParaRPr lang="en-US" sz="4800" dirty="0"/>
           </a:p>
           <a:p>
             <a:pPr algn="ctr" indent="0" marL="0">
               <a:buNone/>
             </a:pPr>
             <a:r>
-              <a:rPr lang="en-US" sz="3600" b="1" dirty="0">
-                <a:solidFill>
-                  <a:srgbClr val="635BFF"/>
+              <a:rPr lang="en-US" sz="4800" b="1" dirty="0">
+                <a:solidFill>
+                  <a:srgbClr val="FFFFFF"/>
                 </a:solidFill>
                 <a:latin typeface="Georgia" pitchFamily="34" charset="0"/>
                 <a:ea typeface="Georgia" pitchFamily="34" charset="-122"/>
                 <a:cs typeface="Georgia" pitchFamily="34" charset="-120"/>
               </a:rPr>
-              <a:t>Equipment. Tea types.</a:t>
-            </a:r>
-            <a:endParaRPr lang="en-US" sz="2800" dirty="0"/>
-          </a:p>
-          <a:p>
-            <a:pPr algn="ctr" indent="0" marL="0">
-              <a:buNone/>
-            </a:pPr>
-            <a:r>
-              <a:rPr lang="en-US" sz="3600" b="1" dirty="0">
-                <a:solidFill>
-                  <a:srgbClr val="635BFF"/>
-                </a:solidFill>
-                <a:latin typeface="Georgia" pitchFamily="34" charset="0"/>
-                <a:ea typeface="Georgia" pitchFamily="34" charset="-122"/>
-                <a:cs typeface="Georgia" pitchFamily="34" charset="-120"/>
-              </a:rPr>
-              <a:t>Team preferences. Who's it for.</a:t>
-            </a:r>
-            <a:endParaRPr lang="en-US" sz="2800" dirty="0"/>
+              <a:t>what the AI knew</a:t>
+            </a:r>
+            <a:endParaRPr lang="en-US" sz="4800" dirty="0"/>
           </a:p>
         </p:txBody>
       </p:sp>
@@ -5278,40 +6014,16 @@
           <a:ln/>
         </p:spPr>
       </p:sp>
-      <p:pic>
-        <p:nvPicPr>
-          <p:cNvPr id="3" name="Image 0" descr="/Users/michaelengland/Developer/michaelengland/ai-best-practices/decks/ai-best-practices/assets/blue-tang-transparent.png">    </p:cNvPr>
-          <p:cNvPicPr>
-            <a:picLocks noChangeAspect="1"/>
-          </p:cNvPicPr>
-          <p:nvPr/>
-        </p:nvPicPr>
-        <p:blipFill>
-          <a:blip r:embed="rId1"/>
-          <a:stretch>
-            <a:fillRect/>
-          </a:stretch>
-        </p:blipFill>
-        <p:spPr>
-          <a:xfrm>
-            <a:off x="274320" y="457200"/>
-            <a:ext cx="3840480" cy="3840480"/>
-          </a:xfrm>
-          <a:prstGeom prst="rect">
-            <a:avLst/>
-          </a:prstGeom>
-        </p:spPr>
-      </p:pic>
-      <p:sp>
-        <p:nvSpPr>
-          <p:cNvPr id="4" name="Text 1"/>
-          <p:cNvSpPr/>
-          <p:nvPr/>
-        </p:nvSpPr>
-        <p:spPr>
-          <a:xfrm>
-            <a:off x="4572000" y="1371600"/>
-            <a:ext cx="4114800" cy="2286000"/>
+      <p:sp>
+        <p:nvSpPr>
+          <p:cNvPr id="3" name="Text 1"/>
+          <p:cNvSpPr/>
+          <p:nvPr/>
+        </p:nvSpPr>
+        <p:spPr>
+          <a:xfrm>
+            <a:off x="914400" y="914400"/>
+            <a:ext cx="7315200" cy="3291840"/>
           </a:xfrm>
           <a:prstGeom prst="rect">
             <a:avLst/>
@@ -5323,38 +6035,55 @@
           <a:bodyPr wrap="square" lIns="0" tIns="0" rIns="0" bIns="0" rtlCol="0" anchor="ctr"/>
           <a:lstStyle/>
           <a:p>
-            <a:pPr algn="l" indent="0" marL="0">
-              <a:buNone/>
-            </a:pPr>
-            <a:r>
-              <a:rPr lang="en-US" sz="4400" b="1" dirty="0">
-                <a:solidFill>
-                  <a:srgbClr val="FFFFFF"/>
+            <a:pPr algn="ctr" indent="0" marL="0">
+              <a:buNone/>
+            </a:pPr>
+            <a:r>
+              <a:rPr lang="en-US" sz="2800" b="1" dirty="0">
+                <a:solidFill>
+                  <a:srgbClr val="635BFF"/>
                 </a:solidFill>
                 <a:latin typeface="Georgia" pitchFamily="34" charset="0"/>
                 <a:ea typeface="Georgia" pitchFamily="34" charset="-122"/>
                 <a:cs typeface="Georgia" pitchFamily="34" charset="-120"/>
               </a:rPr>
-              <a:t>Brilliant. Helpful.</a:t>
-            </a:r>
-            <a:endParaRPr lang="en-US" sz="4400" dirty="0"/>
-          </a:p>
-          <a:p>
-            <a:pPr algn="l" indent="0" marL="0">
-              <a:buNone/>
-            </a:pPr>
-            <a:r>
-              <a:rPr lang="en-US" sz="4400" b="1" dirty="0">
-                <a:solidFill>
-                  <a:srgbClr val="FFFFFF"/>
+              <a:t>Add 3–4 sentences of real context:</a:t>
+            </a:r>
+            <a:endParaRPr lang="en-US" sz="2800" dirty="0"/>
+          </a:p>
+          <a:p>
+            <a:pPr algn="ctr" indent="0" marL="0">
+              <a:buNone/>
+            </a:pPr>
+            <a:r>
+              <a:rPr lang="en-US" sz="3600" b="1" dirty="0">
+                <a:solidFill>
+                  <a:srgbClr val="635BFF"/>
                 </a:solidFill>
                 <a:latin typeface="Georgia" pitchFamily="34" charset="0"/>
                 <a:ea typeface="Georgia" pitchFamily="34" charset="-122"/>
                 <a:cs typeface="Georgia" pitchFamily="34" charset="-120"/>
               </a:rPr>
-              <a:t>Remembers nothing.</a:t>
-            </a:r>
-            <a:endParaRPr lang="en-US" sz="4400" dirty="0"/>
+              <a:t>Equipment. Tea types.</a:t>
+            </a:r>
+            <a:endParaRPr lang="en-US" sz="2800" dirty="0"/>
+          </a:p>
+          <a:p>
+            <a:pPr algn="ctr" indent="0" marL="0">
+              <a:buNone/>
+            </a:pPr>
+            <a:r>
+              <a:rPr lang="en-US" sz="3600" b="1" dirty="0">
+                <a:solidFill>
+                  <a:srgbClr val="635BFF"/>
+                </a:solidFill>
+                <a:latin typeface="Georgia" pitchFamily="34" charset="0"/>
+                <a:ea typeface="Georgia" pitchFamily="34" charset="-122"/>
+                <a:cs typeface="Georgia" pitchFamily="34" charset="-120"/>
+              </a:rPr>
+              <a:t>Team preferences. Who's it for.</a:t>
+            </a:r>
+            <a:endParaRPr lang="en-US" sz="2800" dirty="0"/>
           </a:p>
         </p:txBody>
       </p:sp>
@@ -6138,8 +6867,8 @@
         </p:nvSpPr>
         <p:spPr>
           <a:xfrm>
-            <a:off x="1371600" y="3108960"/>
-            <a:ext cx="6400800" cy="548640"/>
+            <a:off x="914400" y="3108960"/>
+            <a:ext cx="7315200" cy="548640"/>
           </a:xfrm>
           <a:prstGeom prst="rect">
             <a:avLst/>
@@ -6223,16 +6952,40 @@
           <a:ln/>
         </p:spPr>
       </p:sp>
-      <p:sp>
-        <p:nvSpPr>
-          <p:cNvPr id="3" name="Text 1"/>
-          <p:cNvSpPr/>
-          <p:nvPr/>
-        </p:nvSpPr>
-        <p:spPr>
-          <a:xfrm>
-            <a:off x="914400" y="914400"/>
-            <a:ext cx="7315200" cy="3291840"/>
+      <p:pic>
+        <p:nvPicPr>
+          <p:cNvPr id="3" name="Image 0" descr="/Users/michaelengland/Developer/michaelengland/ai-best-practices/decks/ai-best-practices/assets/blue-tang-transparent.png">    </p:cNvPr>
+          <p:cNvPicPr>
+            <a:picLocks noChangeAspect="1"/>
+          </p:cNvPicPr>
+          <p:nvPr/>
+        </p:nvPicPr>
+        <p:blipFill>
+          <a:blip r:embed="rId1"/>
+          <a:stretch>
+            <a:fillRect/>
+          </a:stretch>
+        </p:blipFill>
+        <p:spPr>
+          <a:xfrm>
+            <a:off x="274320" y="457200"/>
+            <a:ext cx="3840480" cy="3840480"/>
+          </a:xfrm>
+          <a:prstGeom prst="rect">
+            <a:avLst/>
+          </a:prstGeom>
+        </p:spPr>
+      </p:pic>
+      <p:sp>
+        <p:nvSpPr>
+          <p:cNvPr id="4" name="Text 1"/>
+          <p:cNvSpPr/>
+          <p:nvPr/>
+        </p:nvSpPr>
+        <p:spPr>
+          <a:xfrm>
+            <a:off x="4572000" y="1371600"/>
+            <a:ext cx="4114800" cy="2286000"/>
           </a:xfrm>
           <a:prstGeom prst="rect">
             <a:avLst/>
@@ -6244,72 +6997,38 @@
           <a:bodyPr wrap="square" lIns="0" tIns="0" rIns="0" bIns="0" rtlCol="0" anchor="ctr"/>
           <a:lstStyle/>
           <a:p>
-            <a:pPr algn="ctr" indent="0" marL="0">
-              <a:buNone/>
-            </a:pPr>
-            <a:r>
-              <a:rPr lang="en-US" sz="2800" b="1" dirty="0">
-                <a:solidFill>
-                  <a:srgbClr val="635BFF"/>
+            <a:pPr algn="l" indent="0" marL="0">
+              <a:buNone/>
+            </a:pPr>
+            <a:r>
+              <a:rPr lang="en-US" sz="4400" b="1" dirty="0">
+                <a:solidFill>
+                  <a:srgbClr val="FFFFFF"/>
                 </a:solidFill>
                 <a:latin typeface="Georgia" pitchFamily="34" charset="0"/>
                 <a:ea typeface="Georgia" pitchFamily="34" charset="-122"/>
                 <a:cs typeface="Georgia" pitchFamily="34" charset="-120"/>
               </a:rPr>
-              <a:t>Add to your prompt:</a:t>
-            </a:r>
-            <a:endParaRPr lang="en-US" sz="2800" dirty="0"/>
-          </a:p>
-          <a:p>
-            <a:pPr algn="ctr" indent="0" marL="0">
-              <a:buNone/>
-            </a:pPr>
-            <a:r>
-              <a:rPr lang="en-US" sz="3600" b="1" dirty="0">
-                <a:solidFill>
-                  <a:srgbClr val="635BFF"/>
+              <a:t>Brilliant. Helpful.</a:t>
+            </a:r>
+            <a:endParaRPr lang="en-US" sz="4400" dirty="0"/>
+          </a:p>
+          <a:p>
+            <a:pPr algn="l" indent="0" marL="0">
+              <a:buNone/>
+            </a:pPr>
+            <a:r>
+              <a:rPr lang="en-US" sz="4400" b="1" dirty="0">
+                <a:solidFill>
+                  <a:srgbClr val="FFFFFF"/>
                 </a:solidFill>
                 <a:latin typeface="Georgia" pitchFamily="34" charset="0"/>
                 <a:ea typeface="Georgia" pitchFamily="34" charset="-122"/>
                 <a:cs typeface="Georgia" pitchFamily="34" charset="-120"/>
               </a:rPr>
-              <a:t>"Before you start, ask me</a:t>
-            </a:r>
-            <a:endParaRPr lang="en-US" sz="2800" dirty="0"/>
-          </a:p>
-          <a:p>
-            <a:pPr algn="ctr" indent="0" marL="0">
-              <a:buNone/>
-            </a:pPr>
-            <a:r>
-              <a:rPr lang="en-US" sz="3600" b="1" dirty="0">
-                <a:solidFill>
-                  <a:srgbClr val="635BFF"/>
-                </a:solidFill>
-                <a:latin typeface="Georgia" pitchFamily="34" charset="0"/>
-                <a:ea typeface="Georgia" pitchFamily="34" charset="-122"/>
-                <a:cs typeface="Georgia" pitchFamily="34" charset="-120"/>
-              </a:rPr>
-              <a:t>clarifying questions about</a:t>
-            </a:r>
-            <a:endParaRPr lang="en-US" sz="2800" dirty="0"/>
-          </a:p>
-          <a:p>
-            <a:pPr algn="ctr" indent="0" marL="0">
-              <a:buNone/>
-            </a:pPr>
-            <a:r>
-              <a:rPr lang="en-US" sz="3600" b="1" dirty="0">
-                <a:solidFill>
-                  <a:srgbClr val="635BFF"/>
-                </a:solidFill>
-                <a:latin typeface="Georgia" pitchFamily="34" charset="0"/>
-                <a:ea typeface="Georgia" pitchFamily="34" charset="-122"/>
-                <a:cs typeface="Georgia" pitchFamily="34" charset="-120"/>
-              </a:rPr>
-              <a:t>anything you'd need to know."</a:t>
-            </a:r>
-            <a:endParaRPr lang="en-US" sz="2800" dirty="0"/>
+              <a:t>Remembers nothing.</a:t>
+            </a:r>
+            <a:endParaRPr lang="en-US" sz="4400" dirty="0"/>
           </a:p>
         </p:txBody>
       </p:sp>
@@ -6375,8 +7094,8 @@
         </p:nvSpPr>
         <p:spPr>
           <a:xfrm>
-            <a:off x="914400" y="1097280"/>
-            <a:ext cx="7315200" cy="2560320"/>
+            <a:off x="914400" y="914400"/>
+            <a:ext cx="7315200" cy="3291840"/>
           </a:xfrm>
           <a:prstGeom prst="rect">
             <a:avLst/>
@@ -6392,34 +7111,68 @@
               <a:buNone/>
             </a:pPr>
             <a:r>
-              <a:rPr lang="en-US" sz="4400" b="1" dirty="0">
-                <a:solidFill>
-                  <a:srgbClr val="FFFFFF"/>
+              <a:rPr lang="en-US" sz="2800" b="1" dirty="0">
+                <a:solidFill>
+                  <a:srgbClr val="635BFF"/>
                 </a:solidFill>
                 <a:latin typeface="Georgia" pitchFamily="34" charset="0"/>
                 <a:ea typeface="Georgia" pitchFamily="34" charset="-122"/>
                 <a:cs typeface="Georgia" pitchFamily="34" charset="-120"/>
               </a:rPr>
-              <a:t>Next conversation?</a:t>
-            </a:r>
-            <a:endParaRPr lang="en-US" sz="4400" dirty="0"/>
+              <a:t>Add to your prompt:</a:t>
+            </a:r>
+            <a:endParaRPr lang="en-US" sz="2800" dirty="0"/>
           </a:p>
           <a:p>
             <a:pPr algn="ctr" indent="0" marL="0">
               <a:buNone/>
             </a:pPr>
             <a:r>
-              <a:rPr lang="en-US" sz="4400" b="1" dirty="0">
-                <a:solidFill>
-                  <a:srgbClr val="FFFFFF"/>
+              <a:rPr lang="en-US" sz="3600" b="1" dirty="0">
+                <a:solidFill>
+                  <a:srgbClr val="635BFF"/>
                 </a:solidFill>
                 <a:latin typeface="Georgia" pitchFamily="34" charset="0"/>
                 <a:ea typeface="Georgia" pitchFamily="34" charset="-122"/>
                 <a:cs typeface="Georgia" pitchFamily="34" charset="-120"/>
               </a:rPr>
-              <a:t>You'll type it all again.</a:t>
-            </a:r>
-            <a:endParaRPr lang="en-US" sz="4400" dirty="0"/>
+              <a:t>"Before you start, ask me</a:t>
+            </a:r>
+            <a:endParaRPr lang="en-US" sz="2800" dirty="0"/>
+          </a:p>
+          <a:p>
+            <a:pPr algn="ctr" indent="0" marL="0">
+              <a:buNone/>
+            </a:pPr>
+            <a:r>
+              <a:rPr lang="en-US" sz="3600" b="1" dirty="0">
+                <a:solidFill>
+                  <a:srgbClr val="635BFF"/>
+                </a:solidFill>
+                <a:latin typeface="Georgia" pitchFamily="34" charset="0"/>
+                <a:ea typeface="Georgia" pitchFamily="34" charset="-122"/>
+                <a:cs typeface="Georgia" pitchFamily="34" charset="-120"/>
+              </a:rPr>
+              <a:t>clarifying questions about</a:t>
+            </a:r>
+            <a:endParaRPr lang="en-US" sz="2800" dirty="0"/>
+          </a:p>
+          <a:p>
+            <a:pPr algn="ctr" indent="0" marL="0">
+              <a:buNone/>
+            </a:pPr>
+            <a:r>
+              <a:rPr lang="en-US" sz="3600" b="1" dirty="0">
+                <a:solidFill>
+                  <a:srgbClr val="635BFF"/>
+                </a:solidFill>
+                <a:latin typeface="Georgia" pitchFamily="34" charset="0"/>
+                <a:ea typeface="Georgia" pitchFamily="34" charset="-122"/>
+                <a:cs typeface="Georgia" pitchFamily="34" charset="-120"/>
+              </a:rPr>
+              <a:t>anything you'd need to know."</a:t>
+            </a:r>
+            <a:endParaRPr lang="en-US" sz="2800" dirty="0"/>
           </a:p>
         </p:txBody>
       </p:sp>
@@ -6479,41 +7232,14 @@
       </p:sp>
       <p:sp>
         <p:nvSpPr>
-          <p:cNvPr id="3" name="Shape 1"/>
-          <p:cNvSpPr/>
-          <p:nvPr/>
-        </p:nvSpPr>
-        <p:spPr>
-          <a:xfrm>
-            <a:off x="274320" y="2011680"/>
-            <a:ext cx="2560320" cy="914400"/>
-          </a:xfrm>
-          <a:prstGeom prst="roundRect">
-            <a:avLst>
-              <a:gd name="adj" fmla="val 10000"/>
-            </a:avLst>
-          </a:prstGeom>
-          <a:solidFill>
-            <a:srgbClr val="0A2540"/>
-          </a:solidFill>
-          <a:ln w="25400">
-            <a:solidFill>
-              <a:srgbClr val="635BFF"/>
-            </a:solidFill>
-            <a:prstDash val="solid"/>
-          </a:ln>
-        </p:spPr>
-      </p:sp>
-      <p:sp>
-        <p:nvSpPr>
-          <p:cNvPr id="4" name="Text 2"/>
-          <p:cNvSpPr/>
-          <p:nvPr/>
-        </p:nvSpPr>
-        <p:spPr>
-          <a:xfrm>
-            <a:off x="274320" y="2011680"/>
-            <a:ext cx="2560320" cy="914400"/>
+          <p:cNvPr id="3" name="Text 1"/>
+          <p:cNvSpPr/>
+          <p:nvPr/>
+        </p:nvSpPr>
+        <p:spPr>
+          <a:xfrm>
+            <a:off x="914400" y="1097280"/>
+            <a:ext cx="7315200" cy="2560320"/>
           </a:xfrm>
           <a:prstGeom prst="rect">
             <a:avLst/>
@@ -6529,227 +7255,34 @@
               <a:buNone/>
             </a:pPr>
             <a:r>
-              <a:rPr lang="en-US" sz="1800" b="1" dirty="0">
+              <a:rPr lang="en-US" sz="4400" b="1" dirty="0">
                 <a:solidFill>
                   <a:srgbClr val="FFFFFF"/>
                 </a:solidFill>
-                <a:latin typeface="Verdana" pitchFamily="34" charset="0"/>
-                <a:ea typeface="Verdana" pitchFamily="34" charset="-122"/>
-                <a:cs typeface="Verdana" pitchFamily="34" charset="-120"/>
-              </a:rPr>
-              <a:t>Settings</a:t>
-            </a:r>
-            <a:endParaRPr lang="en-US" sz="1800" dirty="0"/>
-          </a:p>
-        </p:txBody>
-      </p:sp>
-      <p:sp>
-        <p:nvSpPr>
-          <p:cNvPr id="5" name="Text 3"/>
-          <p:cNvSpPr/>
-          <p:nvPr/>
-        </p:nvSpPr>
-        <p:spPr>
-          <a:xfrm>
-            <a:off x="2834640" y="2011680"/>
-            <a:ext cx="457200" cy="914400"/>
-          </a:xfrm>
-          <a:prstGeom prst="rect">
-            <a:avLst/>
-          </a:prstGeom>
-          <a:noFill/>
-          <a:ln/>
-        </p:spPr>
-        <p:txBody>
-          <a:bodyPr wrap="square" lIns="0" tIns="0" rIns="0" bIns="0" rtlCol="0" anchor="ctr"/>
-          <a:lstStyle/>
+                <a:latin typeface="Georgia" pitchFamily="34" charset="0"/>
+                <a:ea typeface="Georgia" pitchFamily="34" charset="-122"/>
+                <a:cs typeface="Georgia" pitchFamily="34" charset="-120"/>
+              </a:rPr>
+              <a:t>Next conversation?</a:t>
+            </a:r>
+            <a:endParaRPr lang="en-US" sz="4400" dirty="0"/>
+          </a:p>
           <a:p>
             <a:pPr algn="ctr" indent="0" marL="0">
               <a:buNone/>
             </a:pPr>
             <a:r>
-              <a:rPr lang="en-US" sz="2800" dirty="0">
-                <a:solidFill>
-                  <a:srgbClr val="635BFF"/>
-                </a:solidFill>
-                <a:latin typeface="Verdana" pitchFamily="34" charset="0"/>
-                <a:ea typeface="Verdana" pitchFamily="34" charset="-122"/>
-                <a:cs typeface="Verdana" pitchFamily="34" charset="-120"/>
-              </a:rPr>
-              <a:t>→</a:t>
-            </a:r>
-            <a:endParaRPr lang="en-US" sz="2800" dirty="0"/>
-          </a:p>
-        </p:txBody>
-      </p:sp>
-      <p:sp>
-        <p:nvSpPr>
-          <p:cNvPr id="6" name="Shape 4"/>
-          <p:cNvSpPr/>
-          <p:nvPr/>
-        </p:nvSpPr>
-        <p:spPr>
-          <a:xfrm>
-            <a:off x="3291840" y="2011680"/>
-            <a:ext cx="2560320" cy="914400"/>
-          </a:xfrm>
-          <a:prstGeom prst="roundRect">
-            <a:avLst>
-              <a:gd name="adj" fmla="val 10000"/>
-            </a:avLst>
-          </a:prstGeom>
-          <a:solidFill>
-            <a:srgbClr val="0A2540"/>
-          </a:solidFill>
-          <a:ln w="25400">
-            <a:solidFill>
-              <a:srgbClr val="635BFF"/>
-            </a:solidFill>
-            <a:prstDash val="solid"/>
-          </a:ln>
-        </p:spPr>
-      </p:sp>
-      <p:sp>
-        <p:nvSpPr>
-          <p:cNvPr id="7" name="Text 5"/>
-          <p:cNvSpPr/>
-          <p:nvPr/>
-        </p:nvSpPr>
-        <p:spPr>
-          <a:xfrm>
-            <a:off x="3291840" y="2011680"/>
-            <a:ext cx="2560320" cy="914400"/>
-          </a:xfrm>
-          <a:prstGeom prst="rect">
-            <a:avLst/>
-          </a:prstGeom>
-          <a:noFill/>
-          <a:ln/>
-        </p:spPr>
-        <p:txBody>
-          <a:bodyPr wrap="square" lIns="0" tIns="0" rIns="0" bIns="0" rtlCol="0" anchor="ctr"/>
-          <a:lstStyle/>
-          <a:p>
-            <a:pPr algn="ctr" indent="0" marL="0">
-              <a:buNone/>
-            </a:pPr>
-            <a:r>
-              <a:rPr lang="en-US" sz="1800" b="1" dirty="0">
+              <a:rPr lang="en-US" sz="4400" b="1" dirty="0">
                 <a:solidFill>
                   <a:srgbClr val="FFFFFF"/>
                 </a:solidFill>
-                <a:latin typeface="Verdana" pitchFamily="34" charset="0"/>
-                <a:ea typeface="Verdana" pitchFamily="34" charset="-122"/>
-                <a:cs typeface="Verdana" pitchFamily="34" charset="-120"/>
-              </a:rPr>
-              <a:t>General</a:t>
-            </a:r>
-            <a:endParaRPr lang="en-US" sz="1800" dirty="0"/>
-          </a:p>
-        </p:txBody>
-      </p:sp>
-      <p:sp>
-        <p:nvSpPr>
-          <p:cNvPr id="8" name="Text 6"/>
-          <p:cNvSpPr/>
-          <p:nvPr/>
-        </p:nvSpPr>
-        <p:spPr>
-          <a:xfrm>
-            <a:off x="5852160" y="2011680"/>
-            <a:ext cx="457200" cy="914400"/>
-          </a:xfrm>
-          <a:prstGeom prst="rect">
-            <a:avLst/>
-          </a:prstGeom>
-          <a:noFill/>
-          <a:ln/>
-        </p:spPr>
-        <p:txBody>
-          <a:bodyPr wrap="square" lIns="0" tIns="0" rIns="0" bIns="0" rtlCol="0" anchor="ctr"/>
-          <a:lstStyle/>
-          <a:p>
-            <a:pPr algn="ctr" indent="0" marL="0">
-              <a:buNone/>
-            </a:pPr>
-            <a:r>
-              <a:rPr lang="en-US" sz="2800" dirty="0">
-                <a:solidFill>
-                  <a:srgbClr val="635BFF"/>
-                </a:solidFill>
-                <a:latin typeface="Verdana" pitchFamily="34" charset="0"/>
-                <a:ea typeface="Verdana" pitchFamily="34" charset="-122"/>
-                <a:cs typeface="Verdana" pitchFamily="34" charset="-120"/>
-              </a:rPr>
-              <a:t>→</a:t>
-            </a:r>
-            <a:endParaRPr lang="en-US" sz="2800" dirty="0"/>
-          </a:p>
-        </p:txBody>
-      </p:sp>
-      <p:sp>
-        <p:nvSpPr>
-          <p:cNvPr id="9" name="Shape 7"/>
-          <p:cNvSpPr/>
-          <p:nvPr/>
-        </p:nvSpPr>
-        <p:spPr>
-          <a:xfrm>
-            <a:off x="6309360" y="2011680"/>
-            <a:ext cx="2560320" cy="914400"/>
-          </a:xfrm>
-          <a:prstGeom prst="roundRect">
-            <a:avLst>
-              <a:gd name="adj" fmla="val 10000"/>
-            </a:avLst>
-          </a:prstGeom>
-          <a:solidFill>
-            <a:srgbClr val="0A2540"/>
-          </a:solidFill>
-          <a:ln w="25400">
-            <a:solidFill>
-              <a:srgbClr val="635BFF"/>
-            </a:solidFill>
-            <a:prstDash val="solid"/>
-          </a:ln>
-        </p:spPr>
-      </p:sp>
-      <p:sp>
-        <p:nvSpPr>
-          <p:cNvPr id="10" name="Text 8"/>
-          <p:cNvSpPr/>
-          <p:nvPr/>
-        </p:nvSpPr>
-        <p:spPr>
-          <a:xfrm>
-            <a:off x="6309360" y="2011680"/>
-            <a:ext cx="2560320" cy="914400"/>
-          </a:xfrm>
-          <a:prstGeom prst="rect">
-            <a:avLst/>
-          </a:prstGeom>
-          <a:noFill/>
-          <a:ln/>
-        </p:spPr>
-        <p:txBody>
-          <a:bodyPr wrap="square" lIns="0" tIns="0" rIns="0" bIns="0" rtlCol="0" anchor="ctr"/>
-          <a:lstStyle/>
-          <a:p>
-            <a:pPr algn="ctr" indent="0" marL="0">
-              <a:buNone/>
-            </a:pPr>
-            <a:r>
-              <a:rPr lang="en-US" sz="1800" b="1" dirty="0">
-                <a:solidFill>
-                  <a:srgbClr val="FFFFFF"/>
-                </a:solidFill>
-                <a:latin typeface="Verdana" pitchFamily="34" charset="0"/>
-                <a:ea typeface="Verdana" pitchFamily="34" charset="-122"/>
-                <a:cs typeface="Verdana" pitchFamily="34" charset="-120"/>
-              </a:rPr>
-              <a:t>Personal preferences</a:t>
-            </a:r>
-            <a:endParaRPr lang="en-US" sz="1800" dirty="0"/>
+                <a:latin typeface="Georgia" pitchFamily="34" charset="0"/>
+                <a:ea typeface="Georgia" pitchFamily="34" charset="-122"/>
+                <a:cs typeface="Georgia" pitchFamily="34" charset="-120"/>
+              </a:rPr>
+              <a:t>You'll type it all again.</a:t>
+            </a:r>
+            <a:endParaRPr lang="en-US" sz="4400" dirty="0"/>
           </a:p>
         </p:txBody>
       </p:sp>
@@ -6809,14 +7342,41 @@
       </p:sp>
       <p:sp>
         <p:nvSpPr>
-          <p:cNvPr id="3" name="Text 1"/>
-          <p:cNvSpPr/>
-          <p:nvPr/>
-        </p:nvSpPr>
-        <p:spPr>
-          <a:xfrm>
-            <a:off x="914400" y="914400"/>
-            <a:ext cx="7315200" cy="3291840"/>
+          <p:cNvPr id="3" name="Shape 1"/>
+          <p:cNvSpPr/>
+          <p:nvPr/>
+        </p:nvSpPr>
+        <p:spPr>
+          <a:xfrm>
+            <a:off x="274320" y="2011680"/>
+            <a:ext cx="2560320" cy="914400"/>
+          </a:xfrm>
+          <a:prstGeom prst="roundRect">
+            <a:avLst>
+              <a:gd name="adj" fmla="val 10000"/>
+            </a:avLst>
+          </a:prstGeom>
+          <a:solidFill>
+            <a:srgbClr val="0A2540"/>
+          </a:solidFill>
+          <a:ln w="25400">
+            <a:solidFill>
+              <a:srgbClr val="635BFF"/>
+            </a:solidFill>
+            <a:prstDash val="solid"/>
+          </a:ln>
+        </p:spPr>
+      </p:sp>
+      <p:sp>
+        <p:nvSpPr>
+          <p:cNvPr id="4" name="Text 2"/>
+          <p:cNvSpPr/>
+          <p:nvPr/>
+        </p:nvSpPr>
+        <p:spPr>
+          <a:xfrm>
+            <a:off x="274320" y="2011680"/>
+            <a:ext cx="2560320" cy="914400"/>
           </a:xfrm>
           <a:prstGeom prst="rect">
             <a:avLst/>
@@ -6832,51 +7392,227 @@
               <a:buNone/>
             </a:pPr>
             <a:r>
-              <a:rPr lang="en-US" sz="2800" b="1" dirty="0">
+              <a:rPr lang="en-US" sz="1800" b="1" dirty="0">
+                <a:solidFill>
+                  <a:srgbClr val="FFFFFF"/>
+                </a:solidFill>
+                <a:latin typeface="Verdana" pitchFamily="34" charset="0"/>
+                <a:ea typeface="Verdana" pitchFamily="34" charset="-122"/>
+                <a:cs typeface="Verdana" pitchFamily="34" charset="-120"/>
+              </a:rPr>
+              <a:t>Settings</a:t>
+            </a:r>
+            <a:endParaRPr lang="en-US" sz="1800" dirty="0"/>
+          </a:p>
+        </p:txBody>
+      </p:sp>
+      <p:sp>
+        <p:nvSpPr>
+          <p:cNvPr id="5" name="Text 3"/>
+          <p:cNvSpPr/>
+          <p:nvPr/>
+        </p:nvSpPr>
+        <p:spPr>
+          <a:xfrm>
+            <a:off x="2834640" y="2011680"/>
+            <a:ext cx="457200" cy="914400"/>
+          </a:xfrm>
+          <a:prstGeom prst="rect">
+            <a:avLst/>
+          </a:prstGeom>
+          <a:noFill/>
+          <a:ln/>
+        </p:spPr>
+        <p:txBody>
+          <a:bodyPr wrap="square" lIns="0" tIns="0" rIns="0" bIns="0" rtlCol="0" anchor="ctr"/>
+          <a:lstStyle/>
+          <a:p>
+            <a:pPr algn="ctr" indent="0" marL="0">
+              <a:buNone/>
+            </a:pPr>
+            <a:r>
+              <a:rPr lang="en-US" sz="2800" dirty="0">
                 <a:solidFill>
                   <a:srgbClr val="635BFF"/>
                 </a:solidFill>
-                <a:latin typeface="Georgia" pitchFamily="34" charset="0"/>
-                <a:ea typeface="Georgia" pitchFamily="34" charset="-122"/>
-                <a:cs typeface="Georgia" pitchFamily="34" charset="-120"/>
-              </a:rPr>
-              <a:t>Write your personal preferences:</a:t>
+                <a:latin typeface="Verdana" pitchFamily="34" charset="0"/>
+                <a:ea typeface="Verdana" pitchFamily="34" charset="-122"/>
+                <a:cs typeface="Verdana" pitchFamily="34" charset="-120"/>
+              </a:rPr>
+              <a:t>→</a:t>
             </a:r>
             <a:endParaRPr lang="en-US" sz="2800" dirty="0"/>
           </a:p>
+        </p:txBody>
+      </p:sp>
+      <p:sp>
+        <p:nvSpPr>
+          <p:cNvPr id="6" name="Shape 4"/>
+          <p:cNvSpPr/>
+          <p:nvPr/>
+        </p:nvSpPr>
+        <p:spPr>
+          <a:xfrm>
+            <a:off x="3291840" y="2011680"/>
+            <a:ext cx="2560320" cy="914400"/>
+          </a:xfrm>
+          <a:prstGeom prst="roundRect">
+            <a:avLst>
+              <a:gd name="adj" fmla="val 10000"/>
+            </a:avLst>
+          </a:prstGeom>
+          <a:solidFill>
+            <a:srgbClr val="0A2540"/>
+          </a:solidFill>
+          <a:ln w="25400">
+            <a:solidFill>
+              <a:srgbClr val="635BFF"/>
+            </a:solidFill>
+            <a:prstDash val="solid"/>
+          </a:ln>
+        </p:spPr>
+      </p:sp>
+      <p:sp>
+        <p:nvSpPr>
+          <p:cNvPr id="7" name="Text 5"/>
+          <p:cNvSpPr/>
+          <p:nvPr/>
+        </p:nvSpPr>
+        <p:spPr>
+          <a:xfrm>
+            <a:off x="3291840" y="2011680"/>
+            <a:ext cx="2560320" cy="914400"/>
+          </a:xfrm>
+          <a:prstGeom prst="rect">
+            <a:avLst/>
+          </a:prstGeom>
+          <a:noFill/>
+          <a:ln/>
+        </p:spPr>
+        <p:txBody>
+          <a:bodyPr wrap="square" lIns="0" tIns="0" rIns="0" bIns="0" rtlCol="0" anchor="ctr"/>
+          <a:lstStyle/>
           <a:p>
             <a:pPr algn="ctr" indent="0" marL="0">
               <a:buNone/>
             </a:pPr>
             <a:r>
-              <a:rPr lang="en-US" sz="2800" b="1" dirty="0">
+              <a:rPr lang="en-US" sz="1800" b="1" dirty="0">
+                <a:solidFill>
+                  <a:srgbClr val="FFFFFF"/>
+                </a:solidFill>
+                <a:latin typeface="Verdana" pitchFamily="34" charset="0"/>
+                <a:ea typeface="Verdana" pitchFamily="34" charset="-122"/>
+                <a:cs typeface="Verdana" pitchFamily="34" charset="-120"/>
+              </a:rPr>
+              <a:t>General</a:t>
+            </a:r>
+            <a:endParaRPr lang="en-US" sz="1800" dirty="0"/>
+          </a:p>
+        </p:txBody>
+      </p:sp>
+      <p:sp>
+        <p:nvSpPr>
+          <p:cNvPr id="8" name="Text 6"/>
+          <p:cNvSpPr/>
+          <p:nvPr/>
+        </p:nvSpPr>
+        <p:spPr>
+          <a:xfrm>
+            <a:off x="5852160" y="2011680"/>
+            <a:ext cx="457200" cy="914400"/>
+          </a:xfrm>
+          <a:prstGeom prst="rect">
+            <a:avLst/>
+          </a:prstGeom>
+          <a:noFill/>
+          <a:ln/>
+        </p:spPr>
+        <p:txBody>
+          <a:bodyPr wrap="square" lIns="0" tIns="0" rIns="0" bIns="0" rtlCol="0" anchor="ctr"/>
+          <a:lstStyle/>
+          <a:p>
+            <a:pPr algn="ctr" indent="0" marL="0">
+              <a:buNone/>
+            </a:pPr>
+            <a:r>
+              <a:rPr lang="en-US" sz="2800" dirty="0">
                 <a:solidFill>
                   <a:srgbClr val="635BFF"/>
                 </a:solidFill>
-                <a:latin typeface="Georgia" pitchFamily="34" charset="0"/>
-                <a:ea typeface="Georgia" pitchFamily="34" charset="-122"/>
-                <a:cs typeface="Georgia" pitchFamily="34" charset="-120"/>
-              </a:rPr>
-              <a:t>"I work at [company]. My role is [role].</a:t>
+                <a:latin typeface="Verdana" pitchFamily="34" charset="0"/>
+                <a:ea typeface="Verdana" pitchFamily="34" charset="-122"/>
+                <a:cs typeface="Verdana" pitchFamily="34" charset="-120"/>
+              </a:rPr>
+              <a:t>→</a:t>
             </a:r>
             <a:endParaRPr lang="en-US" sz="2800" dirty="0"/>
           </a:p>
+        </p:txBody>
+      </p:sp>
+      <p:sp>
+        <p:nvSpPr>
+          <p:cNvPr id="9" name="Shape 7"/>
+          <p:cNvSpPr/>
+          <p:nvPr/>
+        </p:nvSpPr>
+        <p:spPr>
+          <a:xfrm>
+            <a:off x="6309360" y="2011680"/>
+            <a:ext cx="2560320" cy="914400"/>
+          </a:xfrm>
+          <a:prstGeom prst="roundRect">
+            <a:avLst>
+              <a:gd name="adj" fmla="val 10000"/>
+            </a:avLst>
+          </a:prstGeom>
+          <a:solidFill>
+            <a:srgbClr val="0A2540"/>
+          </a:solidFill>
+          <a:ln w="25400">
+            <a:solidFill>
+              <a:srgbClr val="635BFF"/>
+            </a:solidFill>
+            <a:prstDash val="solid"/>
+          </a:ln>
+        </p:spPr>
+      </p:sp>
+      <p:sp>
+        <p:nvSpPr>
+          <p:cNvPr id="10" name="Text 8"/>
+          <p:cNvSpPr/>
+          <p:nvPr/>
+        </p:nvSpPr>
+        <p:spPr>
+          <a:xfrm>
+            <a:off x="6309360" y="2011680"/>
+            <a:ext cx="2560320" cy="914400"/>
+          </a:xfrm>
+          <a:prstGeom prst="rect">
+            <a:avLst/>
+          </a:prstGeom>
+          <a:noFill/>
+          <a:ln/>
+        </p:spPr>
+        <p:txBody>
+          <a:bodyPr wrap="square" lIns="0" tIns="0" rIns="0" bIns="0" rtlCol="0" anchor="ctr"/>
+          <a:lstStyle/>
           <a:p>
             <a:pPr algn="ctr" indent="0" marL="0">
               <a:buNone/>
             </a:pPr>
             <a:r>
-              <a:rPr lang="en-US" sz="2800" b="1" dirty="0">
-                <a:solidFill>
-                  <a:srgbClr val="635BFF"/>
-                </a:solidFill>
-                <a:latin typeface="Georgia" pitchFamily="34" charset="0"/>
-                <a:ea typeface="Georgia" pitchFamily="34" charset="-122"/>
-                <a:cs typeface="Georgia" pitchFamily="34" charset="-120"/>
-              </a:rPr>
-              <a:t>Be radically honest. Challenge my assumptions."</a:t>
-            </a:r>
-            <a:endParaRPr lang="en-US" sz="2800" dirty="0"/>
+              <a:rPr lang="en-US" sz="1800" b="1" dirty="0">
+                <a:solidFill>
+                  <a:srgbClr val="FFFFFF"/>
+                </a:solidFill>
+                <a:latin typeface="Verdana" pitchFamily="34" charset="0"/>
+                <a:ea typeface="Verdana" pitchFamily="34" charset="-122"/>
+                <a:cs typeface="Verdana" pitchFamily="34" charset="-120"/>
+              </a:rPr>
+              <a:t>Personal preferences</a:t>
+            </a:r>
+            <a:endParaRPr lang="en-US" sz="1800" dirty="0"/>
           </a:p>
         </p:txBody>
       </p:sp>
@@ -6936,41 +7672,14 @@
       </p:sp>
       <p:sp>
         <p:nvSpPr>
-          <p:cNvPr id="3" name="Shape 1"/>
-          <p:cNvSpPr/>
-          <p:nvPr/>
-        </p:nvSpPr>
-        <p:spPr>
-          <a:xfrm>
-            <a:off x="1097280" y="457200"/>
-            <a:ext cx="2926080" cy="4114800"/>
-          </a:xfrm>
-          <a:prstGeom prst="rect">
-            <a:avLst/>
-          </a:prstGeom>
-          <a:solidFill>
-            <a:srgbClr val="F8F8F8"/>
-          </a:solidFill>
-          <a:ln/>
-          <a:effectLst>
-            <a:outerShdw sx="100000" sy="100000" kx="0" ky="0" algn="bl" rotWithShape="0" blurRad="127000" dist="50800" dir="16200000">
-              <a:srgbClr val="000000">
-                <a:alpha val="30000"/>
-              </a:srgbClr>
-            </a:outerShdw>
-          </a:effectLst>
-        </p:spPr>
-      </p:sp>
-      <p:sp>
-        <p:nvSpPr>
-          <p:cNvPr id="4" name="Text 2"/>
-          <p:cNvSpPr/>
-          <p:nvPr/>
-        </p:nvSpPr>
-        <p:spPr>
-          <a:xfrm>
-            <a:off x="1371600" y="731520"/>
-            <a:ext cx="2377440" cy="3474720"/>
+          <p:cNvPr id="3" name="Text 1"/>
+          <p:cNvSpPr/>
+          <p:nvPr/>
+        </p:nvSpPr>
+        <p:spPr>
+          <a:xfrm>
+            <a:off x="914400" y="914400"/>
+            <a:ext cx="7315200" cy="3291840"/>
           </a:xfrm>
           <a:prstGeom prst="rect">
             <a:avLst/>
@@ -6979,163 +7688,61 @@
           <a:ln/>
         </p:spPr>
         <p:txBody>
-          <a:bodyPr wrap="square" lIns="0" tIns="0" rIns="0" bIns="0" rtlCol="0" anchor="t"/>
-          <a:lstStyle/>
-          <a:p>
-            <a:pPr indent="0" marL="0">
-              <a:buNone/>
-            </a:pPr>
-            <a:r>
-              <a:rPr lang="en-US" sz="1600" dirty="0">
-                <a:solidFill>
-                  <a:srgbClr val="1A1F36"/>
-                </a:solidFill>
-                <a:latin typeface="Verdana" pitchFamily="34" charset="0"/>
-                <a:ea typeface="Verdana" pitchFamily="34" charset="-122"/>
-                <a:cs typeface="Verdana" pitchFamily="34" charset="-120"/>
-              </a:rPr>
-              <a:t>Rules</a:t>
-            </a:r>
-            <a:endParaRPr lang="en-US" sz="1600" dirty="0"/>
-          </a:p>
-          <a:p>
-            <a:pPr indent="0" marL="0">
-              <a:buNone/>
-            </a:pPr>
-            <a:endParaRPr lang="en-US" sz="1600" dirty="0"/>
-          </a:p>
-          <a:p>
-            <a:pPr indent="0" marL="0">
-              <a:buNone/>
-            </a:pPr>
-            <a:r>
-              <a:rPr lang="en-US" sz="1600" dirty="0">
-                <a:solidFill>
-                  <a:srgbClr val="1A1F36"/>
-                </a:solidFill>
-                <a:latin typeface="Verdana" pitchFamily="34" charset="0"/>
-                <a:ea typeface="Verdana" pitchFamily="34" charset="-122"/>
-                <a:cs typeface="Verdana" pitchFamily="34" charset="-120"/>
-              </a:rPr>
-              <a:t>• Billboard design</a:t>
-            </a:r>
-            <a:endParaRPr lang="en-US" sz="1600" dirty="0"/>
-          </a:p>
-          <a:p>
-            <a:pPr indent="0" marL="0">
-              <a:buNone/>
-            </a:pPr>
-            <a:r>
-              <a:rPr lang="en-US" sz="1600" dirty="0">
-                <a:solidFill>
-                  <a:srgbClr val="1A1F36"/>
-                </a:solidFill>
-                <a:latin typeface="Verdana" pitchFamily="34" charset="0"/>
-                <a:ea typeface="Verdana" pitchFamily="34" charset="-122"/>
-                <a:cs typeface="Verdana" pitchFamily="34" charset="-120"/>
-              </a:rPr>
-              <a:t>• British English</a:t>
-            </a:r>
-            <a:endParaRPr lang="en-US" sz="1600" dirty="0"/>
-          </a:p>
-          <a:p>
-            <a:pPr indent="0" marL="0">
-              <a:buNone/>
-            </a:pPr>
-            <a:r>
-              <a:rPr lang="en-US" sz="1600" dirty="0">
-                <a:solidFill>
-                  <a:srgbClr val="1A1F36"/>
-                </a:solidFill>
-                <a:latin typeface="Verdana" pitchFamily="34" charset="0"/>
-                <a:ea typeface="Verdana" pitchFamily="34" charset="-122"/>
-                <a:cs typeface="Verdana" pitchFamily="34" charset="-120"/>
-              </a:rPr>
-              <a:t>• Be concise</a:t>
-            </a:r>
-            <a:endParaRPr lang="en-US" sz="1600" dirty="0"/>
-          </a:p>
-          <a:p>
-            <a:pPr indent="0" marL="0">
-              <a:buNone/>
-            </a:pPr>
-            <a:r>
-              <a:rPr lang="en-US" sz="1600" dirty="0">
-                <a:solidFill>
-                  <a:srgbClr val="1A1F36"/>
-                </a:solidFill>
-                <a:latin typeface="Verdana" pitchFamily="34" charset="0"/>
-                <a:ea typeface="Verdana" pitchFamily="34" charset="-122"/>
-                <a:cs typeface="Verdana" pitchFamily="34" charset="-120"/>
-              </a:rPr>
-              <a:t>• No jargon</a:t>
-            </a:r>
-            <a:endParaRPr lang="en-US" sz="1600" dirty="0"/>
-          </a:p>
-        </p:txBody>
-      </p:sp>
-      <p:sp>
-        <p:nvSpPr>
-          <p:cNvPr id="5" name="Text 3"/>
-          <p:cNvSpPr/>
-          <p:nvPr/>
-        </p:nvSpPr>
-        <p:spPr>
-          <a:xfrm>
-            <a:off x="4754880" y="731520"/>
-            <a:ext cx="3840480" cy="1828800"/>
-          </a:xfrm>
-          <a:prstGeom prst="rect">
-            <a:avLst/>
-          </a:prstGeom>
-          <a:noFill/>
-          <a:ln/>
-        </p:spPr>
-        <p:txBody>
           <a:bodyPr wrap="square" lIns="0" tIns="0" rIns="0" bIns="0" rtlCol="0" anchor="ctr"/>
           <a:lstStyle/>
           <a:p>
-            <a:pPr indent="0" marL="0">
-              <a:buNone/>
-            </a:pPr>
-            <a:r>
-              <a:rPr lang="en-US" sz="4800" b="1" dirty="0">
-                <a:solidFill>
-                  <a:srgbClr val="FFFFFF"/>
+            <a:pPr algn="ctr" indent="0" marL="0">
+              <a:buNone/>
+            </a:pPr>
+            <a:r>
+              <a:rPr lang="en-US" sz="2800" b="1" dirty="0">
+                <a:solidFill>
+                  <a:srgbClr val="635BFF"/>
                 </a:solidFill>
                 <a:latin typeface="Georgia" pitchFamily="34" charset="0"/>
                 <a:ea typeface="Georgia" pitchFamily="34" charset="-122"/>
                 <a:cs typeface="Georgia" pitchFamily="34" charset="-120"/>
               </a:rPr>
-              <a:t>Her entire memory.</a:t>
-            </a:r>
-            <a:endParaRPr lang="en-US" sz="4800" dirty="0"/>
-          </a:p>
-        </p:txBody>
-      </p:sp>
-      <p:pic>
-        <p:nvPicPr>
-          <p:cNvPr id="6" name="Image 0" descr="/Users/michaelengland/Developer/michaelengland/ai-best-practices/decks/ai-best-practices/assets/blue-tang-transparent.png">    </p:cNvPr>
-          <p:cNvPicPr>
-            <a:picLocks noChangeAspect="1"/>
-          </p:cNvPicPr>
-          <p:nvPr/>
-        </p:nvPicPr>
-        <p:blipFill>
-          <a:blip r:embed="rId1"/>
-          <a:srcRect l="0" r="0" t="0" b="0"/>
-          <a:stretch/>
-        </p:blipFill>
-        <p:spPr>
-          <a:xfrm>
-            <a:off x="6583680" y="2743200"/>
-            <a:ext cx="2011680" cy="2011680"/>
-          </a:xfrm>
-          <a:prstGeom prst="rect">
-            <a:avLst/>
-          </a:prstGeom>
-        </p:spPr>
-      </p:pic>
+              <a:t>Write your personal preferences:</a:t>
+            </a:r>
+            <a:endParaRPr lang="en-US" sz="2800" dirty="0"/>
+          </a:p>
+          <a:p>
+            <a:pPr algn="ctr" indent="0" marL="0">
+              <a:buNone/>
+            </a:pPr>
+            <a:r>
+              <a:rPr lang="en-US" sz="2800" b="1" dirty="0">
+                <a:solidFill>
+                  <a:srgbClr val="635BFF"/>
+                </a:solidFill>
+                <a:latin typeface="Georgia" pitchFamily="34" charset="0"/>
+                <a:ea typeface="Georgia" pitchFamily="34" charset="-122"/>
+                <a:cs typeface="Georgia" pitchFamily="34" charset="-120"/>
+              </a:rPr>
+              <a:t>"I work at [company]. My role is [role].</a:t>
+            </a:r>
+            <a:endParaRPr lang="en-US" sz="2800" dirty="0"/>
+          </a:p>
+          <a:p>
+            <a:pPr algn="ctr" indent="0" marL="0">
+              <a:buNone/>
+            </a:pPr>
+            <a:r>
+              <a:rPr lang="en-US" sz="2800" b="1" dirty="0">
+                <a:solidFill>
+                  <a:srgbClr val="635BFF"/>
+                </a:solidFill>
+                <a:latin typeface="Georgia" pitchFamily="34" charset="0"/>
+                <a:ea typeface="Georgia" pitchFamily="34" charset="-122"/>
+                <a:cs typeface="Georgia" pitchFamily="34" charset="-120"/>
+              </a:rPr>
+              <a:t>Be radically honest. Challenge my assumptions."</a:t>
+            </a:r>
+            <a:endParaRPr lang="en-US" sz="2800" dirty="0"/>
+          </a:p>
+        </p:txBody>
+      </p:sp>
     </p:spTree>
   </p:cSld>
   <p:clrMapOvr>
@@ -7192,14 +7799,41 @@
       </p:sp>
       <p:sp>
         <p:nvSpPr>
-          <p:cNvPr id="3" name="Text 1"/>
-          <p:cNvSpPr/>
-          <p:nvPr/>
-        </p:nvSpPr>
-        <p:spPr>
-          <a:xfrm>
-            <a:off x="914400" y="1097280"/>
-            <a:ext cx="7315200" cy="2560320"/>
+          <p:cNvPr id="3" name="Shape 1"/>
+          <p:cNvSpPr/>
+          <p:nvPr/>
+        </p:nvSpPr>
+        <p:spPr>
+          <a:xfrm>
+            <a:off x="1097280" y="457200"/>
+            <a:ext cx="2926080" cy="4114800"/>
+          </a:xfrm>
+          <a:prstGeom prst="rect">
+            <a:avLst/>
+          </a:prstGeom>
+          <a:solidFill>
+            <a:srgbClr val="F8F8F8"/>
+          </a:solidFill>
+          <a:ln/>
+          <a:effectLst>
+            <a:outerShdw sx="100000" sy="100000" kx="0" ky="0" algn="bl" rotWithShape="0" blurRad="127000" dist="50800" dir="16200000">
+              <a:srgbClr val="000000">
+                <a:alpha val="30000"/>
+              </a:srgbClr>
+            </a:outerShdw>
+          </a:effectLst>
+        </p:spPr>
+      </p:sp>
+      <p:sp>
+        <p:nvSpPr>
+          <p:cNvPr id="4" name="Text 2"/>
+          <p:cNvSpPr/>
+          <p:nvPr/>
+        </p:nvSpPr>
+        <p:spPr>
+          <a:xfrm>
+            <a:off x="1371600" y="731520"/>
+            <a:ext cx="2377440" cy="3474720"/>
           </a:xfrm>
           <a:prstGeom prst="rect">
             <a:avLst/>
@@ -7208,14 +7842,127 @@
           <a:ln/>
         </p:spPr>
         <p:txBody>
+          <a:bodyPr wrap="square" lIns="0" tIns="0" rIns="0" bIns="0" rtlCol="0" anchor="t"/>
+          <a:lstStyle/>
+          <a:p>
+            <a:pPr indent="0" marL="0">
+              <a:buNone/>
+            </a:pPr>
+            <a:r>
+              <a:rPr lang="en-US" sz="1600" dirty="0">
+                <a:solidFill>
+                  <a:srgbClr val="1A1F36"/>
+                </a:solidFill>
+                <a:latin typeface="Verdana" pitchFamily="34" charset="0"/>
+                <a:ea typeface="Verdana" pitchFamily="34" charset="-122"/>
+                <a:cs typeface="Verdana" pitchFamily="34" charset="-120"/>
+              </a:rPr>
+              <a:t>Rules</a:t>
+            </a:r>
+            <a:endParaRPr lang="en-US" sz="1600" dirty="0"/>
+          </a:p>
+          <a:p>
+            <a:pPr indent="0" marL="0">
+              <a:buNone/>
+            </a:pPr>
+            <a:endParaRPr lang="en-US" sz="1600" dirty="0"/>
+          </a:p>
+          <a:p>
+            <a:pPr indent="0" marL="0">
+              <a:buNone/>
+            </a:pPr>
+            <a:r>
+              <a:rPr lang="en-US" sz="1600" dirty="0">
+                <a:solidFill>
+                  <a:srgbClr val="1A1F36"/>
+                </a:solidFill>
+                <a:latin typeface="Verdana" pitchFamily="34" charset="0"/>
+                <a:ea typeface="Verdana" pitchFamily="34" charset="-122"/>
+                <a:cs typeface="Verdana" pitchFamily="34" charset="-120"/>
+              </a:rPr>
+              <a:t>• Billboard design</a:t>
+            </a:r>
+            <a:endParaRPr lang="en-US" sz="1600" dirty="0"/>
+          </a:p>
+          <a:p>
+            <a:pPr indent="0" marL="0">
+              <a:buNone/>
+            </a:pPr>
+            <a:r>
+              <a:rPr lang="en-US" sz="1600" dirty="0">
+                <a:solidFill>
+                  <a:srgbClr val="1A1F36"/>
+                </a:solidFill>
+                <a:latin typeface="Verdana" pitchFamily="34" charset="0"/>
+                <a:ea typeface="Verdana" pitchFamily="34" charset="-122"/>
+                <a:cs typeface="Verdana" pitchFamily="34" charset="-120"/>
+              </a:rPr>
+              <a:t>• British English</a:t>
+            </a:r>
+            <a:endParaRPr lang="en-US" sz="1600" dirty="0"/>
+          </a:p>
+          <a:p>
+            <a:pPr indent="0" marL="0">
+              <a:buNone/>
+            </a:pPr>
+            <a:r>
+              <a:rPr lang="en-US" sz="1600" dirty="0">
+                <a:solidFill>
+                  <a:srgbClr val="1A1F36"/>
+                </a:solidFill>
+                <a:latin typeface="Verdana" pitchFamily="34" charset="0"/>
+                <a:ea typeface="Verdana" pitchFamily="34" charset="-122"/>
+                <a:cs typeface="Verdana" pitchFamily="34" charset="-120"/>
+              </a:rPr>
+              <a:t>• Be concise</a:t>
+            </a:r>
+            <a:endParaRPr lang="en-US" sz="1600" dirty="0"/>
+          </a:p>
+          <a:p>
+            <a:pPr indent="0" marL="0">
+              <a:buNone/>
+            </a:pPr>
+            <a:r>
+              <a:rPr lang="en-US" sz="1600" dirty="0">
+                <a:solidFill>
+                  <a:srgbClr val="1A1F36"/>
+                </a:solidFill>
+                <a:latin typeface="Verdana" pitchFamily="34" charset="0"/>
+                <a:ea typeface="Verdana" pitchFamily="34" charset="-122"/>
+                <a:cs typeface="Verdana" pitchFamily="34" charset="-120"/>
+              </a:rPr>
+              <a:t>• No jargon</a:t>
+            </a:r>
+            <a:endParaRPr lang="en-US" sz="1600" dirty="0"/>
+          </a:p>
+        </p:txBody>
+      </p:sp>
+      <p:sp>
+        <p:nvSpPr>
+          <p:cNvPr id="5" name="Text 3"/>
+          <p:cNvSpPr/>
+          <p:nvPr/>
+        </p:nvSpPr>
+        <p:spPr>
+          <a:xfrm>
+            <a:off x="4754880" y="731520"/>
+            <a:ext cx="3840480" cy="1828800"/>
+          </a:xfrm>
+          <a:prstGeom prst="rect">
+            <a:avLst/>
+          </a:prstGeom>
+          <a:noFill/>
+          <a:ln/>
+        </p:spPr>
+        <p:txBody>
           <a:bodyPr wrap="square" lIns="0" tIns="0" rIns="0" bIns="0" rtlCol="0" anchor="ctr"/>
           <a:lstStyle/>
           <a:p>
-            <a:pPr algn="ctr" indent="0" marL="0">
-              <a:buNone/>
-            </a:pPr>
-            <a:r>
-              <a:rPr lang="en-US" sz="3600" b="1" dirty="0">
+            <a:pPr indent="0" marL="0">
+              <a:buNone/>
+            </a:pPr>
+            <a:r>
+              <a:rPr lang="en-US" sz="4800" b="1" dirty="0">
                 <a:solidFill>
                   <a:srgbClr val="FFFFFF"/>
                 </a:solidFill>
@@ -7223,63 +7970,35 @@
                 <a:ea typeface="Georgia" pitchFamily="34" charset="-122"/>
                 <a:cs typeface="Georgia" pitchFamily="34" charset="-120"/>
               </a:rPr>
-              <a:t>Skills live in the drawer.</a:t>
-            </a:r>
-            <a:endParaRPr lang="en-US" sz="3600" dirty="0"/>
-          </a:p>
-          <a:p>
-            <a:pPr algn="ctr" indent="0" marL="0">
-              <a:buNone/>
-            </a:pPr>
-            <a:r>
-              <a:rPr lang="en-US" sz="3600" b="1" dirty="0">
-                <a:solidFill>
-                  <a:srgbClr val="FFFFFF"/>
-                </a:solidFill>
-                <a:latin typeface="Georgia" pitchFamily="34" charset="0"/>
-                <a:ea typeface="Georgia" pitchFamily="34" charset="-122"/>
-                <a:cs typeface="Georgia" pitchFamily="34" charset="-120"/>
-              </a:rPr>
-              <a:t>Pulled onto the page</a:t>
-            </a:r>
-            <a:endParaRPr lang="en-US" sz="3600" dirty="0"/>
-          </a:p>
-          <a:p>
-            <a:pPr algn="ctr" indent="0" marL="0">
-              <a:buNone/>
-            </a:pPr>
-            <a:r>
-              <a:rPr lang="en-US" sz="3600" b="1" dirty="0">
-                <a:solidFill>
-                  <a:srgbClr val="FFFFFF"/>
-                </a:solidFill>
-                <a:latin typeface="Georgia" pitchFamily="34" charset="0"/>
-                <a:ea typeface="Georgia" pitchFamily="34" charset="-122"/>
-                <a:cs typeface="Georgia" pitchFamily="34" charset="-120"/>
-              </a:rPr>
-              <a:t>when needed.</a:t>
-            </a:r>
-            <a:endParaRPr lang="en-US" sz="3600" dirty="0"/>
-          </a:p>
-          <a:p>
-            <a:pPr algn="ctr" indent="0" marL="0">
-              <a:buNone/>
-            </a:pPr>
-            <a:r>
-              <a:rPr lang="en-US" sz="3600" b="1" dirty="0">
-                <a:solidFill>
-                  <a:srgbClr val="FFFFFF"/>
-                </a:solidFill>
-                <a:latin typeface="Georgia" pitchFamily="34" charset="0"/>
-                <a:ea typeface="Georgia" pitchFamily="34" charset="-122"/>
-                <a:cs typeface="Georgia" pitchFamily="34" charset="-120"/>
-              </a:rPr>
-              <a:t>Gone when done.</a:t>
-            </a:r>
-            <a:endParaRPr lang="en-US" sz="3600" dirty="0"/>
-          </a:p>
-        </p:txBody>
-      </p:sp>
+              <a:t>Her entire memory.</a:t>
+            </a:r>
+            <a:endParaRPr lang="en-US" sz="4800" dirty="0"/>
+          </a:p>
+        </p:txBody>
+      </p:sp>
+      <p:pic>
+        <p:nvPicPr>
+          <p:cNvPr id="6" name="Image 0" descr="/Users/michaelengland/Developer/michaelengland/ai-best-practices/decks/ai-best-practices/assets/blue-tang-transparent.png">    </p:cNvPr>
+          <p:cNvPicPr>
+            <a:picLocks noChangeAspect="1"/>
+          </p:cNvPicPr>
+          <p:nvPr/>
+        </p:nvPicPr>
+        <p:blipFill>
+          <a:blip r:embed="rId1"/>
+          <a:srcRect l="0" r="0" t="0" b="0"/>
+          <a:stretch/>
+        </p:blipFill>
+        <p:spPr>
+          <a:xfrm>
+            <a:off x="6583680" y="2743200"/>
+            <a:ext cx="2011680" cy="2011680"/>
+          </a:xfrm>
+          <a:prstGeom prst="rect">
+            <a:avLst/>
+          </a:prstGeom>
+        </p:spPr>
+      </p:pic>
     </p:spTree>
   </p:cSld>
   <p:clrMapOvr>
@@ -7342,8 +8061,8 @@
         </p:nvSpPr>
         <p:spPr>
           <a:xfrm>
-            <a:off x="914400" y="914400"/>
-            <a:ext cx="7315200" cy="3291840"/>
+            <a:off x="914400" y="1097280"/>
+            <a:ext cx="7315200" cy="2560320"/>
           </a:xfrm>
           <a:prstGeom prst="rect">
             <a:avLst/>
@@ -7359,17 +8078,17 @@
               <a:buNone/>
             </a:pPr>
             <a:r>
-              <a:rPr lang="en-US" sz="2800" b="1" dirty="0">
-                <a:solidFill>
-                  <a:srgbClr val="635BFF"/>
+              <a:rPr lang="en-US" sz="3600" b="1" dirty="0">
+                <a:solidFill>
+                  <a:srgbClr val="FFFFFF"/>
                 </a:solidFill>
                 <a:latin typeface="Georgia" pitchFamily="34" charset="0"/>
                 <a:ea typeface="Georgia" pitchFamily="34" charset="-122"/>
                 <a:cs typeface="Georgia" pitchFamily="34" charset="-120"/>
               </a:rPr>
-              <a:t>Enable the Presentation skill</a:t>
-            </a:r>
-            <a:endParaRPr lang="en-US" sz="2800" dirty="0"/>
+              <a:t>Skills live in the drawer.</a:t>
+            </a:r>
+            <a:endParaRPr lang="en-US" sz="3600" dirty="0"/>
           </a:p>
           <a:p>
             <a:pPr algn="ctr" indent="0" marL="0">
@@ -7378,15 +8097,15 @@
             <a:r>
               <a:rPr lang="en-US" sz="3600" b="1" dirty="0">
                 <a:solidFill>
-                  <a:srgbClr val="635BFF"/>
+                  <a:srgbClr val="FFFFFF"/>
                 </a:solidFill>
                 <a:latin typeface="Georgia" pitchFamily="34" charset="0"/>
                 <a:ea typeface="Georgia" pitchFamily="34" charset="-122"/>
                 <a:cs typeface="Georgia" pitchFamily="34" charset="-120"/>
               </a:rPr>
-              <a:t>Then type: "Make me a presentation</a:t>
-            </a:r>
-            <a:endParaRPr lang="en-US" sz="2800" dirty="0"/>
+              <a:t>Pulled onto the page</a:t>
+            </a:r>
+            <a:endParaRPr lang="en-US" sz="3600" dirty="0"/>
           </a:p>
           <a:p>
             <a:pPr algn="ctr" indent="0" marL="0">
@@ -7395,32 +8114,32 @@
             <a:r>
               <a:rPr lang="en-US" sz="3600" b="1" dirty="0">
                 <a:solidFill>
-                  <a:srgbClr val="635BFF"/>
+                  <a:srgbClr val="FFFFFF"/>
                 </a:solidFill>
                 <a:latin typeface="Georgia" pitchFamily="34" charset="0"/>
                 <a:ea typeface="Georgia" pitchFamily="34" charset="-122"/>
                 <a:cs typeface="Georgia" pitchFamily="34" charset="-120"/>
               </a:rPr>
-              <a:t>about making a cup of tea"</a:t>
-            </a:r>
-            <a:endParaRPr lang="en-US" sz="2800" dirty="0"/>
+              <a:t>when needed.</a:t>
+            </a:r>
+            <a:endParaRPr lang="en-US" sz="3600" dirty="0"/>
           </a:p>
           <a:p>
             <a:pPr algn="ctr" indent="0" marL="0">
               <a:buNone/>
             </a:pPr>
             <a:r>
-              <a:rPr lang="en-US" sz="2200" i="1" dirty="0">
-                <a:solidFill>
-                  <a:srgbClr val="8B95A5"/>
-                </a:solidFill>
-                <a:latin typeface="Verdana" pitchFamily="34" charset="0"/>
-                <a:ea typeface="Verdana" pitchFamily="34" charset="-122"/>
-                <a:cs typeface="Verdana" pitchFamily="34" charset="-120"/>
-              </a:rPr>
-              <a:t>One sentence. It already knows the rest.</a:t>
-            </a:r>
-            <a:endParaRPr lang="en-US" sz="2800" dirty="0"/>
+              <a:rPr lang="en-US" sz="3600" b="1" dirty="0">
+                <a:solidFill>
+                  <a:srgbClr val="FFFFFF"/>
+                </a:solidFill>
+                <a:latin typeface="Georgia" pitchFamily="34" charset="0"/>
+                <a:ea typeface="Georgia" pitchFamily="34" charset="-122"/>
+                <a:cs typeface="Georgia" pitchFamily="34" charset="-120"/>
+              </a:rPr>
+              <a:t>Gone when done.</a:t>
+            </a:r>
+            <a:endParaRPr lang="en-US" sz="3600" dirty="0"/>
           </a:p>
         </p:txBody>
       </p:sp>
@@ -7486,8 +8205,8 @@
         </p:nvSpPr>
         <p:spPr>
           <a:xfrm>
-            <a:off x="914400" y="1097280"/>
-            <a:ext cx="7315200" cy="2560320"/>
+            <a:off x="914400" y="914400"/>
+            <a:ext cx="7315200" cy="3291840"/>
           </a:xfrm>
           <a:prstGeom prst="rect">
             <a:avLst/>
@@ -7503,7 +8222,7 @@
               <a:buNone/>
             </a:pPr>
             <a:r>
-              <a:rPr lang="en-US" sz="4400" b="1" dirty="0">
+              <a:rPr lang="en-US" sz="2800" b="1" dirty="0">
                 <a:solidFill>
                   <a:srgbClr val="635BFF"/>
                 </a:solidFill>
@@ -7511,16 +8230,16 @@
                 <a:ea typeface="Georgia" pitchFamily="34" charset="-122"/>
                 <a:cs typeface="Georgia" pitchFamily="34" charset="-120"/>
               </a:rPr>
-              <a:t>The page stays clean.</a:t>
-            </a:r>
-            <a:endParaRPr lang="en-US" sz="4400" dirty="0"/>
+              <a:t>Enable the Presentation skill</a:t>
+            </a:r>
+            <a:endParaRPr lang="en-US" sz="2800" dirty="0"/>
           </a:p>
           <a:p>
             <a:pPr algn="ctr" indent="0" marL="0">
               <a:buNone/>
             </a:pPr>
             <a:r>
-              <a:rPr lang="en-US" sz="4400" b="1" dirty="0">
+              <a:rPr lang="en-US" sz="3600" b="1" dirty="0">
                 <a:solidFill>
                   <a:srgbClr val="635BFF"/>
                 </a:solidFill>
@@ -7528,9 +8247,43 @@
                 <a:ea typeface="Georgia" pitchFamily="34" charset="-122"/>
                 <a:cs typeface="Georgia" pitchFamily="34" charset="-120"/>
               </a:rPr>
-              <a:t>The drawer holds the rest.</a:t>
-            </a:r>
-            <a:endParaRPr lang="en-US" sz="4400" dirty="0"/>
+              <a:t>Then type: "Make me a presentation</a:t>
+            </a:r>
+            <a:endParaRPr lang="en-US" sz="2800" dirty="0"/>
+          </a:p>
+          <a:p>
+            <a:pPr algn="ctr" indent="0" marL="0">
+              <a:buNone/>
+            </a:pPr>
+            <a:r>
+              <a:rPr lang="en-US" sz="3600" b="1" dirty="0">
+                <a:solidFill>
+                  <a:srgbClr val="635BFF"/>
+                </a:solidFill>
+                <a:latin typeface="Georgia" pitchFamily="34" charset="0"/>
+                <a:ea typeface="Georgia" pitchFamily="34" charset="-122"/>
+                <a:cs typeface="Georgia" pitchFamily="34" charset="-120"/>
+              </a:rPr>
+              <a:t>about making a cup of tea"</a:t>
+            </a:r>
+            <a:endParaRPr lang="en-US" sz="2800" dirty="0"/>
+          </a:p>
+          <a:p>
+            <a:pPr algn="ctr" indent="0" marL="0">
+              <a:buNone/>
+            </a:pPr>
+            <a:r>
+              <a:rPr lang="en-US" sz="2200" i="1" dirty="0">
+                <a:solidFill>
+                  <a:srgbClr val="8B95A5"/>
+                </a:solidFill>
+                <a:latin typeface="Verdana" pitchFamily="34" charset="0"/>
+                <a:ea typeface="Verdana" pitchFamily="34" charset="-122"/>
+                <a:cs typeface="Verdana" pitchFamily="34" charset="-120"/>
+              </a:rPr>
+              <a:t>One sentence. It already knows the rest.</a:t>
+            </a:r>
+            <a:endParaRPr lang="en-US" sz="2800" dirty="0"/>
           </a:p>
         </p:txBody>
       </p:sp>
@@ -7545,6 +8298,116 @@
 <file path=ppt/slides/slide28.xml><?xml version="1.0" encoding="utf-8"?>
 <p:sld xmlns:a="http://schemas.openxmlformats.org/drawingml/2006/main" xmlns:r="http://schemas.openxmlformats.org/officeDocument/2006/relationships" xmlns:p="http://schemas.openxmlformats.org/presentationml/2006/main">
   <p:cSld name="Slide 28">
+    <p:bg>
+      <p:bgPr>
+        <a:solidFill>
+          <a:srgbClr val="0A2540"/>
+        </a:solidFill>
+      </p:bgPr>
+    </p:bg>
+    <p:spTree>
+      <p:nvGrpSpPr>
+        <p:cNvPr id="1" name=""/>
+        <p:cNvGrpSpPr/>
+        <p:nvPr/>
+      </p:nvGrpSpPr>
+      <p:grpSpPr>
+        <a:xfrm>
+          <a:off x="0" y="0"/>
+          <a:ext cx="0" cy="0"/>
+          <a:chOff x="0" y="0"/>
+          <a:chExt cx="0" cy="0"/>
+        </a:xfrm>
+      </p:grpSpPr>
+      <p:sp>
+        <p:nvSpPr>
+          <p:cNvPr id="2" name="Shape 0"/>
+          <p:cNvSpPr/>
+          <p:nvPr/>
+        </p:nvSpPr>
+        <p:spPr>
+          <a:xfrm>
+            <a:off x="4572000" y="2286000"/>
+            <a:ext cx="7315200" cy="5486400"/>
+          </a:xfrm>
+          <a:prstGeom prst="ellipse">
+            <a:avLst/>
+          </a:prstGeom>
+          <a:solidFill>
+            <a:srgbClr val="635BFF">
+              <a:alpha val="4000"/>
+            </a:srgbClr>
+          </a:solidFill>
+          <a:ln/>
+        </p:spPr>
+      </p:sp>
+      <p:sp>
+        <p:nvSpPr>
+          <p:cNvPr id="3" name="Text 1"/>
+          <p:cNvSpPr/>
+          <p:nvPr/>
+        </p:nvSpPr>
+        <p:spPr>
+          <a:xfrm>
+            <a:off x="914400" y="1097280"/>
+            <a:ext cx="7315200" cy="2560320"/>
+          </a:xfrm>
+          <a:prstGeom prst="rect">
+            <a:avLst/>
+          </a:prstGeom>
+          <a:noFill/>
+          <a:ln/>
+        </p:spPr>
+        <p:txBody>
+          <a:bodyPr wrap="square" lIns="0" tIns="0" rIns="0" bIns="0" rtlCol="0" anchor="ctr"/>
+          <a:lstStyle/>
+          <a:p>
+            <a:pPr algn="ctr" indent="0" marL="0">
+              <a:buNone/>
+            </a:pPr>
+            <a:r>
+              <a:rPr lang="en-US" sz="4400" b="1" dirty="0">
+                <a:solidFill>
+                  <a:srgbClr val="635BFF"/>
+                </a:solidFill>
+                <a:latin typeface="Georgia" pitchFamily="34" charset="0"/>
+                <a:ea typeface="Georgia" pitchFamily="34" charset="-122"/>
+                <a:cs typeface="Georgia" pitchFamily="34" charset="-120"/>
+              </a:rPr>
+              <a:t>The page stays clean.</a:t>
+            </a:r>
+            <a:endParaRPr lang="en-US" sz="4400" dirty="0"/>
+          </a:p>
+          <a:p>
+            <a:pPr algn="ctr" indent="0" marL="0">
+              <a:buNone/>
+            </a:pPr>
+            <a:r>
+              <a:rPr lang="en-US" sz="4400" b="1" dirty="0">
+                <a:solidFill>
+                  <a:srgbClr val="635BFF"/>
+                </a:solidFill>
+                <a:latin typeface="Georgia" pitchFamily="34" charset="0"/>
+                <a:ea typeface="Georgia" pitchFamily="34" charset="-122"/>
+                <a:cs typeface="Georgia" pitchFamily="34" charset="-120"/>
+              </a:rPr>
+              <a:t>The drawer holds the rest.</a:t>
+            </a:r>
+            <a:endParaRPr lang="en-US" sz="4400" dirty="0"/>
+          </a:p>
+        </p:txBody>
+      </p:sp>
+    </p:spTree>
+  </p:cSld>
+  <p:clrMapOvr>
+    <a:masterClrMapping/>
+  </p:clrMapOvr>
+</p:sld>
+</file>
+
+<file path=ppt/slides/slide29.xml><?xml version="1.0" encoding="utf-8"?>
+<p:sld xmlns:a="http://schemas.openxmlformats.org/drawingml/2006/main" xmlns:r="http://schemas.openxmlformats.org/officeDocument/2006/relationships" xmlns:p="http://schemas.openxmlformats.org/presentationml/2006/main">
+  <p:cSld name="Slide 29">
     <p:bg>
       <p:bgPr>
         <a:solidFill>
@@ -7956,99 +8819,6 @@
               <a:t>Strategist</a:t>
             </a:r>
             <a:endParaRPr lang="en-US" sz="1400" dirty="0"/>
-          </a:p>
-        </p:txBody>
-      </p:sp>
-    </p:spTree>
-  </p:cSld>
-  <p:clrMapOvr>
-    <a:masterClrMapping/>
-  </p:clrMapOvr>
-</p:sld>
-</file>
-
-<file path=ppt/slides/slide29.xml><?xml version="1.0" encoding="utf-8"?>
-<p:sld xmlns:a="http://schemas.openxmlformats.org/drawingml/2006/main" xmlns:r="http://schemas.openxmlformats.org/officeDocument/2006/relationships" xmlns:p="http://schemas.openxmlformats.org/presentationml/2006/main">
-  <p:cSld name="Slide 29">
-    <p:bg>
-      <p:bgPr>
-        <a:solidFill>
-          <a:srgbClr val="0A2540"/>
-        </a:solidFill>
-      </p:bgPr>
-    </p:bg>
-    <p:spTree>
-      <p:nvGrpSpPr>
-        <p:cNvPr id="1" name=""/>
-        <p:cNvGrpSpPr/>
-        <p:nvPr/>
-      </p:nvGrpSpPr>
-      <p:grpSpPr>
-        <a:xfrm>
-          <a:off x="0" y="0"/>
-          <a:ext cx="0" cy="0"/>
-          <a:chOff x="0" y="0"/>
-          <a:chExt cx="0" cy="0"/>
-        </a:xfrm>
-      </p:grpSpPr>
-      <p:sp>
-        <p:nvSpPr>
-          <p:cNvPr id="2" name="Shape 0"/>
-          <p:cNvSpPr/>
-          <p:nvPr/>
-        </p:nvSpPr>
-        <p:spPr>
-          <a:xfrm>
-            <a:off x="4572000" y="2286000"/>
-            <a:ext cx="7315200" cy="5486400"/>
-          </a:xfrm>
-          <a:prstGeom prst="ellipse">
-            <a:avLst/>
-          </a:prstGeom>
-          <a:solidFill>
-            <a:srgbClr val="635BFF">
-              <a:alpha val="4000"/>
-            </a:srgbClr>
-          </a:solidFill>
-          <a:ln/>
-        </p:spPr>
-      </p:sp>
-      <p:sp>
-        <p:nvSpPr>
-          <p:cNvPr id="3" name="Text 1"/>
-          <p:cNvSpPr/>
-          <p:nvPr/>
-        </p:nvSpPr>
-        <p:spPr>
-          <a:xfrm>
-            <a:off x="914400" y="1097280"/>
-            <a:ext cx="7315200" cy="2560320"/>
-          </a:xfrm>
-          <a:prstGeom prst="rect">
-            <a:avLst/>
-          </a:prstGeom>
-          <a:noFill/>
-          <a:ln/>
-        </p:spPr>
-        <p:txBody>
-          <a:bodyPr wrap="square" lIns="0" tIns="0" rIns="0" bIns="0" rtlCol="0" anchor="ctr"/>
-          <a:lstStyle/>
-          <a:p>
-            <a:pPr algn="ctr" indent="0" marL="0">
-              <a:buNone/>
-            </a:pPr>
-            <a:r>
-              <a:rPr lang="en-US" sz="5400" b="1" dirty="0">
-                <a:solidFill>
-                  <a:srgbClr val="FFFFFF"/>
-                </a:solidFill>
-                <a:latin typeface="Georgia" pitchFamily="34" charset="0"/>
-                <a:ea typeface="Georgia" pitchFamily="34" charset="-122"/>
-                <a:cs typeface="Georgia" pitchFamily="34" charset="-120"/>
-              </a:rPr>
-              <a:t>You're now a Strategist</a:t>
-            </a:r>
-            <a:endParaRPr lang="en-US" sz="5400" dirty="0"/>
           </a:p>
         </p:txBody>
       </p:sp>
@@ -8173,6 +8943,817 @@
 <file path=ppt/slides/slide30.xml><?xml version="1.0" encoding="utf-8"?>
 <p:sld xmlns:a="http://schemas.openxmlformats.org/drawingml/2006/main" xmlns:r="http://schemas.openxmlformats.org/officeDocument/2006/relationships" xmlns:p="http://schemas.openxmlformats.org/presentationml/2006/main">
   <p:cSld name="Slide 30">
+    <p:bg>
+      <p:bgPr>
+        <a:solidFill>
+          <a:srgbClr val="0A2540"/>
+        </a:solidFill>
+      </p:bgPr>
+    </p:bg>
+    <p:spTree>
+      <p:nvGrpSpPr>
+        <p:cNvPr id="1" name=""/>
+        <p:cNvGrpSpPr/>
+        <p:nvPr/>
+      </p:nvGrpSpPr>
+      <p:grpSpPr>
+        <a:xfrm>
+          <a:off x="0" y="0"/>
+          <a:ext cx="0" cy="0"/>
+          <a:chOff x="0" y="0"/>
+          <a:chExt cx="0" cy="0"/>
+        </a:xfrm>
+      </p:grpSpPr>
+      <p:sp>
+        <p:nvSpPr>
+          <p:cNvPr id="2" name="Shape 0"/>
+          <p:cNvSpPr/>
+          <p:nvPr/>
+        </p:nvSpPr>
+        <p:spPr>
+          <a:xfrm>
+            <a:off x="4572000" y="2286000"/>
+            <a:ext cx="7315200" cy="5486400"/>
+          </a:xfrm>
+          <a:prstGeom prst="ellipse">
+            <a:avLst/>
+          </a:prstGeom>
+          <a:solidFill>
+            <a:srgbClr val="635BFF">
+              <a:alpha val="4000"/>
+            </a:srgbClr>
+          </a:solidFill>
+          <a:ln/>
+        </p:spPr>
+      </p:sp>
+      <p:sp>
+        <p:nvSpPr>
+          <p:cNvPr id="3" name="Shape 1"/>
+          <p:cNvSpPr/>
+          <p:nvPr/>
+        </p:nvSpPr>
+        <p:spPr>
+          <a:xfrm>
+            <a:off x="192024" y="2011680"/>
+            <a:ext cx="1188720" cy="640080"/>
+          </a:xfrm>
+          <a:prstGeom prst="roundRect">
+            <a:avLst>
+              <a:gd name="adj" fmla="val 11429"/>
+            </a:avLst>
+          </a:prstGeom>
+          <a:solidFill>
+            <a:srgbClr val="0A2540">
+              <a:alpha val="50000"/>
+            </a:srgbClr>
+          </a:solidFill>
+          <a:ln w="19050">
+            <a:solidFill>
+              <a:srgbClr val="8B95A5"/>
+            </a:solidFill>
+            <a:prstDash val="solid"/>
+          </a:ln>
+        </p:spPr>
+      </p:sp>
+      <p:sp>
+        <p:nvSpPr>
+          <p:cNvPr id="4" name="Text 2"/>
+          <p:cNvSpPr/>
+          <p:nvPr/>
+        </p:nvSpPr>
+        <p:spPr>
+          <a:xfrm>
+            <a:off x="192024" y="2011680"/>
+            <a:ext cx="1188720" cy="640080"/>
+          </a:xfrm>
+          <a:prstGeom prst="rect">
+            <a:avLst/>
+          </a:prstGeom>
+          <a:noFill/>
+          <a:ln/>
+        </p:spPr>
+        <p:txBody>
+          <a:bodyPr wrap="square" lIns="0" tIns="0" rIns="0" bIns="0" rtlCol="0" anchor="ctr">
+            <a:normAutofit/>
+          </a:bodyPr>
+          <a:lstStyle/>
+          <a:p>
+            <a:pPr algn="ctr" indent="0" marL="0">
+              <a:buNone/>
+            </a:pPr>
+            <a:r>
+              <a:rPr lang="en-US" sz="1100" b="1" dirty="0">
+                <a:solidFill>
+                  <a:srgbClr val="8B95A5"/>
+                </a:solidFill>
+                <a:latin typeface="Verdana" pitchFamily="34" charset="0"/>
+                <a:ea typeface="Verdana" pitchFamily="34" charset="-122"/>
+                <a:cs typeface="Verdana" pitchFamily="34" charset="-120"/>
+              </a:rPr>
+              <a:t>Skeptic</a:t>
+            </a:r>
+            <a:endParaRPr lang="en-US" sz="1100" dirty="0"/>
+          </a:p>
+        </p:txBody>
+      </p:sp>
+      <p:sp>
+        <p:nvSpPr>
+          <p:cNvPr id="5" name="Text 3"/>
+          <p:cNvSpPr/>
+          <p:nvPr/>
+        </p:nvSpPr>
+        <p:spPr>
+          <a:xfrm>
+            <a:off x="1380744" y="2011680"/>
+            <a:ext cx="73152" cy="640080"/>
+          </a:xfrm>
+          <a:prstGeom prst="rect">
+            <a:avLst/>
+          </a:prstGeom>
+          <a:noFill/>
+          <a:ln/>
+        </p:spPr>
+        <p:txBody>
+          <a:bodyPr wrap="square" lIns="0" tIns="0" rIns="0" bIns="0" rtlCol="0" anchor="ctr"/>
+          <a:lstStyle/>
+          <a:p>
+            <a:pPr algn="ctr" indent="0" marL="0">
+              <a:buNone/>
+            </a:pPr>
+            <a:r>
+              <a:rPr lang="en-US" sz="1100" dirty="0">
+                <a:solidFill>
+                  <a:srgbClr val="8B95A5"/>
+                </a:solidFill>
+                <a:latin typeface="Verdana" pitchFamily="34" charset="0"/>
+                <a:ea typeface="Verdana" pitchFamily="34" charset="-122"/>
+                <a:cs typeface="Verdana" pitchFamily="34" charset="-120"/>
+              </a:rPr>
+              <a:t>→</a:t>
+            </a:r>
+            <a:endParaRPr lang="en-US" sz="1100" dirty="0"/>
+          </a:p>
+        </p:txBody>
+      </p:sp>
+      <p:sp>
+        <p:nvSpPr>
+          <p:cNvPr id="6" name="Shape 4"/>
+          <p:cNvSpPr/>
+          <p:nvPr/>
+        </p:nvSpPr>
+        <p:spPr>
+          <a:xfrm>
+            <a:off x="1453896" y="2011680"/>
+            <a:ext cx="1188720" cy="640080"/>
+          </a:xfrm>
+          <a:prstGeom prst="roundRect">
+            <a:avLst>
+              <a:gd name="adj" fmla="val 11429"/>
+            </a:avLst>
+          </a:prstGeom>
+          <a:solidFill>
+            <a:srgbClr val="635BFF"/>
+          </a:solidFill>
+          <a:ln w="19050">
+            <a:solidFill>
+              <a:srgbClr val="635BFF"/>
+            </a:solidFill>
+            <a:prstDash val="solid"/>
+          </a:ln>
+        </p:spPr>
+      </p:sp>
+      <p:sp>
+        <p:nvSpPr>
+          <p:cNvPr id="7" name="Text 5"/>
+          <p:cNvSpPr/>
+          <p:nvPr/>
+        </p:nvSpPr>
+        <p:spPr>
+          <a:xfrm>
+            <a:off x="1453896" y="2011680"/>
+            <a:ext cx="1188720" cy="640080"/>
+          </a:xfrm>
+          <a:prstGeom prst="rect">
+            <a:avLst/>
+          </a:prstGeom>
+          <a:noFill/>
+          <a:ln/>
+        </p:spPr>
+        <p:txBody>
+          <a:bodyPr wrap="square" lIns="0" tIns="0" rIns="0" bIns="0" rtlCol="0" anchor="ctr">
+            <a:normAutofit/>
+          </a:bodyPr>
+          <a:lstStyle/>
+          <a:p>
+            <a:pPr algn="ctr" indent="0" marL="0">
+              <a:buNone/>
+            </a:pPr>
+            <a:r>
+              <a:rPr lang="en-US" sz="1100" b="1" dirty="0">
+                <a:solidFill>
+                  <a:srgbClr val="FFFFFF"/>
+                </a:solidFill>
+                <a:latin typeface="Verdana" pitchFamily="34" charset="0"/>
+                <a:ea typeface="Verdana" pitchFamily="34" charset="-122"/>
+                <a:cs typeface="Verdana" pitchFamily="34" charset="-120"/>
+              </a:rPr>
+              <a:t>Explorer</a:t>
+            </a:r>
+            <a:endParaRPr lang="en-US" sz="1100" dirty="0"/>
+          </a:p>
+        </p:txBody>
+      </p:sp>
+      <p:sp>
+        <p:nvSpPr>
+          <p:cNvPr id="8" name="Text 6"/>
+          <p:cNvSpPr/>
+          <p:nvPr/>
+        </p:nvSpPr>
+        <p:spPr>
+          <a:xfrm>
+            <a:off x="2642616" y="2011680"/>
+            <a:ext cx="73152" cy="640080"/>
+          </a:xfrm>
+          <a:prstGeom prst="rect">
+            <a:avLst/>
+          </a:prstGeom>
+          <a:noFill/>
+          <a:ln/>
+        </p:spPr>
+        <p:txBody>
+          <a:bodyPr wrap="square" lIns="0" tIns="0" rIns="0" bIns="0" rtlCol="0" anchor="ctr"/>
+          <a:lstStyle/>
+          <a:p>
+            <a:pPr algn="ctr" indent="0" marL="0">
+              <a:buNone/>
+            </a:pPr>
+            <a:r>
+              <a:rPr lang="en-US" sz="1100" dirty="0">
+                <a:solidFill>
+                  <a:srgbClr val="8B95A5"/>
+                </a:solidFill>
+                <a:latin typeface="Verdana" pitchFamily="34" charset="0"/>
+                <a:ea typeface="Verdana" pitchFamily="34" charset="-122"/>
+                <a:cs typeface="Verdana" pitchFamily="34" charset="-120"/>
+              </a:rPr>
+              <a:t>→</a:t>
+            </a:r>
+            <a:endParaRPr lang="en-US" sz="1100" dirty="0"/>
+          </a:p>
+        </p:txBody>
+      </p:sp>
+      <p:sp>
+        <p:nvSpPr>
+          <p:cNvPr id="9" name="Shape 7"/>
+          <p:cNvSpPr/>
+          <p:nvPr/>
+        </p:nvSpPr>
+        <p:spPr>
+          <a:xfrm>
+            <a:off x="2715768" y="2011680"/>
+            <a:ext cx="1188720" cy="640080"/>
+          </a:xfrm>
+          <a:prstGeom prst="roundRect">
+            <a:avLst>
+              <a:gd name="adj" fmla="val 11429"/>
+            </a:avLst>
+          </a:prstGeom>
+          <a:solidFill>
+            <a:srgbClr val="635BFF"/>
+          </a:solidFill>
+          <a:ln w="19050">
+            <a:solidFill>
+              <a:srgbClr val="635BFF"/>
+            </a:solidFill>
+            <a:prstDash val="solid"/>
+          </a:ln>
+        </p:spPr>
+      </p:sp>
+      <p:sp>
+        <p:nvSpPr>
+          <p:cNvPr id="10" name="Text 8"/>
+          <p:cNvSpPr/>
+          <p:nvPr/>
+        </p:nvSpPr>
+        <p:spPr>
+          <a:xfrm>
+            <a:off x="2715768" y="2011680"/>
+            <a:ext cx="1188720" cy="640080"/>
+          </a:xfrm>
+          <a:prstGeom prst="rect">
+            <a:avLst/>
+          </a:prstGeom>
+          <a:noFill/>
+          <a:ln/>
+        </p:spPr>
+        <p:txBody>
+          <a:bodyPr wrap="square" lIns="0" tIns="0" rIns="0" bIns="0" rtlCol="0" anchor="ctr">
+            <a:normAutofit/>
+          </a:bodyPr>
+          <a:lstStyle/>
+          <a:p>
+            <a:pPr algn="ctr" indent="0" marL="0">
+              <a:buNone/>
+            </a:pPr>
+            <a:r>
+              <a:rPr lang="en-US" sz="1100" b="1" dirty="0">
+                <a:solidFill>
+                  <a:srgbClr val="FFFFFF"/>
+                </a:solidFill>
+                <a:latin typeface="Verdana" pitchFamily="34" charset="0"/>
+                <a:ea typeface="Verdana" pitchFamily="34" charset="-122"/>
+                <a:cs typeface="Verdana" pitchFamily="34" charset="-120"/>
+              </a:rPr>
+              <a:t>Whisperer</a:t>
+            </a:r>
+            <a:endParaRPr lang="en-US" sz="1100" dirty="0"/>
+          </a:p>
+        </p:txBody>
+      </p:sp>
+      <p:sp>
+        <p:nvSpPr>
+          <p:cNvPr id="11" name="Text 9"/>
+          <p:cNvSpPr/>
+          <p:nvPr/>
+        </p:nvSpPr>
+        <p:spPr>
+          <a:xfrm>
+            <a:off x="3904488" y="2011680"/>
+            <a:ext cx="73152" cy="640080"/>
+          </a:xfrm>
+          <a:prstGeom prst="rect">
+            <a:avLst/>
+          </a:prstGeom>
+          <a:noFill/>
+          <a:ln/>
+        </p:spPr>
+        <p:txBody>
+          <a:bodyPr wrap="square" lIns="0" tIns="0" rIns="0" bIns="0" rtlCol="0" anchor="ctr"/>
+          <a:lstStyle/>
+          <a:p>
+            <a:pPr algn="ctr" indent="0" marL="0">
+              <a:buNone/>
+            </a:pPr>
+            <a:r>
+              <a:rPr lang="en-US" sz="1100" dirty="0">
+                <a:solidFill>
+                  <a:srgbClr val="8B95A5"/>
+                </a:solidFill>
+                <a:latin typeface="Verdana" pitchFamily="34" charset="0"/>
+                <a:ea typeface="Verdana" pitchFamily="34" charset="-122"/>
+                <a:cs typeface="Verdana" pitchFamily="34" charset="-120"/>
+              </a:rPr>
+              <a:t>→</a:t>
+            </a:r>
+            <a:endParaRPr lang="en-US" sz="1100" dirty="0"/>
+          </a:p>
+        </p:txBody>
+      </p:sp>
+      <p:sp>
+        <p:nvSpPr>
+          <p:cNvPr id="12" name="Shape 10"/>
+          <p:cNvSpPr/>
+          <p:nvPr/>
+        </p:nvSpPr>
+        <p:spPr>
+          <a:xfrm>
+            <a:off x="3977640" y="2011680"/>
+            <a:ext cx="1188720" cy="640080"/>
+          </a:xfrm>
+          <a:prstGeom prst="roundRect">
+            <a:avLst>
+              <a:gd name="adj" fmla="val 11429"/>
+            </a:avLst>
+          </a:prstGeom>
+          <a:solidFill>
+            <a:srgbClr val="635BFF"/>
+          </a:solidFill>
+          <a:ln w="19050">
+            <a:solidFill>
+              <a:srgbClr val="635BFF"/>
+            </a:solidFill>
+            <a:prstDash val="solid"/>
+          </a:ln>
+        </p:spPr>
+      </p:sp>
+      <p:sp>
+        <p:nvSpPr>
+          <p:cNvPr id="13" name="Text 11"/>
+          <p:cNvSpPr/>
+          <p:nvPr/>
+        </p:nvSpPr>
+        <p:spPr>
+          <a:xfrm>
+            <a:off x="3977640" y="2011680"/>
+            <a:ext cx="1188720" cy="640080"/>
+          </a:xfrm>
+          <a:prstGeom prst="rect">
+            <a:avLst/>
+          </a:prstGeom>
+          <a:noFill/>
+          <a:ln/>
+        </p:spPr>
+        <p:txBody>
+          <a:bodyPr wrap="square" lIns="0" tIns="0" rIns="0" bIns="0" rtlCol="0" anchor="ctr">
+            <a:normAutofit/>
+          </a:bodyPr>
+          <a:lstStyle/>
+          <a:p>
+            <a:pPr algn="ctr" indent="0" marL="0">
+              <a:buNone/>
+            </a:pPr>
+            <a:r>
+              <a:rPr lang="en-US" sz="1100" b="1" dirty="0">
+                <a:solidFill>
+                  <a:srgbClr val="FFFFFF"/>
+                </a:solidFill>
+                <a:latin typeface="Verdana" pitchFamily="34" charset="0"/>
+                <a:ea typeface="Verdana" pitchFamily="34" charset="-122"/>
+                <a:cs typeface="Verdana" pitchFamily="34" charset="-120"/>
+              </a:rPr>
+              <a:t>Strategist</a:t>
+            </a:r>
+            <a:endParaRPr lang="en-US" sz="1100" dirty="0"/>
+          </a:p>
+        </p:txBody>
+      </p:sp>
+      <p:sp>
+        <p:nvSpPr>
+          <p:cNvPr id="14" name="Text 12"/>
+          <p:cNvSpPr/>
+          <p:nvPr/>
+        </p:nvSpPr>
+        <p:spPr>
+          <a:xfrm>
+            <a:off x="5166360" y="2011680"/>
+            <a:ext cx="73152" cy="640080"/>
+          </a:xfrm>
+          <a:prstGeom prst="rect">
+            <a:avLst/>
+          </a:prstGeom>
+          <a:noFill/>
+          <a:ln/>
+        </p:spPr>
+        <p:txBody>
+          <a:bodyPr wrap="square" lIns="0" tIns="0" rIns="0" bIns="0" rtlCol="0" anchor="ctr"/>
+          <a:lstStyle/>
+          <a:p>
+            <a:pPr algn="ctr" indent="0" marL="0">
+              <a:buNone/>
+            </a:pPr>
+            <a:r>
+              <a:rPr lang="en-US" sz="1100" dirty="0">
+                <a:solidFill>
+                  <a:srgbClr val="8B95A5"/>
+                </a:solidFill>
+                <a:latin typeface="Verdana" pitchFamily="34" charset="0"/>
+                <a:ea typeface="Verdana" pitchFamily="34" charset="-122"/>
+                <a:cs typeface="Verdana" pitchFamily="34" charset="-120"/>
+              </a:rPr>
+              <a:t>→</a:t>
+            </a:r>
+            <a:endParaRPr lang="en-US" sz="1100" dirty="0"/>
+          </a:p>
+        </p:txBody>
+      </p:sp>
+      <p:sp>
+        <p:nvSpPr>
+          <p:cNvPr id="15" name="Shape 13"/>
+          <p:cNvSpPr/>
+          <p:nvPr/>
+        </p:nvSpPr>
+        <p:spPr>
+          <a:xfrm>
+            <a:off x="5239512" y="2011680"/>
+            <a:ext cx="1188720" cy="640080"/>
+          </a:xfrm>
+          <a:prstGeom prst="roundRect">
+            <a:avLst>
+              <a:gd name="adj" fmla="val 11429"/>
+            </a:avLst>
+          </a:prstGeom>
+          <a:solidFill>
+            <a:srgbClr val="0A2540">
+              <a:alpha val="50000"/>
+            </a:srgbClr>
+          </a:solidFill>
+          <a:ln w="19050">
+            <a:solidFill>
+              <a:srgbClr val="8B95A5"/>
+            </a:solidFill>
+            <a:prstDash val="solid"/>
+          </a:ln>
+        </p:spPr>
+      </p:sp>
+      <p:sp>
+        <p:nvSpPr>
+          <p:cNvPr id="16" name="Text 14"/>
+          <p:cNvSpPr/>
+          <p:nvPr/>
+        </p:nvSpPr>
+        <p:spPr>
+          <a:xfrm>
+            <a:off x="5239512" y="2011680"/>
+            <a:ext cx="1188720" cy="640080"/>
+          </a:xfrm>
+          <a:prstGeom prst="rect">
+            <a:avLst/>
+          </a:prstGeom>
+          <a:noFill/>
+          <a:ln/>
+        </p:spPr>
+        <p:txBody>
+          <a:bodyPr wrap="square" lIns="0" tIns="0" rIns="0" bIns="0" rtlCol="0" anchor="ctr">
+            <a:normAutofit/>
+          </a:bodyPr>
+          <a:lstStyle/>
+          <a:p>
+            <a:pPr algn="ctr" indent="0" marL="0">
+              <a:buNone/>
+            </a:pPr>
+            <a:r>
+              <a:rPr lang="en-US" sz="1100" b="1" dirty="0">
+                <a:solidFill>
+                  <a:srgbClr val="8B95A5"/>
+                </a:solidFill>
+                <a:latin typeface="Verdana" pitchFamily="34" charset="0"/>
+                <a:ea typeface="Verdana" pitchFamily="34" charset="-122"/>
+                <a:cs typeface="Verdana" pitchFamily="34" charset="-120"/>
+              </a:rPr>
+              <a:t>Operator</a:t>
+            </a:r>
+            <a:endParaRPr lang="en-US" sz="1100" dirty="0"/>
+          </a:p>
+        </p:txBody>
+      </p:sp>
+      <p:sp>
+        <p:nvSpPr>
+          <p:cNvPr id="17" name="Text 15"/>
+          <p:cNvSpPr/>
+          <p:nvPr/>
+        </p:nvSpPr>
+        <p:spPr>
+          <a:xfrm>
+            <a:off x="6428232" y="2011680"/>
+            <a:ext cx="73152" cy="640080"/>
+          </a:xfrm>
+          <a:prstGeom prst="rect">
+            <a:avLst/>
+          </a:prstGeom>
+          <a:noFill/>
+          <a:ln/>
+        </p:spPr>
+        <p:txBody>
+          <a:bodyPr wrap="square" lIns="0" tIns="0" rIns="0" bIns="0" rtlCol="0" anchor="ctr"/>
+          <a:lstStyle/>
+          <a:p>
+            <a:pPr algn="ctr" indent="0" marL="0">
+              <a:buNone/>
+            </a:pPr>
+            <a:r>
+              <a:rPr lang="en-US" sz="1100" dirty="0">
+                <a:solidFill>
+                  <a:srgbClr val="8B95A5"/>
+                </a:solidFill>
+                <a:latin typeface="Verdana" pitchFamily="34" charset="0"/>
+                <a:ea typeface="Verdana" pitchFamily="34" charset="-122"/>
+                <a:cs typeface="Verdana" pitchFamily="34" charset="-120"/>
+              </a:rPr>
+              <a:t>→</a:t>
+            </a:r>
+            <a:endParaRPr lang="en-US" sz="1100" dirty="0"/>
+          </a:p>
+        </p:txBody>
+      </p:sp>
+      <p:sp>
+        <p:nvSpPr>
+          <p:cNvPr id="18" name="Shape 16"/>
+          <p:cNvSpPr/>
+          <p:nvPr/>
+        </p:nvSpPr>
+        <p:spPr>
+          <a:xfrm>
+            <a:off x="6501384" y="2011680"/>
+            <a:ext cx="1188720" cy="640080"/>
+          </a:xfrm>
+          <a:prstGeom prst="roundRect">
+            <a:avLst>
+              <a:gd name="adj" fmla="val 11429"/>
+            </a:avLst>
+          </a:prstGeom>
+          <a:solidFill>
+            <a:srgbClr val="0A2540">
+              <a:alpha val="50000"/>
+            </a:srgbClr>
+          </a:solidFill>
+          <a:ln w="19050">
+            <a:solidFill>
+              <a:srgbClr val="8B95A5"/>
+            </a:solidFill>
+            <a:prstDash val="solid"/>
+          </a:ln>
+        </p:spPr>
+      </p:sp>
+      <p:sp>
+        <p:nvSpPr>
+          <p:cNvPr id="19" name="Text 17"/>
+          <p:cNvSpPr/>
+          <p:nvPr/>
+        </p:nvSpPr>
+        <p:spPr>
+          <a:xfrm>
+            <a:off x="6501384" y="2011680"/>
+            <a:ext cx="1188720" cy="640080"/>
+          </a:xfrm>
+          <a:prstGeom prst="rect">
+            <a:avLst/>
+          </a:prstGeom>
+          <a:noFill/>
+          <a:ln/>
+        </p:spPr>
+        <p:txBody>
+          <a:bodyPr wrap="square" lIns="0" tIns="0" rIns="0" bIns="0" rtlCol="0" anchor="ctr">
+            <a:normAutofit/>
+          </a:bodyPr>
+          <a:lstStyle/>
+          <a:p>
+            <a:pPr algn="ctr" indent="0" marL="0">
+              <a:buNone/>
+            </a:pPr>
+            <a:r>
+              <a:rPr lang="en-US" sz="1100" b="1" dirty="0">
+                <a:solidFill>
+                  <a:srgbClr val="8B95A5"/>
+                </a:solidFill>
+                <a:latin typeface="Verdana" pitchFamily="34" charset="0"/>
+                <a:ea typeface="Verdana" pitchFamily="34" charset="-122"/>
+                <a:cs typeface="Verdana" pitchFamily="34" charset="-120"/>
+              </a:rPr>
+              <a:t>Orchestrator</a:t>
+            </a:r>
+            <a:endParaRPr lang="en-US" sz="1100" dirty="0"/>
+          </a:p>
+        </p:txBody>
+      </p:sp>
+      <p:sp>
+        <p:nvSpPr>
+          <p:cNvPr id="20" name="Text 18"/>
+          <p:cNvSpPr/>
+          <p:nvPr/>
+        </p:nvSpPr>
+        <p:spPr>
+          <a:xfrm>
+            <a:off x="7690104" y="2011680"/>
+            <a:ext cx="73152" cy="640080"/>
+          </a:xfrm>
+          <a:prstGeom prst="rect">
+            <a:avLst/>
+          </a:prstGeom>
+          <a:noFill/>
+          <a:ln/>
+        </p:spPr>
+        <p:txBody>
+          <a:bodyPr wrap="square" lIns="0" tIns="0" rIns="0" bIns="0" rtlCol="0" anchor="ctr"/>
+          <a:lstStyle/>
+          <a:p>
+            <a:pPr algn="ctr" indent="0" marL="0">
+              <a:buNone/>
+            </a:pPr>
+            <a:r>
+              <a:rPr lang="en-US" sz="1100" dirty="0">
+                <a:solidFill>
+                  <a:srgbClr val="8B95A5"/>
+                </a:solidFill>
+                <a:latin typeface="Verdana" pitchFamily="34" charset="0"/>
+                <a:ea typeface="Verdana" pitchFamily="34" charset="-122"/>
+                <a:cs typeface="Verdana" pitchFamily="34" charset="-120"/>
+              </a:rPr>
+              <a:t>→</a:t>
+            </a:r>
+            <a:endParaRPr lang="en-US" sz="1100" dirty="0"/>
+          </a:p>
+        </p:txBody>
+      </p:sp>
+      <p:sp>
+        <p:nvSpPr>
+          <p:cNvPr id="21" name="Shape 19"/>
+          <p:cNvSpPr/>
+          <p:nvPr/>
+        </p:nvSpPr>
+        <p:spPr>
+          <a:xfrm>
+            <a:off x="7763256" y="2011680"/>
+            <a:ext cx="1188720" cy="640080"/>
+          </a:xfrm>
+          <a:prstGeom prst="roundRect">
+            <a:avLst>
+              <a:gd name="adj" fmla="val 11429"/>
+            </a:avLst>
+          </a:prstGeom>
+          <a:solidFill>
+            <a:srgbClr val="0A2540">
+              <a:alpha val="50000"/>
+            </a:srgbClr>
+          </a:solidFill>
+          <a:ln w="19050">
+            <a:solidFill>
+              <a:srgbClr val="8B95A5"/>
+            </a:solidFill>
+            <a:prstDash val="dash"/>
+          </a:ln>
+        </p:spPr>
+      </p:sp>
+      <p:sp>
+        <p:nvSpPr>
+          <p:cNvPr id="22" name="Text 20"/>
+          <p:cNvSpPr/>
+          <p:nvPr/>
+        </p:nvSpPr>
+        <p:spPr>
+          <a:xfrm>
+            <a:off x="7763256" y="2011680"/>
+            <a:ext cx="1188720" cy="640080"/>
+          </a:xfrm>
+          <a:prstGeom prst="rect">
+            <a:avLst/>
+          </a:prstGeom>
+          <a:noFill/>
+          <a:ln/>
+        </p:spPr>
+        <p:txBody>
+          <a:bodyPr wrap="square" lIns="0" tIns="0" rIns="0" bIns="0" rtlCol="0" anchor="ctr">
+            <a:normAutofit/>
+          </a:bodyPr>
+          <a:lstStyle/>
+          <a:p>
+            <a:pPr algn="ctr" indent="0" marL="0">
+              <a:buNone/>
+            </a:pPr>
+            <a:r>
+              <a:rPr lang="en-US" sz="1100" b="1" dirty="0">
+                <a:solidFill>
+                  <a:srgbClr val="8B95A5"/>
+                </a:solidFill>
+                <a:latin typeface="Verdana" pitchFamily="34" charset="0"/>
+                <a:ea typeface="Verdana" pitchFamily="34" charset="-122"/>
+                <a:cs typeface="Verdana" pitchFamily="34" charset="-120"/>
+              </a:rPr>
+              <a:t>Builder</a:t>
+            </a:r>
+            <a:endParaRPr lang="en-US" sz="1100" dirty="0"/>
+          </a:p>
+        </p:txBody>
+      </p:sp>
+      <p:sp>
+        <p:nvSpPr>
+          <p:cNvPr id="23" name="Text 21"/>
+          <p:cNvSpPr/>
+          <p:nvPr/>
+        </p:nvSpPr>
+        <p:spPr>
+          <a:xfrm>
+            <a:off x="914400" y="3108960"/>
+            <a:ext cx="7315200" cy="548640"/>
+          </a:xfrm>
+          <a:prstGeom prst="rect">
+            <a:avLst/>
+          </a:prstGeom>
+          <a:noFill/>
+          <a:ln/>
+        </p:spPr>
+        <p:txBody>
+          <a:bodyPr wrap="square" lIns="0" tIns="0" rIns="0" bIns="0" rtlCol="0" anchor="ctr"/>
+          <a:lstStyle/>
+          <a:p>
+            <a:pPr algn="ctr" indent="0" marL="0">
+              <a:buNone/>
+            </a:pPr>
+            <a:r>
+              <a:rPr lang="en-US" sz="2400" b="1" dirty="0">
+                <a:solidFill>
+                  <a:srgbClr val="635BFF"/>
+                </a:solidFill>
+                <a:latin typeface="Georgia" pitchFamily="34" charset="0"/>
+                <a:ea typeface="Georgia" pitchFamily="34" charset="-122"/>
+                <a:cs typeface="Georgia" pitchFamily="34" charset="-120"/>
+              </a:rPr>
+              <a:t>You’re now a Strategist</a:t>
+            </a:r>
+            <a:endParaRPr lang="en-US" sz="2400" dirty="0"/>
+          </a:p>
+        </p:txBody>
+      </p:sp>
+    </p:spTree>
+  </p:cSld>
+  <p:clrMapOvr>
+    <a:masterClrMapping/>
+  </p:clrMapOvr>
+</p:sld>
+</file>
+
+<file path=ppt/slides/slide31.xml><?xml version="1.0" encoding="utf-8"?>
+<p:sld xmlns:a="http://schemas.openxmlformats.org/drawingml/2006/main" xmlns:r="http://schemas.openxmlformats.org/officeDocument/2006/relationships" xmlns:p="http://schemas.openxmlformats.org/presentationml/2006/main">
+  <p:cSld name="Slide 31">
     <p:bg>
       <p:bgPr>
         <a:solidFill>

</xml_diff>